<commit_message>
Harden agent workflow and multi-format evaluation
</commit_message>
<xml_diff>
--- a/presentation/LedgerPilot_Assignment_Deck.pptx
+++ b/presentation/LedgerPilot_Assignment_Deck.pptx
@@ -2,24 +2,24 @@
 <file path=ppt/presentation.xml><?xml version="1.0" encoding="utf-8"?>
 <p:presentation xmlns:p="http://schemas.openxmlformats.org/presentationml/2006/main">
   <p:sldMasterIdLst>
-    <p:sldMasterId xmlns:r="http://schemas.openxmlformats.org/officeDocument/2006/relationships" id="2147483648" r:id="R67f39ec982be4f9c"/>
+    <p:sldMasterId xmlns:r="http://schemas.openxmlformats.org/officeDocument/2006/relationships" id="2147483648" r:id="Rf5773d6313f045fa"/>
   </p:sldMasterIdLst>
   <p:notesMasterIdLst>
-    <p:notesMasterId xmlns:r="http://schemas.openxmlformats.org/officeDocument/2006/relationships" r:id="R4fb8492d0c624fb8"/>
+    <p:notesMasterId xmlns:r="http://schemas.openxmlformats.org/officeDocument/2006/relationships" r:id="R8be14cdb30df4aae"/>
   </p:notesMasterIdLst>
   <p:sldIdLst>
-    <p:sldId xmlns:r="http://schemas.openxmlformats.org/officeDocument/2006/relationships" id="256" r:id="Ra6b2baa0d9594a02"/>
-    <p:sldId xmlns:r="http://schemas.openxmlformats.org/officeDocument/2006/relationships" id="257" r:id="R9d3282d11a714814"/>
-    <p:sldId xmlns:r="http://schemas.openxmlformats.org/officeDocument/2006/relationships" id="258" r:id="Ra8173b9cc79b4dd4"/>
-    <p:sldId xmlns:r="http://schemas.openxmlformats.org/officeDocument/2006/relationships" id="259" r:id="R7693ab6828344104"/>
-    <p:sldId xmlns:r="http://schemas.openxmlformats.org/officeDocument/2006/relationships" id="260" r:id="R650b3f4c492d4c8a"/>
-    <p:sldId xmlns:r="http://schemas.openxmlformats.org/officeDocument/2006/relationships" id="261" r:id="Rb41badeca7b74369"/>
-    <p:sldId xmlns:r="http://schemas.openxmlformats.org/officeDocument/2006/relationships" id="262" r:id="R220125226f7e41fa"/>
-    <p:sldId xmlns:r="http://schemas.openxmlformats.org/officeDocument/2006/relationships" id="263" r:id="R98168751934d4ed3"/>
-    <p:sldId xmlns:r="http://schemas.openxmlformats.org/officeDocument/2006/relationships" id="264" r:id="R444ac09a6fff4382"/>
-    <p:sldId xmlns:r="http://schemas.openxmlformats.org/officeDocument/2006/relationships" id="265" r:id="R4ed1e5eeda524e5c"/>
-    <p:sldId xmlns:r="http://schemas.openxmlformats.org/officeDocument/2006/relationships" id="266" r:id="R372341ce61154017"/>
-    <p:sldId xmlns:r="http://schemas.openxmlformats.org/officeDocument/2006/relationships" id="267" r:id="R0be82e22aa21441e"/>
+    <p:sldId xmlns:r="http://schemas.openxmlformats.org/officeDocument/2006/relationships" id="256" r:id="Rf9baf3b98d9d433e"/>
+    <p:sldId xmlns:r="http://schemas.openxmlformats.org/officeDocument/2006/relationships" id="257" r:id="Re430cc526797406f"/>
+    <p:sldId xmlns:r="http://schemas.openxmlformats.org/officeDocument/2006/relationships" id="258" r:id="Rbbce57e443724043"/>
+    <p:sldId xmlns:r="http://schemas.openxmlformats.org/officeDocument/2006/relationships" id="259" r:id="Ra92fae650c104963"/>
+    <p:sldId xmlns:r="http://schemas.openxmlformats.org/officeDocument/2006/relationships" id="260" r:id="Ree340e8c3b9b4c4f"/>
+    <p:sldId xmlns:r="http://schemas.openxmlformats.org/officeDocument/2006/relationships" id="261" r:id="Rd83d302ea59942db"/>
+    <p:sldId xmlns:r="http://schemas.openxmlformats.org/officeDocument/2006/relationships" id="262" r:id="R76ef13ae759e4f95"/>
+    <p:sldId xmlns:r="http://schemas.openxmlformats.org/officeDocument/2006/relationships" id="263" r:id="R0988c7ce6fa2454a"/>
+    <p:sldId xmlns:r="http://schemas.openxmlformats.org/officeDocument/2006/relationships" id="264" r:id="Rbc5db942f91e4db8"/>
+    <p:sldId xmlns:r="http://schemas.openxmlformats.org/officeDocument/2006/relationships" id="265" r:id="R5ab7c48f43a84b9b"/>
+    <p:sldId xmlns:r="http://schemas.openxmlformats.org/officeDocument/2006/relationships" id="266" r:id="R9ef02e9916004cb2"/>
+    <p:sldId xmlns:r="http://schemas.openxmlformats.org/officeDocument/2006/relationships" id="267" r:id="R6d409656237c4201"/>
   </p:sldIdLst>
   <p:sldSz cx="12192000" cy="6858000"/>
   <p:notesSz cx="6858000" cy="9144000"/>
@@ -543,7 +543,7 @@
           <a:lstStyle xmlns:a="http://schemas.openxmlformats.org/drawingml/2006/main"/>
           <a:p xmlns:a="http://schemas.openxmlformats.org/drawingml/2006/main">
             <a:r>
-              <a:t>Do not oversell the 100% figures; the STP rate is low by design because two cases must escalate.</a:t>
+              <a:t>The 100% figures are controlled-fixture results, not production estimates. Call out the zero false-auto-post rate and the need for a permissioned pilot.</a:t>
             </a:r>
           </a:p>
           <a:p xmlns:a="http://schemas.openxmlformats.org/drawingml/2006/main">
@@ -558,7 +558,7 @@
           </a:p>
           <a:p xmlns:a="http://schemas.openxmlformats.org/drawingml/2006/main">
             <a:r>
-              <a:t>- evaluation/results/latest.json — generated metrics.</a:t>
+              <a:t>- evaluation/results/latest.json — generated six-document metrics.</a:t>
             </a:r>
           </a:p>
           <a:p xmlns:a="http://schemas.openxmlformats.org/drawingml/2006/main">
@@ -1561,7 +1561,7 @@
   </p:cSld>
   <p:clrMap bg1="lt1" tx1="dk1" bg2="lt2" tx2="dk2" accent1="accent1" accent2="accent2" accent3="accent3" accent4="accent4" accent5="accent5" accent6="accent6" hlink="hlink" folHlink="folHlink"/>
   <p:sldLayoutIdLst>
-    <p:sldLayoutId xmlns:r="http://schemas.openxmlformats.org/officeDocument/2006/relationships" id="2147483649" r:id="Rcd8285576b9a4fe9"/>
+    <p:sldLayoutId xmlns:r="http://schemas.openxmlformats.org/officeDocument/2006/relationships" id="2147483649" r:id="R87f8d3d6ee504aea"/>
   </p:sldLayoutIdLst>
   <p:txStyles>
     <p:titleStyle>
@@ -2142,6 +2142,7 @@
           <a:lstStyle xmlns:a="http://schemas.openxmlformats.org/drawingml/2006/main"/>
           <a:p xmlns:a="http://schemas.openxmlformats.org/drawingml/2006/main">
             <a:pPr algn="l">
+              <a:buNone/>
               <a:defRPr sz="1125" b="1">
                 <a:solidFill>
                   <a:srgbClr val="5E6773"/>
@@ -2200,6 +2201,7 @@
           <a:lstStyle xmlns:a="http://schemas.openxmlformats.org/drawingml/2006/main"/>
           <a:p xmlns:a="http://schemas.openxmlformats.org/drawingml/2006/main">
             <a:pPr algn="l">
+              <a:buNone/>
               <a:defRPr sz="4050" b="1">
                 <a:solidFill>
                   <a:srgbClr val="000000"/>
@@ -2258,6 +2260,7 @@
           <a:lstStyle xmlns:a="http://schemas.openxmlformats.org/drawingml/2006/main"/>
           <a:p xmlns:a="http://schemas.openxmlformats.org/drawingml/2006/main">
             <a:pPr algn="l">
+              <a:buNone/>
               <a:defRPr sz="1725" b="0">
                 <a:solidFill>
                   <a:srgbClr val="5E6773"/>
@@ -2347,6 +2350,7 @@
           <a:lstStyle xmlns:a="http://schemas.openxmlformats.org/drawingml/2006/main"/>
           <a:p xmlns:a="http://schemas.openxmlformats.org/drawingml/2006/main">
             <a:pPr algn="l">
+              <a:buNone/>
               <a:defRPr sz="1275" b="0">
                 <a:solidFill>
                   <a:srgbClr val="5E6773"/>
@@ -2372,14 +2376,14 @@
       </p:sp>
       <p:pic>
         <p:nvPicPr>
-          <p:cNvPr id="13" name=""/>
+          <p:cNvPr id="15" name=""/>
           <p:cNvPicPr>
             <a:picLocks xmlns:a="http://schemas.openxmlformats.org/drawingml/2006/main" noChangeAspect="1"/>
           </p:cNvPicPr>
           <p:nvPr/>
         </p:nvPicPr>
         <p:blipFill>
-          <a:blip xmlns:r="http://schemas.openxmlformats.org/officeDocument/2006/relationships" xmlns:a="http://schemas.openxmlformats.org/drawingml/2006/main" r:embed="Rd521cfe57e8c40cf"/>
+          <a:blip xmlns:r="http://schemas.openxmlformats.org/officeDocument/2006/relationships" xmlns:a="http://schemas.openxmlformats.org/drawingml/2006/main" r:embed="R253d26adb28041d3"/>
           <a:srcRect xmlns:a="http://schemas.openxmlformats.org/drawingml/2006/main" l="0" t="9434" r="0" b="9434"/>
           <a:stretch xmlns:a="http://schemas.openxmlformats.org/drawingml/2006/main">
             <a:fillRect l="0" t="0" r="0" b="0"/>
@@ -2432,6 +2436,7 @@
           <a:lstStyle xmlns:a="http://schemas.openxmlformats.org/drawingml/2006/main"/>
           <a:p xmlns:a="http://schemas.openxmlformats.org/drawingml/2006/main">
             <a:pPr algn="r">
+              <a:buNone/>
               <a:defRPr sz="975" b="0">
                 <a:solidFill>
                   <a:srgbClr val="5E6773"/>
@@ -2519,6 +2524,7 @@
           <a:lstStyle xmlns:a="http://schemas.openxmlformats.org/drawingml/2006/main"/>
           <a:p xmlns:a="http://schemas.openxmlformats.org/drawingml/2006/main">
             <a:pPr algn="l">
+              <a:buNone/>
               <a:defRPr sz="1050" b="1">
                 <a:solidFill>
                   <a:srgbClr val="5E6773"/>
@@ -2577,6 +2583,7 @@
           <a:lstStyle xmlns:a="http://schemas.openxmlformats.org/drawingml/2006/main"/>
           <a:p xmlns:a="http://schemas.openxmlformats.org/drawingml/2006/main">
             <a:pPr algn="l">
+              <a:buNone/>
               <a:defRPr sz="2850" b="1">
                 <a:solidFill>
                   <a:srgbClr val="000000"/>
@@ -2666,6 +2673,7 @@
           <a:lstStyle xmlns:a="http://schemas.openxmlformats.org/drawingml/2006/main"/>
           <a:p xmlns:a="http://schemas.openxmlformats.org/drawingml/2006/main">
             <a:pPr algn="r">
+              <a:buNone/>
               <a:defRPr sz="975" b="0">
                 <a:solidFill>
                   <a:srgbClr val="5E6773"/>
@@ -2724,6 +2732,7 @@
           <a:lstStyle xmlns:a="http://schemas.openxmlformats.org/drawingml/2006/main"/>
           <a:p xmlns:a="http://schemas.openxmlformats.org/drawingml/2006/main">
             <a:pPr algn="l">
+              <a:buNone/>
               <a:defRPr sz="1575" b="0">
                 <a:solidFill>
                   <a:srgbClr val="5E6773"/>
@@ -2742,7 +2751,7 @@
                 <a:ea typeface="Arial"/>
                 <a:cs typeface="Arial"/>
               </a:rPr>
-              <a:t>Three synthetic cases isolate workflow correctness: clean match, 10% price variance, and missing PO.</a:t>
+              <a:t>Six synthetic cases span JSON, text-native PDF, and scan-like PNG: three clean and three controlled exceptions.</a:t>
             </a:r>
           </a:p>
         </p:txBody>
@@ -2813,6 +2822,7 @@
           <a:lstStyle xmlns:a="http://schemas.openxmlformats.org/drawingml/2006/main"/>
           <a:p xmlns:a="http://schemas.openxmlformats.org/drawingml/2006/main">
             <a:pPr algn="l">
+              <a:buNone/>
               <a:defRPr sz="3750" b="1">
                 <a:solidFill>
                   <a:srgbClr val="000000"/>
@@ -2871,6 +2881,7 @@
           <a:lstStyle xmlns:a="http://schemas.openxmlformats.org/drawingml/2006/main"/>
           <a:p xmlns:a="http://schemas.openxmlformats.org/drawingml/2006/main">
             <a:pPr algn="l">
+              <a:buNone/>
               <a:defRPr sz="1425" b="0">
                 <a:solidFill>
                   <a:srgbClr val="5E6773"/>
@@ -2894,6 +2905,7 @@
           </a:p>
           <a:p xmlns:a="http://schemas.openxmlformats.org/drawingml/2006/main">
             <a:pPr algn="l">
+              <a:buNone/>
               <a:defRPr sz="1425" b="0">
                 <a:solidFill>
                   <a:srgbClr val="5E6773"/>
@@ -2912,7 +2924,7 @@
                 <a:ea typeface="Arial"/>
                 <a:cs typeface="Arial"/>
               </a:rPr>
-              <a:t>15 / 15 labels</a:t>
+              <a:t>30 / 30 labels</a:t>
             </a:r>
           </a:p>
         </p:txBody>
@@ -2983,6 +2995,7 @@
           <a:lstStyle xmlns:a="http://schemas.openxmlformats.org/drawingml/2006/main"/>
           <a:p xmlns:a="http://schemas.openxmlformats.org/drawingml/2006/main">
             <a:pPr algn="l">
+              <a:buNone/>
               <a:defRPr sz="3750" b="1">
                 <a:solidFill>
                   <a:srgbClr val="000000"/>
@@ -3041,6 +3054,7 @@
           <a:lstStyle xmlns:a="http://schemas.openxmlformats.org/drawingml/2006/main"/>
           <a:p xmlns:a="http://schemas.openxmlformats.org/drawingml/2006/main">
             <a:pPr algn="l">
+              <a:buNone/>
               <a:defRPr sz="1425" b="0">
                 <a:solidFill>
                   <a:srgbClr val="5E6773"/>
@@ -3064,6 +3078,7 @@
           </a:p>
           <a:p xmlns:a="http://schemas.openxmlformats.org/drawingml/2006/main">
             <a:pPr algn="l">
+              <a:buNone/>
               <a:defRPr sz="1425" b="0">
                 <a:solidFill>
                   <a:srgbClr val="5E6773"/>
@@ -3082,7 +3097,7 @@
                 <a:ea typeface="Arial"/>
                 <a:cs typeface="Arial"/>
               </a:rPr>
-              <a:t>3 / 3 documents</a:t>
+              <a:t>6 / 6 documents</a:t>
             </a:r>
           </a:p>
         </p:txBody>
@@ -3153,6 +3168,7 @@
           <a:lstStyle xmlns:a="http://schemas.openxmlformats.org/drawingml/2006/main"/>
           <a:p xmlns:a="http://schemas.openxmlformats.org/drawingml/2006/main">
             <a:pPr algn="l">
+              <a:buNone/>
               <a:defRPr sz="3750" b="1">
                 <a:solidFill>
                   <a:srgbClr val="000000"/>
@@ -3171,7 +3187,7 @@
                 <a:ea typeface="Arial"/>
                 <a:cs typeface="Arial"/>
               </a:rPr>
-              <a:t>33.33%</a:t>
+              <a:t>50%</a:t>
             </a:r>
           </a:p>
         </p:txBody>
@@ -3211,6 +3227,7 @@
           <a:lstStyle xmlns:a="http://schemas.openxmlformats.org/drawingml/2006/main"/>
           <a:p xmlns:a="http://schemas.openxmlformats.org/drawingml/2006/main">
             <a:pPr algn="l">
+              <a:buNone/>
               <a:defRPr sz="1425" b="0">
                 <a:solidFill>
                   <a:srgbClr val="5E6773"/>
@@ -3234,6 +3251,7 @@
           </a:p>
           <a:p xmlns:a="http://schemas.openxmlformats.org/drawingml/2006/main">
             <a:pPr algn="l">
+              <a:buNone/>
               <a:defRPr sz="1425" b="0">
                 <a:solidFill>
                   <a:srgbClr val="5E6773"/>
@@ -3252,7 +3270,7 @@
                 <a:ea typeface="Arial"/>
                 <a:cs typeface="Arial"/>
               </a:rPr>
-              <a:t>1 / 3 eligible</a:t>
+              <a:t>3 / 6 documents</a:t>
             </a:r>
           </a:p>
         </p:txBody>
@@ -3292,6 +3310,7 @@
           <a:lstStyle xmlns:a="http://schemas.openxmlformats.org/drawingml/2006/main"/>
           <a:p xmlns:a="http://schemas.openxmlformats.org/drawingml/2006/main">
             <a:pPr algn="l">
+              <a:buNone/>
               <a:defRPr sz="1425" b="1">
                 <a:solidFill>
                   <a:srgbClr val="000000"/>
@@ -3379,6 +3398,7 @@
           <a:lstStyle xmlns:a="http://schemas.openxmlformats.org/drawingml/2006/main"/>
           <a:p xmlns:a="http://schemas.openxmlformats.org/drawingml/2006/main">
             <a:pPr algn="l">
+              <a:buNone/>
               <a:defRPr sz="1050" b="1">
                 <a:solidFill>
                   <a:srgbClr val="5E6773"/>
@@ -3437,6 +3457,7 @@
           <a:lstStyle xmlns:a="http://schemas.openxmlformats.org/drawingml/2006/main"/>
           <a:p xmlns:a="http://schemas.openxmlformats.org/drawingml/2006/main">
             <a:pPr algn="l">
+              <a:buNone/>
               <a:defRPr sz="2850" b="1">
                 <a:solidFill>
                   <a:srgbClr val="000000"/>
@@ -3526,6 +3547,7 @@
           <a:lstStyle xmlns:a="http://schemas.openxmlformats.org/drawingml/2006/main"/>
           <a:p xmlns:a="http://schemas.openxmlformats.org/drawingml/2006/main">
             <a:pPr algn="r">
+              <a:buNone/>
               <a:defRPr sz="975" b="0">
                 <a:solidFill>
                   <a:srgbClr val="5E6773"/>
@@ -3648,6 +3670,7 @@
           <a:lstStyle xmlns:a="http://schemas.openxmlformats.org/drawingml/2006/main"/>
           <a:p xmlns:a="http://schemas.openxmlformats.org/drawingml/2006/main">
             <a:pPr algn="l">
+              <a:buNone/>
               <a:defRPr sz="1275" b="1">
                 <a:solidFill>
                   <a:srgbClr val="5E6773"/>
@@ -3706,6 +3729,7 @@
           <a:lstStyle xmlns:a="http://schemas.openxmlformats.org/drawingml/2006/main"/>
           <a:p xmlns:a="http://schemas.openxmlformats.org/drawingml/2006/main">
             <a:pPr algn="l">
+              <a:buNone/>
               <a:defRPr sz="1875" b="1">
                 <a:solidFill>
                   <a:srgbClr val="000000"/>
@@ -3764,6 +3788,7 @@
           <a:lstStyle xmlns:a="http://schemas.openxmlformats.org/drawingml/2006/main"/>
           <a:p xmlns:a="http://schemas.openxmlformats.org/drawingml/2006/main">
             <a:pPr algn="l">
+              <a:buNone/>
               <a:defRPr sz="1425" b="0">
                 <a:solidFill>
                   <a:srgbClr val="5E6773"/>
@@ -3787,6 +3812,7 @@
           </a:p>
           <a:p xmlns:a="http://schemas.openxmlformats.org/drawingml/2006/main">
             <a:pPr algn="l">
+              <a:buNone/>
               <a:defRPr sz="1425" b="0">
                 <a:solidFill>
                   <a:srgbClr val="5E6773"/>
@@ -3878,6 +3904,7 @@
           <a:lstStyle xmlns:a="http://schemas.openxmlformats.org/drawingml/2006/main"/>
           <a:p xmlns:a="http://schemas.openxmlformats.org/drawingml/2006/main">
             <a:pPr algn="l">
+              <a:buNone/>
               <a:defRPr sz="1275" b="1">
                 <a:solidFill>
                   <a:srgbClr val="5E6773"/>
@@ -3936,6 +3963,7 @@
           <a:lstStyle xmlns:a="http://schemas.openxmlformats.org/drawingml/2006/main"/>
           <a:p xmlns:a="http://schemas.openxmlformats.org/drawingml/2006/main">
             <a:pPr algn="l">
+              <a:buNone/>
               <a:defRPr sz="1875" b="1">
                 <a:solidFill>
                   <a:srgbClr val="000000"/>
@@ -3994,6 +4022,7 @@
           <a:lstStyle xmlns:a="http://schemas.openxmlformats.org/drawingml/2006/main"/>
           <a:p xmlns:a="http://schemas.openxmlformats.org/drawingml/2006/main">
             <a:pPr algn="l">
+              <a:buNone/>
               <a:defRPr sz="1425" b="0">
                 <a:solidFill>
                   <a:srgbClr val="5E6773"/>
@@ -4017,6 +4046,7 @@
           </a:p>
           <a:p xmlns:a="http://schemas.openxmlformats.org/drawingml/2006/main">
             <a:pPr algn="l">
+              <a:buNone/>
               <a:defRPr sz="1425" b="0">
                 <a:solidFill>
                   <a:srgbClr val="5E6773"/>
@@ -4035,7 +4065,7 @@
                 <a:ea typeface="Arial"/>
                 <a:cs typeface="Arial"/>
               </a:rPr>
-              <a:t>9 tests · evaluation</a:t>
+              <a:t>11 tests · multi-format eval</a:t>
             </a:r>
           </a:p>
         </p:txBody>
@@ -4108,6 +4138,7 @@
           <a:lstStyle xmlns:a="http://schemas.openxmlformats.org/drawingml/2006/main"/>
           <a:p xmlns:a="http://schemas.openxmlformats.org/drawingml/2006/main">
             <a:pPr algn="l">
+              <a:buNone/>
               <a:defRPr sz="1275" b="1">
                 <a:solidFill>
                   <a:srgbClr val="5E6773"/>
@@ -4166,6 +4197,7 @@
           <a:lstStyle xmlns:a="http://schemas.openxmlformats.org/drawingml/2006/main"/>
           <a:p xmlns:a="http://schemas.openxmlformats.org/drawingml/2006/main">
             <a:pPr algn="l">
+              <a:buNone/>
               <a:defRPr sz="1875" b="1">
                 <a:solidFill>
                   <a:srgbClr val="000000"/>
@@ -4224,6 +4256,7 @@
           <a:lstStyle xmlns:a="http://schemas.openxmlformats.org/drawingml/2006/main"/>
           <a:p xmlns:a="http://schemas.openxmlformats.org/drawingml/2006/main">
             <a:pPr algn="l">
+              <a:buNone/>
               <a:defRPr sz="1425" b="0">
                 <a:solidFill>
                   <a:srgbClr val="5E6773"/>
@@ -4247,6 +4280,7 @@
           </a:p>
           <a:p xmlns:a="http://schemas.openxmlformats.org/drawingml/2006/main">
             <a:pPr algn="l">
+              <a:buNone/>
               <a:defRPr sz="1425" b="0">
                 <a:solidFill>
                   <a:srgbClr val="5E6773"/>
@@ -4336,6 +4370,7 @@
           <a:lstStyle xmlns:a="http://schemas.openxmlformats.org/drawingml/2006/main"/>
           <a:p xmlns:a="http://schemas.openxmlformats.org/drawingml/2006/main">
             <a:pPr algn="ctr">
+              <a:buNone/>
               <a:defRPr sz="1425" b="1">
                 <a:solidFill>
                   <a:srgbClr val="000000"/>
@@ -4423,6 +4458,7 @@
           <a:lstStyle xmlns:a="http://schemas.openxmlformats.org/drawingml/2006/main"/>
           <a:p xmlns:a="http://schemas.openxmlformats.org/drawingml/2006/main">
             <a:pPr algn="l">
+              <a:buNone/>
               <a:defRPr sz="1200" b="1">
                 <a:solidFill>
                   <a:srgbClr val="3D8DFF"/>
@@ -4481,6 +4517,7 @@
           <a:lstStyle xmlns:a="http://schemas.openxmlformats.org/drawingml/2006/main"/>
           <a:p xmlns:a="http://schemas.openxmlformats.org/drawingml/2006/main">
             <a:pPr algn="l">
+              <a:buNone/>
               <a:defRPr sz="3750" b="1">
                 <a:solidFill>
                   <a:srgbClr val="000000"/>
@@ -4570,6 +4607,7 @@
           <a:lstStyle xmlns:a="http://schemas.openxmlformats.org/drawingml/2006/main"/>
           <a:p xmlns:a="http://schemas.openxmlformats.org/drawingml/2006/main">
             <a:pPr algn="l">
+              <a:buNone/>
               <a:defRPr sz="1800" b="0">
                 <a:solidFill>
                   <a:srgbClr val="5E6773"/>
@@ -4593,6 +4631,7 @@
           </a:p>
           <a:p xmlns:a="http://schemas.openxmlformats.org/drawingml/2006/main">
             <a:pPr algn="l">
+              <a:buNone/>
               <a:defRPr sz="1800" b="0">
                 <a:solidFill>
                   <a:srgbClr val="5E6773"/>
@@ -4616,6 +4655,7 @@
           </a:p>
           <a:p xmlns:a="http://schemas.openxmlformats.org/drawingml/2006/main">
             <a:pPr algn="l">
+              <a:buNone/>
               <a:defRPr sz="1800" b="0">
                 <a:solidFill>
                   <a:srgbClr val="5E6773"/>
@@ -4639,6 +4679,7 @@
           </a:p>
           <a:p xmlns:a="http://schemas.openxmlformats.org/drawingml/2006/main">
             <a:pPr algn="l">
+              <a:buNone/>
               <a:defRPr sz="1800" b="0">
                 <a:solidFill>
                   <a:srgbClr val="5E6773"/>
@@ -4728,6 +4769,7 @@
           <a:lstStyle xmlns:a="http://schemas.openxmlformats.org/drawingml/2006/main"/>
           <a:p xmlns:a="http://schemas.openxmlformats.org/drawingml/2006/main">
             <a:pPr algn="l">
+              <a:buNone/>
               <a:defRPr sz="1650" b="1">
                 <a:solidFill>
                   <a:srgbClr val="FFFFFF"/>
@@ -4756,6 +4798,7 @@
           </a:p>
           <a:p xmlns:a="http://schemas.openxmlformats.org/drawingml/2006/main">
             <a:pPr algn="l">
+              <a:buNone/>
               <a:defRPr sz="1650" b="1">
                 <a:solidFill>
                   <a:srgbClr val="FFFFFF"/>
@@ -4814,6 +4857,7 @@
           <a:lstStyle xmlns:a="http://schemas.openxmlformats.org/drawingml/2006/main"/>
           <a:p xmlns:a="http://schemas.openxmlformats.org/drawingml/2006/main">
             <a:pPr algn="r">
+              <a:buNone/>
               <a:defRPr sz="975" b="0">
                 <a:solidFill>
                   <a:srgbClr val="5E6773"/>
@@ -4901,6 +4945,7 @@
           <a:lstStyle xmlns:a="http://schemas.openxmlformats.org/drawingml/2006/main"/>
           <a:p xmlns:a="http://schemas.openxmlformats.org/drawingml/2006/main">
             <a:pPr algn="l">
+              <a:buNone/>
               <a:defRPr sz="1050" b="1">
                 <a:solidFill>
                   <a:srgbClr val="5E6773"/>
@@ -4959,6 +5004,7 @@
           <a:lstStyle xmlns:a="http://schemas.openxmlformats.org/drawingml/2006/main"/>
           <a:p xmlns:a="http://schemas.openxmlformats.org/drawingml/2006/main">
             <a:pPr algn="l">
+              <a:buNone/>
               <a:defRPr sz="2850" b="1">
                 <a:solidFill>
                   <a:srgbClr val="000000"/>
@@ -5048,6 +5094,7 @@
           <a:lstStyle xmlns:a="http://schemas.openxmlformats.org/drawingml/2006/main"/>
           <a:p xmlns:a="http://schemas.openxmlformats.org/drawingml/2006/main">
             <a:pPr algn="r">
+              <a:buNone/>
               <a:defRPr sz="975" b="0">
                 <a:solidFill>
                   <a:srgbClr val="5E6773"/>
@@ -5106,6 +5153,7 @@
           <a:lstStyle xmlns:a="http://schemas.openxmlformats.org/drawingml/2006/main"/>
           <a:p xmlns:a="http://schemas.openxmlformats.org/drawingml/2006/main">
             <a:pPr algn="l">
+              <a:buNone/>
               <a:defRPr sz="2100" b="1">
                 <a:solidFill>
                   <a:srgbClr val="000000"/>
@@ -5195,6 +5243,7 @@
           <a:lstStyle xmlns:a="http://schemas.openxmlformats.org/drawingml/2006/main"/>
           <a:p xmlns:a="http://schemas.openxmlformats.org/drawingml/2006/main">
             <a:pPr algn="l">
+              <a:buNone/>
               <a:defRPr sz="1800" b="1">
                 <a:solidFill>
                   <a:srgbClr val="000000"/>
@@ -5253,6 +5302,7 @@
           <a:lstStyle xmlns:a="http://schemas.openxmlformats.org/drawingml/2006/main"/>
           <a:p xmlns:a="http://schemas.openxmlformats.org/drawingml/2006/main">
             <a:pPr algn="l">
+              <a:buNone/>
               <a:defRPr sz="1350" b="0">
                 <a:solidFill>
                   <a:srgbClr val="5E6773"/>
@@ -5342,6 +5392,7 @@
           <a:lstStyle xmlns:a="http://schemas.openxmlformats.org/drawingml/2006/main"/>
           <a:p xmlns:a="http://schemas.openxmlformats.org/drawingml/2006/main">
             <a:pPr algn="l">
+              <a:buNone/>
               <a:defRPr sz="1800" b="1">
                 <a:solidFill>
                   <a:srgbClr val="000000"/>
@@ -5400,6 +5451,7 @@
           <a:lstStyle xmlns:a="http://schemas.openxmlformats.org/drawingml/2006/main"/>
           <a:p xmlns:a="http://schemas.openxmlformats.org/drawingml/2006/main">
             <a:pPr algn="l">
+              <a:buNone/>
               <a:defRPr sz="1350" b="0">
                 <a:solidFill>
                   <a:srgbClr val="5E6773"/>
@@ -5489,6 +5541,7 @@
           <a:lstStyle xmlns:a="http://schemas.openxmlformats.org/drawingml/2006/main"/>
           <a:p xmlns:a="http://schemas.openxmlformats.org/drawingml/2006/main">
             <a:pPr algn="l">
+              <a:buNone/>
               <a:defRPr sz="1800" b="1">
                 <a:solidFill>
                   <a:srgbClr val="000000"/>
@@ -5547,6 +5600,7 @@
           <a:lstStyle xmlns:a="http://schemas.openxmlformats.org/drawingml/2006/main"/>
           <a:p xmlns:a="http://schemas.openxmlformats.org/drawingml/2006/main">
             <a:pPr algn="l">
+              <a:buNone/>
               <a:defRPr sz="1350" b="0">
                 <a:solidFill>
                   <a:srgbClr val="5E6773"/>
@@ -5605,6 +5659,7 @@
           <a:lstStyle xmlns:a="http://schemas.openxmlformats.org/drawingml/2006/main"/>
           <a:p xmlns:a="http://schemas.openxmlformats.org/drawingml/2006/main">
             <a:pPr algn="l">
+              <a:buNone/>
               <a:defRPr sz="1650" b="1">
                 <a:solidFill>
                   <a:srgbClr val="000000"/>
@@ -5692,6 +5747,7 @@
           <a:lstStyle xmlns:a="http://schemas.openxmlformats.org/drawingml/2006/main"/>
           <a:p xmlns:a="http://schemas.openxmlformats.org/drawingml/2006/main">
             <a:pPr algn="l">
+              <a:buNone/>
               <a:defRPr sz="1050" b="1">
                 <a:solidFill>
                   <a:srgbClr val="5E6773"/>
@@ -5750,6 +5806,7 @@
           <a:lstStyle xmlns:a="http://schemas.openxmlformats.org/drawingml/2006/main"/>
           <a:p xmlns:a="http://schemas.openxmlformats.org/drawingml/2006/main">
             <a:pPr algn="l">
+              <a:buNone/>
               <a:defRPr sz="2850" b="1">
                 <a:solidFill>
                   <a:srgbClr val="000000"/>
@@ -5839,6 +5896,7 @@
           <a:lstStyle xmlns:a="http://schemas.openxmlformats.org/drawingml/2006/main"/>
           <a:p xmlns:a="http://schemas.openxmlformats.org/drawingml/2006/main">
             <a:pPr algn="r">
+              <a:buNone/>
               <a:defRPr sz="975" b="0">
                 <a:solidFill>
                   <a:srgbClr val="5E6773"/>
@@ -6207,6 +6265,7 @@
           <a:lstStyle xmlns:a="http://schemas.openxmlformats.org/drawingml/2006/main"/>
           <a:p xmlns:a="http://schemas.openxmlformats.org/drawingml/2006/main">
             <a:pPr algn="l">
+              <a:buNone/>
               <a:defRPr sz="1725" b="1">
                 <a:solidFill>
                   <a:srgbClr val="000000"/>
@@ -6265,6 +6324,7 @@
           <a:lstStyle xmlns:a="http://schemas.openxmlformats.org/drawingml/2006/main"/>
           <a:p xmlns:a="http://schemas.openxmlformats.org/drawingml/2006/main">
             <a:pPr algn="l">
+              <a:buNone/>
               <a:defRPr sz="1200" b="0">
                 <a:solidFill>
                   <a:srgbClr val="5E6773"/>
@@ -6288,6 +6348,7 @@
           </a:p>
           <a:p xmlns:a="http://schemas.openxmlformats.org/drawingml/2006/main">
             <a:pPr algn="l">
+              <a:buNone/>
               <a:defRPr sz="1200" b="0">
                 <a:solidFill>
                   <a:srgbClr val="5E6773"/>
@@ -6377,6 +6438,7 @@
           <a:lstStyle xmlns:a="http://schemas.openxmlformats.org/drawingml/2006/main"/>
           <a:p xmlns:a="http://schemas.openxmlformats.org/drawingml/2006/main">
             <a:pPr algn="l">
+              <a:buNone/>
               <a:defRPr sz="1725" b="1">
                 <a:solidFill>
                   <a:srgbClr val="000000"/>
@@ -6435,6 +6497,7 @@
           <a:lstStyle xmlns:a="http://schemas.openxmlformats.org/drawingml/2006/main"/>
           <a:p xmlns:a="http://schemas.openxmlformats.org/drawingml/2006/main">
             <a:pPr algn="l">
+              <a:buNone/>
               <a:defRPr sz="1200" b="0">
                 <a:solidFill>
                   <a:srgbClr val="5E6773"/>
@@ -6453,11 +6516,12 @@
                 <a:ea typeface="Arial"/>
                 <a:cs typeface="Arial"/>
               </a:rPr>
-              <a:t>Docling</a:t>
-            </a:r>
-          </a:p>
-          <a:p xmlns:a="http://schemas.openxmlformats.org/drawingml/2006/main">
-            <a:pPr algn="l">
+              <a:t>PDF text + OCR</a:t>
+            </a:r>
+          </a:p>
+          <a:p xmlns:a="http://schemas.openxmlformats.org/drawingml/2006/main">
+            <a:pPr algn="l">
+              <a:buNone/>
               <a:defRPr sz="1200" b="0">
                 <a:solidFill>
                   <a:srgbClr val="5E6773"/>
@@ -6476,7 +6540,7 @@
                 <a:ea typeface="Arial"/>
                 <a:cs typeface="Arial"/>
               </a:rPr>
-              <a:t>Ollama</a:t>
+              <a:t>Docling + Ollama</a:t>
             </a:r>
           </a:p>
         </p:txBody>
@@ -6547,6 +6611,7 @@
           <a:lstStyle xmlns:a="http://schemas.openxmlformats.org/drawingml/2006/main"/>
           <a:p xmlns:a="http://schemas.openxmlformats.org/drawingml/2006/main">
             <a:pPr algn="l">
+              <a:buNone/>
               <a:defRPr sz="1725" b="1">
                 <a:solidFill>
                   <a:srgbClr val="FFFFFF"/>
@@ -6605,6 +6670,7 @@
           <a:lstStyle xmlns:a="http://schemas.openxmlformats.org/drawingml/2006/main"/>
           <a:p xmlns:a="http://schemas.openxmlformats.org/drawingml/2006/main">
             <a:pPr algn="l">
+              <a:buNone/>
               <a:defRPr sz="1200" b="0">
                 <a:solidFill>
                   <a:srgbClr val="D7E7F4"/>
@@ -6628,6 +6694,7 @@
           </a:p>
           <a:p xmlns:a="http://schemas.openxmlformats.org/drawingml/2006/main">
             <a:pPr algn="l">
+              <a:buNone/>
               <a:defRPr sz="1200" b="0">
                 <a:solidFill>
                   <a:srgbClr val="D7E7F4"/>
@@ -6717,6 +6784,7 @@
           <a:lstStyle xmlns:a="http://schemas.openxmlformats.org/drawingml/2006/main"/>
           <a:p xmlns:a="http://schemas.openxmlformats.org/drawingml/2006/main">
             <a:pPr algn="l">
+              <a:buNone/>
               <a:defRPr sz="1725" b="1">
                 <a:solidFill>
                   <a:srgbClr val="000000"/>
@@ -6775,6 +6843,7 @@
           <a:lstStyle xmlns:a="http://schemas.openxmlformats.org/drawingml/2006/main"/>
           <a:p xmlns:a="http://schemas.openxmlformats.org/drawingml/2006/main">
             <a:pPr algn="l">
+              <a:buNone/>
               <a:defRPr sz="1200" b="0">
                 <a:solidFill>
                   <a:srgbClr val="5E6773"/>
@@ -6798,6 +6867,7 @@
           </a:p>
           <a:p xmlns:a="http://schemas.openxmlformats.org/drawingml/2006/main">
             <a:pPr algn="l">
+              <a:buNone/>
               <a:defRPr sz="1200" b="0">
                 <a:solidFill>
                   <a:srgbClr val="5E6773"/>
@@ -6887,6 +6957,7 @@
           <a:lstStyle xmlns:a="http://schemas.openxmlformats.org/drawingml/2006/main"/>
           <a:p xmlns:a="http://schemas.openxmlformats.org/drawingml/2006/main">
             <a:pPr algn="l">
+              <a:buNone/>
               <a:defRPr sz="1725" b="1">
                 <a:solidFill>
                   <a:srgbClr val="000000"/>
@@ -6945,6 +7016,7 @@
           <a:lstStyle xmlns:a="http://schemas.openxmlformats.org/drawingml/2006/main"/>
           <a:p xmlns:a="http://schemas.openxmlformats.org/drawingml/2006/main">
             <a:pPr algn="l">
+              <a:buNone/>
               <a:defRPr sz="1200" b="0">
                 <a:solidFill>
                   <a:srgbClr val="5E6773"/>
@@ -6968,6 +7040,7 @@
           </a:p>
           <a:p xmlns:a="http://schemas.openxmlformats.org/drawingml/2006/main">
             <a:pPr algn="l">
+              <a:buNone/>
               <a:defRPr sz="1200" b="0">
                 <a:solidFill>
                   <a:srgbClr val="5E6773"/>
@@ -7059,6 +7132,7 @@
           <a:lstStyle xmlns:a="http://schemas.openxmlformats.org/drawingml/2006/main"/>
           <a:p xmlns:a="http://schemas.openxmlformats.org/drawingml/2006/main">
             <a:pPr algn="ctr">
+              <a:buNone/>
               <a:defRPr sz="1425" b="1">
                 <a:solidFill>
                   <a:srgbClr val="000000"/>
@@ -7146,6 +7220,7 @@
           <a:lstStyle xmlns:a="http://schemas.openxmlformats.org/drawingml/2006/main"/>
           <a:p xmlns:a="http://schemas.openxmlformats.org/drawingml/2006/main">
             <a:pPr algn="l">
+              <a:buNone/>
               <a:defRPr sz="1050" b="1">
                 <a:solidFill>
                   <a:srgbClr val="5E6773"/>
@@ -7204,6 +7279,7 @@
           <a:lstStyle xmlns:a="http://schemas.openxmlformats.org/drawingml/2006/main"/>
           <a:p xmlns:a="http://schemas.openxmlformats.org/drawingml/2006/main">
             <a:pPr algn="l">
+              <a:buNone/>
               <a:defRPr sz="2850" b="1">
                 <a:solidFill>
                   <a:srgbClr val="000000"/>
@@ -7293,6 +7369,7 @@
           <a:lstStyle xmlns:a="http://schemas.openxmlformats.org/drawingml/2006/main"/>
           <a:p xmlns:a="http://schemas.openxmlformats.org/drawingml/2006/main">
             <a:pPr algn="r">
+              <a:buNone/>
               <a:defRPr sz="975" b="0">
                 <a:solidFill>
                   <a:srgbClr val="5E6773"/>
@@ -7415,6 +7492,7 @@
           <a:lstStyle xmlns:a="http://schemas.openxmlformats.org/drawingml/2006/main"/>
           <a:p xmlns:a="http://schemas.openxmlformats.org/drawingml/2006/main">
             <a:pPr algn="l">
+              <a:buNone/>
               <a:defRPr sz="1275" b="1">
                 <a:solidFill>
                   <a:srgbClr val="5E6773"/>
@@ -7473,6 +7551,7 @@
           <a:lstStyle xmlns:a="http://schemas.openxmlformats.org/drawingml/2006/main"/>
           <a:p xmlns:a="http://schemas.openxmlformats.org/drawingml/2006/main">
             <a:pPr algn="l">
+              <a:buNone/>
               <a:defRPr sz="1650" b="1">
                 <a:solidFill>
                   <a:srgbClr val="000000"/>
@@ -7531,6 +7610,7 @@
           <a:lstStyle xmlns:a="http://schemas.openxmlformats.org/drawingml/2006/main"/>
           <a:p xmlns:a="http://schemas.openxmlformats.org/drawingml/2006/main">
             <a:pPr algn="l">
+              <a:buNone/>
               <a:defRPr sz="1200" b="0">
                 <a:solidFill>
                   <a:srgbClr val="5E6773"/>
@@ -7622,6 +7702,7 @@
           <a:lstStyle xmlns:a="http://schemas.openxmlformats.org/drawingml/2006/main"/>
           <a:p xmlns:a="http://schemas.openxmlformats.org/drawingml/2006/main">
             <a:pPr algn="l">
+              <a:buNone/>
               <a:defRPr sz="1275" b="1">
                 <a:solidFill>
                   <a:srgbClr val="5E6773"/>
@@ -7680,6 +7761,7 @@
           <a:lstStyle xmlns:a="http://schemas.openxmlformats.org/drawingml/2006/main"/>
           <a:p xmlns:a="http://schemas.openxmlformats.org/drawingml/2006/main">
             <a:pPr algn="l">
+              <a:buNone/>
               <a:defRPr sz="1650" b="1">
                 <a:solidFill>
                   <a:srgbClr val="000000"/>
@@ -7738,6 +7820,7 @@
           <a:lstStyle xmlns:a="http://schemas.openxmlformats.org/drawingml/2006/main"/>
           <a:p xmlns:a="http://schemas.openxmlformats.org/drawingml/2006/main">
             <a:pPr algn="l">
+              <a:buNone/>
               <a:defRPr sz="1200" b="0">
                 <a:solidFill>
                   <a:srgbClr val="5E6773"/>
@@ -7829,6 +7912,7 @@
           <a:lstStyle xmlns:a="http://schemas.openxmlformats.org/drawingml/2006/main"/>
           <a:p xmlns:a="http://schemas.openxmlformats.org/drawingml/2006/main">
             <a:pPr algn="l">
+              <a:buNone/>
               <a:defRPr sz="1275" b="1">
                 <a:solidFill>
                   <a:srgbClr val="5E6773"/>
@@ -7887,6 +7971,7 @@
           <a:lstStyle xmlns:a="http://schemas.openxmlformats.org/drawingml/2006/main"/>
           <a:p xmlns:a="http://schemas.openxmlformats.org/drawingml/2006/main">
             <a:pPr algn="l">
+              <a:buNone/>
               <a:defRPr sz="1650" b="1">
                 <a:solidFill>
                   <a:srgbClr val="000000"/>
@@ -7945,6 +8030,7 @@
           <a:lstStyle xmlns:a="http://schemas.openxmlformats.org/drawingml/2006/main"/>
           <a:p xmlns:a="http://schemas.openxmlformats.org/drawingml/2006/main">
             <a:pPr algn="l">
+              <a:buNone/>
               <a:defRPr sz="1200" b="0">
                 <a:solidFill>
                   <a:srgbClr val="5E6773"/>
@@ -8036,6 +8122,7 @@
           <a:lstStyle xmlns:a="http://schemas.openxmlformats.org/drawingml/2006/main"/>
           <a:p xmlns:a="http://schemas.openxmlformats.org/drawingml/2006/main">
             <a:pPr algn="l">
+              <a:buNone/>
               <a:defRPr sz="1275" b="1">
                 <a:solidFill>
                   <a:srgbClr val="5E6773"/>
@@ -8094,6 +8181,7 @@
           <a:lstStyle xmlns:a="http://schemas.openxmlformats.org/drawingml/2006/main"/>
           <a:p xmlns:a="http://schemas.openxmlformats.org/drawingml/2006/main">
             <a:pPr algn="l">
+              <a:buNone/>
               <a:defRPr sz="1650" b="1">
                 <a:solidFill>
                   <a:srgbClr val="000000"/>
@@ -8152,6 +8240,7 @@
           <a:lstStyle xmlns:a="http://schemas.openxmlformats.org/drawingml/2006/main"/>
           <a:p xmlns:a="http://schemas.openxmlformats.org/drawingml/2006/main">
             <a:pPr algn="l">
+              <a:buNone/>
               <a:defRPr sz="1200" b="0">
                 <a:solidFill>
                   <a:srgbClr val="5E6773"/>
@@ -8243,6 +8332,7 @@
           <a:lstStyle xmlns:a="http://schemas.openxmlformats.org/drawingml/2006/main"/>
           <a:p xmlns:a="http://schemas.openxmlformats.org/drawingml/2006/main">
             <a:pPr algn="l">
+              <a:buNone/>
               <a:defRPr sz="1275" b="1">
                 <a:solidFill>
                   <a:srgbClr val="5E6773"/>
@@ -8301,6 +8391,7 @@
           <a:lstStyle xmlns:a="http://schemas.openxmlformats.org/drawingml/2006/main"/>
           <a:p xmlns:a="http://schemas.openxmlformats.org/drawingml/2006/main">
             <a:pPr algn="l">
+              <a:buNone/>
               <a:defRPr sz="1650" b="1">
                 <a:solidFill>
                   <a:srgbClr val="000000"/>
@@ -8359,6 +8450,7 @@
           <a:lstStyle xmlns:a="http://schemas.openxmlformats.org/drawingml/2006/main"/>
           <a:p xmlns:a="http://schemas.openxmlformats.org/drawingml/2006/main">
             <a:pPr algn="l">
+              <a:buNone/>
               <a:defRPr sz="1200" b="0">
                 <a:solidFill>
                   <a:srgbClr val="5E6773"/>
@@ -8450,6 +8542,7 @@
           <a:lstStyle xmlns:a="http://schemas.openxmlformats.org/drawingml/2006/main"/>
           <a:p xmlns:a="http://schemas.openxmlformats.org/drawingml/2006/main">
             <a:pPr algn="l">
+              <a:buNone/>
               <a:defRPr sz="1275" b="1">
                 <a:solidFill>
                   <a:srgbClr val="5E6773"/>
@@ -8508,6 +8601,7 @@
           <a:lstStyle xmlns:a="http://schemas.openxmlformats.org/drawingml/2006/main"/>
           <a:p xmlns:a="http://schemas.openxmlformats.org/drawingml/2006/main">
             <a:pPr algn="l">
+              <a:buNone/>
               <a:defRPr sz="1650" b="1">
                 <a:solidFill>
                   <a:srgbClr val="000000"/>
@@ -8566,6 +8660,7 @@
           <a:lstStyle xmlns:a="http://schemas.openxmlformats.org/drawingml/2006/main"/>
           <a:p xmlns:a="http://schemas.openxmlformats.org/drawingml/2006/main">
             <a:pPr algn="l">
+              <a:buNone/>
               <a:defRPr sz="1200" b="0">
                 <a:solidFill>
                   <a:srgbClr val="5E6773"/>
@@ -8624,6 +8719,7 @@
           <a:lstStyle xmlns:a="http://schemas.openxmlformats.org/drawingml/2006/main"/>
           <a:p xmlns:a="http://schemas.openxmlformats.org/drawingml/2006/main">
             <a:pPr algn="l">
+              <a:buNone/>
               <a:defRPr sz="1650" b="1">
                 <a:solidFill>
                   <a:srgbClr val="000000"/>
@@ -8711,6 +8807,7 @@
           <a:lstStyle xmlns:a="http://schemas.openxmlformats.org/drawingml/2006/main"/>
           <a:p xmlns:a="http://schemas.openxmlformats.org/drawingml/2006/main">
             <a:pPr algn="l">
+              <a:buNone/>
               <a:defRPr sz="1050" b="1">
                 <a:solidFill>
                   <a:srgbClr val="5E6773"/>
@@ -8769,6 +8866,7 @@
           <a:lstStyle xmlns:a="http://schemas.openxmlformats.org/drawingml/2006/main"/>
           <a:p xmlns:a="http://schemas.openxmlformats.org/drawingml/2006/main">
             <a:pPr algn="l">
+              <a:buNone/>
               <a:defRPr sz="2850" b="1">
                 <a:solidFill>
                   <a:srgbClr val="000000"/>
@@ -8858,6 +8956,7 @@
           <a:lstStyle xmlns:a="http://schemas.openxmlformats.org/drawingml/2006/main"/>
           <a:p xmlns:a="http://schemas.openxmlformats.org/drawingml/2006/main">
             <a:pPr algn="r">
+              <a:buNone/>
               <a:defRPr sz="975" b="0">
                 <a:solidFill>
                   <a:srgbClr val="5E6773"/>
@@ -8916,6 +9015,7 @@
           <a:lstStyle xmlns:a="http://schemas.openxmlformats.org/drawingml/2006/main"/>
           <a:p xmlns:a="http://schemas.openxmlformats.org/drawingml/2006/main">
             <a:pPr algn="l">
+              <a:buNone/>
               <a:defRPr sz="1350" b="1">
                 <a:solidFill>
                   <a:srgbClr val="3D8DFF"/>
@@ -8974,6 +9074,7 @@
           <a:lstStyle xmlns:a="http://schemas.openxmlformats.org/drawingml/2006/main"/>
           <a:p xmlns:a="http://schemas.openxmlformats.org/drawingml/2006/main">
             <a:pPr algn="l">
+              <a:buNone/>
               <a:defRPr sz="2325" b="1">
                 <a:solidFill>
                   <a:srgbClr val="000000"/>
@@ -9032,6 +9133,7 @@
           <a:lstStyle xmlns:a="http://schemas.openxmlformats.org/drawingml/2006/main"/>
           <a:p xmlns:a="http://schemas.openxmlformats.org/drawingml/2006/main">
             <a:pPr algn="l">
+              <a:buNone/>
               <a:defRPr sz="1425" b="0">
                 <a:solidFill>
                   <a:srgbClr val="5E6773"/>
@@ -9121,6 +9223,7 @@
           <a:lstStyle xmlns:a="http://schemas.openxmlformats.org/drawingml/2006/main"/>
           <a:p xmlns:a="http://schemas.openxmlformats.org/drawingml/2006/main">
             <a:pPr algn="l">
+              <a:buNone/>
               <a:defRPr sz="1350" b="1">
                 <a:solidFill>
                   <a:srgbClr val="2F7D58"/>
@@ -9179,6 +9282,7 @@
           <a:lstStyle xmlns:a="http://schemas.openxmlformats.org/drawingml/2006/main"/>
           <a:p xmlns:a="http://schemas.openxmlformats.org/drawingml/2006/main">
             <a:pPr algn="l">
+              <a:buNone/>
               <a:defRPr sz="2325" b="1">
                 <a:solidFill>
                   <a:srgbClr val="000000"/>
@@ -9237,6 +9341,7 @@
           <a:lstStyle xmlns:a="http://schemas.openxmlformats.org/drawingml/2006/main"/>
           <a:p xmlns:a="http://schemas.openxmlformats.org/drawingml/2006/main">
             <a:pPr algn="l">
+              <a:buNone/>
               <a:defRPr sz="1425" b="0">
                 <a:solidFill>
                   <a:srgbClr val="5E6773"/>
@@ -9326,6 +9431,7 @@
           <a:lstStyle xmlns:a="http://schemas.openxmlformats.org/drawingml/2006/main"/>
           <a:p xmlns:a="http://schemas.openxmlformats.org/drawingml/2006/main">
             <a:pPr algn="l">
+              <a:buNone/>
               <a:defRPr sz="2850" b="1">
                 <a:solidFill>
                   <a:srgbClr val="000000"/>
@@ -9384,6 +9490,7 @@
           <a:lstStyle xmlns:a="http://schemas.openxmlformats.org/drawingml/2006/main"/>
           <a:p xmlns:a="http://schemas.openxmlformats.org/drawingml/2006/main">
             <a:pPr algn="l">
+              <a:buNone/>
               <a:defRPr sz="1275" b="0">
                 <a:solidFill>
                   <a:srgbClr val="5E6773"/>
@@ -9442,6 +9549,7 @@
           <a:lstStyle xmlns:a="http://schemas.openxmlformats.org/drawingml/2006/main"/>
           <a:p xmlns:a="http://schemas.openxmlformats.org/drawingml/2006/main">
             <a:pPr algn="l">
+              <a:buNone/>
               <a:defRPr sz="2850" b="1">
                 <a:solidFill>
                   <a:srgbClr val="000000"/>
@@ -9500,6 +9608,7 @@
           <a:lstStyle xmlns:a="http://schemas.openxmlformats.org/drawingml/2006/main"/>
           <a:p xmlns:a="http://schemas.openxmlformats.org/drawingml/2006/main">
             <a:pPr algn="l">
+              <a:buNone/>
               <a:defRPr sz="1275" b="0">
                 <a:solidFill>
                   <a:srgbClr val="5E6773"/>
@@ -9558,6 +9667,7 @@
           <a:lstStyle xmlns:a="http://schemas.openxmlformats.org/drawingml/2006/main"/>
           <a:p xmlns:a="http://schemas.openxmlformats.org/drawingml/2006/main">
             <a:pPr algn="l">
+              <a:buNone/>
               <a:defRPr sz="2850" b="1">
                 <a:solidFill>
                   <a:srgbClr val="000000"/>
@@ -9616,6 +9726,7 @@
           <a:lstStyle xmlns:a="http://schemas.openxmlformats.org/drawingml/2006/main"/>
           <a:p xmlns:a="http://schemas.openxmlformats.org/drawingml/2006/main">
             <a:pPr algn="l">
+              <a:buNone/>
               <a:defRPr sz="1275" b="0">
                 <a:solidFill>
                   <a:srgbClr val="5E6773"/>
@@ -9674,6 +9785,7 @@
           <a:lstStyle xmlns:a="http://schemas.openxmlformats.org/drawingml/2006/main"/>
           <a:p xmlns:a="http://schemas.openxmlformats.org/drawingml/2006/main">
             <a:pPr algn="l">
+              <a:buNone/>
               <a:defRPr sz="1350" b="1">
                 <a:solidFill>
                   <a:srgbClr val="000000"/>
@@ -9761,6 +9873,7 @@
           <a:lstStyle xmlns:a="http://schemas.openxmlformats.org/drawingml/2006/main"/>
           <a:p xmlns:a="http://schemas.openxmlformats.org/drawingml/2006/main">
             <a:pPr algn="l">
+              <a:buNone/>
               <a:defRPr sz="1050" b="1">
                 <a:solidFill>
                   <a:srgbClr val="5E6773"/>
@@ -9819,6 +9932,7 @@
           <a:lstStyle xmlns:a="http://schemas.openxmlformats.org/drawingml/2006/main"/>
           <a:p xmlns:a="http://schemas.openxmlformats.org/drawingml/2006/main">
             <a:pPr algn="l">
+              <a:buNone/>
               <a:defRPr sz="2850" b="1">
                 <a:solidFill>
                   <a:srgbClr val="000000"/>
@@ -9908,6 +10022,7 @@
           <a:lstStyle xmlns:a="http://schemas.openxmlformats.org/drawingml/2006/main"/>
           <a:p xmlns:a="http://schemas.openxmlformats.org/drawingml/2006/main">
             <a:pPr algn="r">
+              <a:buNone/>
               <a:defRPr sz="975" b="0">
                 <a:solidFill>
                   <a:srgbClr val="5E6773"/>
@@ -9966,6 +10081,7 @@
           <a:lstStyle xmlns:a="http://schemas.openxmlformats.org/drawingml/2006/main"/>
           <a:p xmlns:a="http://schemas.openxmlformats.org/drawingml/2006/main">
             <a:pPr algn="l">
+              <a:buNone/>
               <a:defRPr sz="1950" b="1">
                 <a:solidFill>
                   <a:srgbClr val="000000"/>
@@ -10055,6 +10171,7 @@
           <a:lstStyle xmlns:a="http://schemas.openxmlformats.org/drawingml/2006/main"/>
           <a:p xmlns:a="http://schemas.openxmlformats.org/drawingml/2006/main">
             <a:pPr algn="l">
+              <a:buNone/>
               <a:defRPr sz="1350" b="1">
                 <a:solidFill>
                   <a:srgbClr val="000000"/>
@@ -10144,6 +10261,7 @@
           <a:lstStyle xmlns:a="http://schemas.openxmlformats.org/drawingml/2006/main"/>
           <a:p xmlns:a="http://schemas.openxmlformats.org/drawingml/2006/main">
             <a:pPr algn="l">
+              <a:buNone/>
               <a:defRPr sz="1350" b="0">
                 <a:solidFill>
                   <a:srgbClr val="000000"/>
@@ -10233,6 +10351,7 @@
           <a:lstStyle xmlns:a="http://schemas.openxmlformats.org/drawingml/2006/main"/>
           <a:p xmlns:a="http://schemas.openxmlformats.org/drawingml/2006/main">
             <a:pPr algn="l">
+              <a:buNone/>
               <a:defRPr sz="1350" b="0">
                 <a:solidFill>
                   <a:srgbClr val="000000"/>
@@ -10322,6 +10441,7 @@
           <a:lstStyle xmlns:a="http://schemas.openxmlformats.org/drawingml/2006/main"/>
           <a:p xmlns:a="http://schemas.openxmlformats.org/drawingml/2006/main">
             <a:pPr algn="l">
+              <a:buNone/>
               <a:defRPr sz="1350" b="0">
                 <a:solidFill>
                   <a:srgbClr val="000000"/>
@@ -10380,6 +10500,7 @@
           <a:lstStyle xmlns:a="http://schemas.openxmlformats.org/drawingml/2006/main"/>
           <a:p xmlns:a="http://schemas.openxmlformats.org/drawingml/2006/main">
             <a:pPr algn="l">
+              <a:buNone/>
               <a:defRPr sz="1950" b="1">
                 <a:solidFill>
                   <a:srgbClr val="000000"/>
@@ -10469,6 +10590,7 @@
           <a:lstStyle xmlns:a="http://schemas.openxmlformats.org/drawingml/2006/main"/>
           <a:p xmlns:a="http://schemas.openxmlformats.org/drawingml/2006/main">
             <a:pPr algn="l">
+              <a:buNone/>
               <a:defRPr sz="2100" b="1">
                 <a:solidFill>
                   <a:srgbClr val="000000"/>
@@ -10527,6 +10649,7 @@
           <a:lstStyle xmlns:a="http://schemas.openxmlformats.org/drawingml/2006/main"/>
           <a:p xmlns:a="http://schemas.openxmlformats.org/drawingml/2006/main">
             <a:pPr algn="l">
+              <a:buNone/>
               <a:defRPr sz="1425" b="0">
                 <a:solidFill>
                   <a:srgbClr val="5E6773"/>
@@ -10585,6 +10708,7 @@
           <a:lstStyle xmlns:a="http://schemas.openxmlformats.org/drawingml/2006/main"/>
           <a:p xmlns:a="http://schemas.openxmlformats.org/drawingml/2006/main">
             <a:pPr algn="l">
+              <a:buNone/>
               <a:defRPr sz="1350" b="1">
                 <a:solidFill>
                   <a:srgbClr val="3D8DFF"/>
@@ -10643,6 +10767,7 @@
           <a:lstStyle xmlns:a="http://schemas.openxmlformats.org/drawingml/2006/main"/>
           <a:p xmlns:a="http://schemas.openxmlformats.org/drawingml/2006/main">
             <a:pPr algn="l">
+              <a:buNone/>
               <a:defRPr sz="1575" b="1">
                 <a:solidFill>
                   <a:srgbClr val="000000"/>
@@ -10730,6 +10855,7 @@
           <a:lstStyle xmlns:a="http://schemas.openxmlformats.org/drawingml/2006/main"/>
           <a:p xmlns:a="http://schemas.openxmlformats.org/drawingml/2006/main">
             <a:pPr algn="l">
+              <a:buNone/>
               <a:defRPr sz="1050" b="1">
                 <a:solidFill>
                   <a:srgbClr val="5E6773"/>
@@ -10788,6 +10914,7 @@
           <a:lstStyle xmlns:a="http://schemas.openxmlformats.org/drawingml/2006/main"/>
           <a:p xmlns:a="http://schemas.openxmlformats.org/drawingml/2006/main">
             <a:pPr algn="l">
+              <a:buNone/>
               <a:defRPr sz="2850" b="1">
                 <a:solidFill>
                   <a:srgbClr val="000000"/>
@@ -10877,6 +11004,7 @@
           <a:lstStyle xmlns:a="http://schemas.openxmlformats.org/drawingml/2006/main"/>
           <a:p xmlns:a="http://schemas.openxmlformats.org/drawingml/2006/main">
             <a:pPr algn="r">
+              <a:buNone/>
               <a:defRPr sz="975" b="0">
                 <a:solidFill>
                   <a:srgbClr val="5E6773"/>
@@ -10935,6 +11063,7 @@
           <a:lstStyle xmlns:a="http://schemas.openxmlformats.org/drawingml/2006/main"/>
           <a:p xmlns:a="http://schemas.openxmlformats.org/drawingml/2006/main">
             <a:pPr algn="l">
+              <a:buNone/>
               <a:defRPr sz="1200" b="1">
                 <a:solidFill>
                   <a:srgbClr val="5E6773"/>
@@ -10995,6 +11124,7 @@
           <a:lstStyle xmlns:a="http://schemas.openxmlformats.org/drawingml/2006/main"/>
           <a:p xmlns:a="http://schemas.openxmlformats.org/drawingml/2006/main">
             <a:pPr algn="ctr">
+              <a:buNone/>
               <a:defRPr sz="2250" b="1">
                 <a:solidFill>
                   <a:srgbClr val="000000"/>
@@ -11018,6 +11148,7 @@
           </a:p>
           <a:p xmlns:a="http://schemas.openxmlformats.org/drawingml/2006/main">
             <a:pPr algn="ctr">
+              <a:buNone/>
               <a:defRPr sz="2250" b="1">
                 <a:solidFill>
                   <a:srgbClr val="000000"/>
@@ -11041,6 +11172,7 @@
           </a:p>
           <a:p xmlns:a="http://schemas.openxmlformats.org/drawingml/2006/main">
             <a:pPr algn="ctr">
+              <a:buNone/>
               <a:defRPr sz="2250" b="1">
                 <a:solidFill>
                   <a:srgbClr val="000000"/>
@@ -11064,6 +11196,7 @@
           </a:p>
           <a:p xmlns:a="http://schemas.openxmlformats.org/drawingml/2006/main">
             <a:pPr algn="ctr">
+              <a:buNone/>
               <a:defRPr sz="2250" b="1">
                 <a:solidFill>
                   <a:srgbClr val="000000"/>
@@ -11087,6 +11220,7 @@
           </a:p>
           <a:p xmlns:a="http://schemas.openxmlformats.org/drawingml/2006/main">
             <a:pPr algn="ctr">
+              <a:buNone/>
               <a:defRPr sz="2250" b="1">
                 <a:solidFill>
                   <a:srgbClr val="000000"/>
@@ -11145,6 +11279,7 @@
           <a:lstStyle xmlns:a="http://schemas.openxmlformats.org/drawingml/2006/main"/>
           <a:p xmlns:a="http://schemas.openxmlformats.org/drawingml/2006/main">
             <a:pPr algn="l">
+              <a:buNone/>
               <a:defRPr sz="1200" b="1">
                 <a:solidFill>
                   <a:srgbClr val="3D8DFF"/>
@@ -11205,6 +11340,7 @@
           <a:lstStyle xmlns:a="http://schemas.openxmlformats.org/drawingml/2006/main"/>
           <a:p xmlns:a="http://schemas.openxmlformats.org/drawingml/2006/main">
             <a:pPr algn="ctr">
+              <a:buNone/>
               <a:defRPr sz="2250" b="1">
                 <a:solidFill>
                   <a:srgbClr val="000000"/>
@@ -11228,6 +11364,7 @@
           </a:p>
           <a:p xmlns:a="http://schemas.openxmlformats.org/drawingml/2006/main">
             <a:pPr algn="ctr">
+              <a:buNone/>
               <a:defRPr sz="2250" b="1">
                 <a:solidFill>
                   <a:srgbClr val="000000"/>
@@ -11251,6 +11388,7 @@
           </a:p>
           <a:p xmlns:a="http://schemas.openxmlformats.org/drawingml/2006/main">
             <a:pPr algn="ctr">
+              <a:buNone/>
               <a:defRPr sz="2250" b="1">
                 <a:solidFill>
                   <a:srgbClr val="000000"/>
@@ -11274,6 +11412,7 @@
           </a:p>
           <a:p xmlns:a="http://schemas.openxmlformats.org/drawingml/2006/main">
             <a:pPr algn="ctr">
+              <a:buNone/>
               <a:defRPr sz="2250" b="1">
                 <a:solidFill>
                   <a:srgbClr val="000000"/>
@@ -11297,6 +11436,7 @@
           </a:p>
           <a:p xmlns:a="http://schemas.openxmlformats.org/drawingml/2006/main">
             <a:pPr algn="ctr">
+              <a:buNone/>
               <a:defRPr sz="2250" b="1">
                 <a:solidFill>
                   <a:srgbClr val="000000"/>
@@ -11355,6 +11495,7 @@
           <a:lstStyle xmlns:a="http://schemas.openxmlformats.org/drawingml/2006/main"/>
           <a:p xmlns:a="http://schemas.openxmlformats.org/drawingml/2006/main">
             <a:pPr algn="ctr">
+              <a:buNone/>
               <a:defRPr sz="1575" b="1">
                 <a:solidFill>
                   <a:srgbClr val="000000"/>
@@ -11442,6 +11583,7 @@
           <a:lstStyle xmlns:a="http://schemas.openxmlformats.org/drawingml/2006/main"/>
           <a:p xmlns:a="http://schemas.openxmlformats.org/drawingml/2006/main">
             <a:pPr algn="l">
+              <a:buNone/>
               <a:defRPr sz="1050" b="1">
                 <a:solidFill>
                   <a:srgbClr val="5E6773"/>
@@ -11500,6 +11642,7 @@
           <a:lstStyle xmlns:a="http://schemas.openxmlformats.org/drawingml/2006/main"/>
           <a:p xmlns:a="http://schemas.openxmlformats.org/drawingml/2006/main">
             <a:pPr algn="l">
+              <a:buNone/>
               <a:defRPr sz="2850" b="1">
                 <a:solidFill>
                   <a:srgbClr val="000000"/>
@@ -11589,6 +11732,7 @@
           <a:lstStyle xmlns:a="http://schemas.openxmlformats.org/drawingml/2006/main"/>
           <a:p xmlns:a="http://schemas.openxmlformats.org/drawingml/2006/main">
             <a:pPr algn="r">
+              <a:buNone/>
               <a:defRPr sz="975" b="0">
                 <a:solidFill>
                   <a:srgbClr val="5E6773"/>
@@ -11647,6 +11791,7 @@
           <a:lstStyle xmlns:a="http://schemas.openxmlformats.org/drawingml/2006/main"/>
           <a:p xmlns:a="http://schemas.openxmlformats.org/drawingml/2006/main">
             <a:pPr algn="l">
+              <a:buNone/>
               <a:defRPr sz="1125" b="1">
                 <a:solidFill>
                   <a:srgbClr val="5E6773"/>
@@ -11705,6 +11850,7 @@
           <a:lstStyle xmlns:a="http://schemas.openxmlformats.org/drawingml/2006/main"/>
           <a:p xmlns:a="http://schemas.openxmlformats.org/drawingml/2006/main">
             <a:pPr algn="l">
+              <a:buNone/>
               <a:defRPr sz="1125" b="1">
                 <a:solidFill>
                   <a:srgbClr val="5E6773"/>
@@ -11763,6 +11909,7 @@
           <a:lstStyle xmlns:a="http://schemas.openxmlformats.org/drawingml/2006/main"/>
           <a:p xmlns:a="http://schemas.openxmlformats.org/drawingml/2006/main">
             <a:pPr algn="l">
+              <a:buNone/>
               <a:defRPr sz="1125" b="1">
                 <a:solidFill>
                   <a:srgbClr val="5E6773"/>
@@ -11852,6 +11999,7 @@
           <a:lstStyle xmlns:a="http://schemas.openxmlformats.org/drawingml/2006/main"/>
           <a:p xmlns:a="http://schemas.openxmlformats.org/drawingml/2006/main">
             <a:pPr algn="l">
+              <a:buNone/>
               <a:defRPr sz="1350" b="1">
                 <a:solidFill>
                   <a:srgbClr val="3D8DFF"/>
@@ -11910,6 +12058,7 @@
           <a:lstStyle xmlns:a="http://schemas.openxmlformats.org/drawingml/2006/main"/>
           <a:p xmlns:a="http://schemas.openxmlformats.org/drawingml/2006/main">
             <a:pPr algn="l">
+              <a:buNone/>
               <a:defRPr sz="1350" b="1">
                 <a:solidFill>
                   <a:srgbClr val="000000"/>
@@ -11968,6 +12117,7 @@
           <a:lstStyle xmlns:a="http://schemas.openxmlformats.org/drawingml/2006/main"/>
           <a:p xmlns:a="http://schemas.openxmlformats.org/drawingml/2006/main">
             <a:pPr algn="l">
+              <a:buNone/>
               <a:defRPr sz="1275" b="0">
                 <a:solidFill>
                   <a:srgbClr val="5E6773"/>
@@ -12057,6 +12207,7 @@
           <a:lstStyle xmlns:a="http://schemas.openxmlformats.org/drawingml/2006/main"/>
           <a:p xmlns:a="http://schemas.openxmlformats.org/drawingml/2006/main">
             <a:pPr algn="l">
+              <a:buNone/>
               <a:defRPr sz="1350" b="1">
                 <a:solidFill>
                   <a:srgbClr val="3D8DFF"/>
@@ -12115,6 +12266,7 @@
           <a:lstStyle xmlns:a="http://schemas.openxmlformats.org/drawingml/2006/main"/>
           <a:p xmlns:a="http://schemas.openxmlformats.org/drawingml/2006/main">
             <a:pPr algn="l">
+              <a:buNone/>
               <a:defRPr sz="1350" b="1">
                 <a:solidFill>
                   <a:srgbClr val="000000"/>
@@ -12173,6 +12325,7 @@
           <a:lstStyle xmlns:a="http://schemas.openxmlformats.org/drawingml/2006/main"/>
           <a:p xmlns:a="http://schemas.openxmlformats.org/drawingml/2006/main">
             <a:pPr algn="l">
+              <a:buNone/>
               <a:defRPr sz="1275" b="0">
                 <a:solidFill>
                   <a:srgbClr val="5E6773"/>
@@ -12262,6 +12415,7 @@
           <a:lstStyle xmlns:a="http://schemas.openxmlformats.org/drawingml/2006/main"/>
           <a:p xmlns:a="http://schemas.openxmlformats.org/drawingml/2006/main">
             <a:pPr algn="l">
+              <a:buNone/>
               <a:defRPr sz="1350" b="1">
                 <a:solidFill>
                   <a:srgbClr val="3D8DFF"/>
@@ -12320,6 +12474,7 @@
           <a:lstStyle xmlns:a="http://schemas.openxmlformats.org/drawingml/2006/main"/>
           <a:p xmlns:a="http://schemas.openxmlformats.org/drawingml/2006/main">
             <a:pPr algn="l">
+              <a:buNone/>
               <a:defRPr sz="1350" b="1">
                 <a:solidFill>
                   <a:srgbClr val="000000"/>
@@ -12378,6 +12533,7 @@
           <a:lstStyle xmlns:a="http://schemas.openxmlformats.org/drawingml/2006/main"/>
           <a:p xmlns:a="http://schemas.openxmlformats.org/drawingml/2006/main">
             <a:pPr algn="l">
+              <a:buNone/>
               <a:defRPr sz="1275" b="0">
                 <a:solidFill>
                   <a:srgbClr val="5E6773"/>
@@ -12467,6 +12623,7 @@
           <a:lstStyle xmlns:a="http://schemas.openxmlformats.org/drawingml/2006/main"/>
           <a:p xmlns:a="http://schemas.openxmlformats.org/drawingml/2006/main">
             <a:pPr algn="l">
+              <a:buNone/>
               <a:defRPr sz="1350" b="1">
                 <a:solidFill>
                   <a:srgbClr val="2F7D58"/>
@@ -12525,6 +12682,7 @@
           <a:lstStyle xmlns:a="http://schemas.openxmlformats.org/drawingml/2006/main"/>
           <a:p xmlns:a="http://schemas.openxmlformats.org/drawingml/2006/main">
             <a:pPr algn="l">
+              <a:buNone/>
               <a:defRPr sz="1350" b="1">
                 <a:solidFill>
                   <a:srgbClr val="000000"/>
@@ -12583,6 +12741,7 @@
           <a:lstStyle xmlns:a="http://schemas.openxmlformats.org/drawingml/2006/main"/>
           <a:p xmlns:a="http://schemas.openxmlformats.org/drawingml/2006/main">
             <a:pPr algn="l">
+              <a:buNone/>
               <a:defRPr sz="1275" b="0">
                 <a:solidFill>
                   <a:srgbClr val="5E6773"/>
@@ -12672,6 +12831,7 @@
           <a:lstStyle xmlns:a="http://schemas.openxmlformats.org/drawingml/2006/main"/>
           <a:p xmlns:a="http://schemas.openxmlformats.org/drawingml/2006/main">
             <a:pPr algn="l">
+              <a:buNone/>
               <a:defRPr sz="1350" b="1">
                 <a:solidFill>
                   <a:srgbClr val="2F7D58"/>
@@ -12730,6 +12890,7 @@
           <a:lstStyle xmlns:a="http://schemas.openxmlformats.org/drawingml/2006/main"/>
           <a:p xmlns:a="http://schemas.openxmlformats.org/drawingml/2006/main">
             <a:pPr algn="l">
+              <a:buNone/>
               <a:defRPr sz="1350" b="1">
                 <a:solidFill>
                   <a:srgbClr val="000000"/>
@@ -12788,6 +12949,7 @@
           <a:lstStyle xmlns:a="http://schemas.openxmlformats.org/drawingml/2006/main"/>
           <a:p xmlns:a="http://schemas.openxmlformats.org/drawingml/2006/main">
             <a:pPr algn="l">
+              <a:buNone/>
               <a:defRPr sz="1275" b="0">
                 <a:solidFill>
                   <a:srgbClr val="5E6773"/>
@@ -12877,6 +13039,7 @@
           <a:lstStyle xmlns:a="http://schemas.openxmlformats.org/drawingml/2006/main"/>
           <a:p xmlns:a="http://schemas.openxmlformats.org/drawingml/2006/main">
             <a:pPr algn="l">
+              <a:buNone/>
               <a:defRPr sz="1425" b="1">
                 <a:solidFill>
                   <a:srgbClr val="000000"/>
@@ -12964,6 +13127,7 @@
           <a:lstStyle xmlns:a="http://schemas.openxmlformats.org/drawingml/2006/main"/>
           <a:p xmlns:a="http://schemas.openxmlformats.org/drawingml/2006/main">
             <a:pPr algn="l">
+              <a:buNone/>
               <a:defRPr sz="1050" b="1">
                 <a:solidFill>
                   <a:srgbClr val="5E6773"/>
@@ -13022,6 +13186,7 @@
           <a:lstStyle xmlns:a="http://schemas.openxmlformats.org/drawingml/2006/main"/>
           <a:p xmlns:a="http://schemas.openxmlformats.org/drawingml/2006/main">
             <a:pPr algn="l">
+              <a:buNone/>
               <a:defRPr sz="2850" b="1">
                 <a:solidFill>
                   <a:srgbClr val="000000"/>
@@ -13111,6 +13276,7 @@
           <a:lstStyle xmlns:a="http://schemas.openxmlformats.org/drawingml/2006/main"/>
           <a:p xmlns:a="http://schemas.openxmlformats.org/drawingml/2006/main">
             <a:pPr algn="r">
+              <a:buNone/>
               <a:defRPr sz="975" b="0">
                 <a:solidFill>
                   <a:srgbClr val="5E6773"/>
@@ -13200,6 +13366,7 @@
           <a:lstStyle xmlns:a="http://schemas.openxmlformats.org/drawingml/2006/main"/>
           <a:p xmlns:a="http://schemas.openxmlformats.org/drawingml/2006/main">
             <a:pPr algn="l">
+              <a:buNone/>
               <a:defRPr sz="1125" b="1">
                 <a:solidFill>
                   <a:srgbClr val="5E6773"/>
@@ -13258,6 +13425,7 @@
           <a:lstStyle xmlns:a="http://schemas.openxmlformats.org/drawingml/2006/main"/>
           <a:p xmlns:a="http://schemas.openxmlformats.org/drawingml/2006/main">
             <a:pPr algn="ctr">
+              <a:buNone/>
               <a:defRPr sz="1725" b="1">
                 <a:solidFill>
                   <a:srgbClr val="000000"/>
@@ -13281,6 +13449,7 @@
           </a:p>
           <a:p xmlns:a="http://schemas.openxmlformats.org/drawingml/2006/main">
             <a:pPr algn="ctr">
+              <a:buNone/>
               <a:defRPr sz="1725" b="1">
                 <a:solidFill>
                   <a:srgbClr val="000000"/>
@@ -13370,6 +13539,7 @@
           <a:lstStyle xmlns:a="http://schemas.openxmlformats.org/drawingml/2006/main"/>
           <a:p xmlns:a="http://schemas.openxmlformats.org/drawingml/2006/main">
             <a:pPr algn="l">
+              <a:buNone/>
               <a:defRPr sz="1125" b="1">
                 <a:solidFill>
                   <a:srgbClr val="5E6773"/>
@@ -13428,6 +13598,7 @@
           <a:lstStyle xmlns:a="http://schemas.openxmlformats.org/drawingml/2006/main"/>
           <a:p xmlns:a="http://schemas.openxmlformats.org/drawingml/2006/main">
             <a:pPr algn="ctr">
+              <a:buNone/>
               <a:defRPr sz="1725" b="1">
                 <a:solidFill>
                   <a:srgbClr val="000000"/>
@@ -13451,6 +13622,7 @@
           </a:p>
           <a:p xmlns:a="http://schemas.openxmlformats.org/drawingml/2006/main">
             <a:pPr algn="ctr">
+              <a:buNone/>
               <a:defRPr sz="1725" b="1">
                 <a:solidFill>
                   <a:srgbClr val="000000"/>
@@ -13540,6 +13712,7 @@
           <a:lstStyle xmlns:a="http://schemas.openxmlformats.org/drawingml/2006/main"/>
           <a:p xmlns:a="http://schemas.openxmlformats.org/drawingml/2006/main">
             <a:pPr algn="l">
+              <a:buNone/>
               <a:defRPr sz="1125" b="1">
                 <a:solidFill>
                   <a:srgbClr val="3D8DFF"/>
@@ -13598,6 +13771,7 @@
           <a:lstStyle xmlns:a="http://schemas.openxmlformats.org/drawingml/2006/main"/>
           <a:p xmlns:a="http://schemas.openxmlformats.org/drawingml/2006/main">
             <a:pPr algn="ctr">
+              <a:buNone/>
               <a:defRPr sz="1725" b="1">
                 <a:solidFill>
                   <a:srgbClr val="000000"/>
@@ -13621,6 +13795,7 @@
           </a:p>
           <a:p xmlns:a="http://schemas.openxmlformats.org/drawingml/2006/main">
             <a:pPr algn="ctr">
+              <a:buNone/>
               <a:defRPr sz="1725" b="1">
                 <a:solidFill>
                   <a:srgbClr val="000000"/>
@@ -13710,6 +13885,7 @@
           <a:lstStyle xmlns:a="http://schemas.openxmlformats.org/drawingml/2006/main"/>
           <a:p xmlns:a="http://schemas.openxmlformats.org/drawingml/2006/main">
             <a:pPr algn="l">
+              <a:buNone/>
               <a:defRPr sz="1125" b="1">
                 <a:solidFill>
                   <a:srgbClr val="5E6773"/>
@@ -13768,6 +13944,7 @@
           <a:lstStyle xmlns:a="http://schemas.openxmlformats.org/drawingml/2006/main"/>
           <a:p xmlns:a="http://schemas.openxmlformats.org/drawingml/2006/main">
             <a:pPr algn="ctr">
+              <a:buNone/>
               <a:defRPr sz="1725" b="1">
                 <a:solidFill>
                   <a:srgbClr val="000000"/>
@@ -13791,6 +13968,7 @@
           </a:p>
           <a:p xmlns:a="http://schemas.openxmlformats.org/drawingml/2006/main">
             <a:pPr algn="ctr">
+              <a:buNone/>
               <a:defRPr sz="1725" b="1">
                 <a:solidFill>
                   <a:srgbClr val="000000"/>
@@ -13880,6 +14058,7 @@
           <a:lstStyle xmlns:a="http://schemas.openxmlformats.org/drawingml/2006/main"/>
           <a:p xmlns:a="http://schemas.openxmlformats.org/drawingml/2006/main">
             <a:pPr algn="l">
+              <a:buNone/>
               <a:defRPr sz="1125" b="1">
                 <a:solidFill>
                   <a:srgbClr val="5E6773"/>
@@ -13938,6 +14117,7 @@
           <a:lstStyle xmlns:a="http://schemas.openxmlformats.org/drawingml/2006/main"/>
           <a:p xmlns:a="http://schemas.openxmlformats.org/drawingml/2006/main">
             <a:pPr algn="ctr">
+              <a:buNone/>
               <a:defRPr sz="1725" b="1">
                 <a:solidFill>
                   <a:srgbClr val="000000"/>
@@ -13961,6 +14141,7 @@
           </a:p>
           <a:p xmlns:a="http://schemas.openxmlformats.org/drawingml/2006/main">
             <a:pPr algn="ctr">
+              <a:buNone/>
               <a:defRPr sz="1725" b="1">
                 <a:solidFill>
                   <a:srgbClr val="000000"/>
@@ -14019,6 +14200,7 @@
           <a:lstStyle xmlns:a="http://schemas.openxmlformats.org/drawingml/2006/main"/>
           <a:p xmlns:a="http://schemas.openxmlformats.org/drawingml/2006/main">
             <a:pPr algn="l">
+              <a:buNone/>
               <a:defRPr sz="1575" b="1">
                 <a:solidFill>
                   <a:srgbClr val="000000"/>

</xml_diff>

<commit_message>
Close review gaps and strengthen evaluation
</commit_message>
<xml_diff>
--- a/presentation/LedgerPilot_Assignment_Deck.pptx
+++ b/presentation/LedgerPilot_Assignment_Deck.pptx
@@ -2,24 +2,24 @@
 <file path=ppt/presentation.xml><?xml version="1.0" encoding="utf-8"?>
 <p:presentation xmlns:p="http://schemas.openxmlformats.org/presentationml/2006/main">
   <p:sldMasterIdLst>
-    <p:sldMasterId xmlns:r="http://schemas.openxmlformats.org/officeDocument/2006/relationships" id="2147483648" r:id="Rf5773d6313f045fa"/>
+    <p:sldMasterId xmlns:r="http://schemas.openxmlformats.org/officeDocument/2006/relationships" id="2147483648" r:id="Rbd2cb8e19eee45df"/>
   </p:sldMasterIdLst>
   <p:notesMasterIdLst>
-    <p:notesMasterId xmlns:r="http://schemas.openxmlformats.org/officeDocument/2006/relationships" r:id="R8be14cdb30df4aae"/>
+    <p:notesMasterId xmlns:r="http://schemas.openxmlformats.org/officeDocument/2006/relationships" r:id="Rc260ec79f0374a38"/>
   </p:notesMasterIdLst>
   <p:sldIdLst>
-    <p:sldId xmlns:r="http://schemas.openxmlformats.org/officeDocument/2006/relationships" id="256" r:id="Rf9baf3b98d9d433e"/>
-    <p:sldId xmlns:r="http://schemas.openxmlformats.org/officeDocument/2006/relationships" id="257" r:id="Re430cc526797406f"/>
-    <p:sldId xmlns:r="http://schemas.openxmlformats.org/officeDocument/2006/relationships" id="258" r:id="Rbbce57e443724043"/>
-    <p:sldId xmlns:r="http://schemas.openxmlformats.org/officeDocument/2006/relationships" id="259" r:id="Ra92fae650c104963"/>
-    <p:sldId xmlns:r="http://schemas.openxmlformats.org/officeDocument/2006/relationships" id="260" r:id="Ree340e8c3b9b4c4f"/>
-    <p:sldId xmlns:r="http://schemas.openxmlformats.org/officeDocument/2006/relationships" id="261" r:id="Rd83d302ea59942db"/>
-    <p:sldId xmlns:r="http://schemas.openxmlformats.org/officeDocument/2006/relationships" id="262" r:id="R76ef13ae759e4f95"/>
-    <p:sldId xmlns:r="http://schemas.openxmlformats.org/officeDocument/2006/relationships" id="263" r:id="R0988c7ce6fa2454a"/>
-    <p:sldId xmlns:r="http://schemas.openxmlformats.org/officeDocument/2006/relationships" id="264" r:id="Rbc5db942f91e4db8"/>
-    <p:sldId xmlns:r="http://schemas.openxmlformats.org/officeDocument/2006/relationships" id="265" r:id="R5ab7c48f43a84b9b"/>
-    <p:sldId xmlns:r="http://schemas.openxmlformats.org/officeDocument/2006/relationships" id="266" r:id="R9ef02e9916004cb2"/>
-    <p:sldId xmlns:r="http://schemas.openxmlformats.org/officeDocument/2006/relationships" id="267" r:id="R6d409656237c4201"/>
+    <p:sldId xmlns:r="http://schemas.openxmlformats.org/officeDocument/2006/relationships" id="256" r:id="Rfe8000e77c1f4b11"/>
+    <p:sldId xmlns:r="http://schemas.openxmlformats.org/officeDocument/2006/relationships" id="257" r:id="R56c17a4b731a47b0"/>
+    <p:sldId xmlns:r="http://schemas.openxmlformats.org/officeDocument/2006/relationships" id="258" r:id="Rcc621dd5e0344d45"/>
+    <p:sldId xmlns:r="http://schemas.openxmlformats.org/officeDocument/2006/relationships" id="259" r:id="R82ae7f20b9eb499e"/>
+    <p:sldId xmlns:r="http://schemas.openxmlformats.org/officeDocument/2006/relationships" id="260" r:id="R26b94abe2c914b17"/>
+    <p:sldId xmlns:r="http://schemas.openxmlformats.org/officeDocument/2006/relationships" id="261" r:id="R228cf1d02e474a08"/>
+    <p:sldId xmlns:r="http://schemas.openxmlformats.org/officeDocument/2006/relationships" id="262" r:id="Rfd8c94f3d28e4030"/>
+    <p:sldId xmlns:r="http://schemas.openxmlformats.org/officeDocument/2006/relationships" id="263" r:id="Rca6bca1f4830437d"/>
+    <p:sldId xmlns:r="http://schemas.openxmlformats.org/officeDocument/2006/relationships" id="264" r:id="Ra3e64c3effb6479b"/>
+    <p:sldId xmlns:r="http://schemas.openxmlformats.org/officeDocument/2006/relationships" id="265" r:id="Rce0a70f8e3984cb9"/>
+    <p:sldId xmlns:r="http://schemas.openxmlformats.org/officeDocument/2006/relationships" id="266" r:id="Rfaa8187cf21e4ea0"/>
+    <p:sldId xmlns:r="http://schemas.openxmlformats.org/officeDocument/2006/relationships" id="267" r:id="Rccb81db7f623494d"/>
   </p:sldIdLst>
   <p:sldSz cx="12192000" cy="6858000"/>
   <p:notesSz cx="6858000" cy="9144000"/>
@@ -543,7 +543,7 @@
           <a:lstStyle xmlns:a="http://schemas.openxmlformats.org/drawingml/2006/main"/>
           <a:p xmlns:a="http://schemas.openxmlformats.org/drawingml/2006/main">
             <a:r>
-              <a:t>The 100% figures are controlled-fixture results, not production estimates. Call out the zero false-auto-post rate and the need for a permissioned pilot.</a:t>
+              <a:t>The 100% figures are controlled-fixture results, not production estimates. Call out the zero false-auto-post rate, forced Docling path, and the need for a permissioned pilot.</a:t>
             </a:r>
           </a:p>
           <a:p xmlns:a="http://schemas.openxmlformats.org/drawingml/2006/main">
@@ -558,7 +558,12 @@
           </a:p>
           <a:p xmlns:a="http://schemas.openxmlformats.org/drawingml/2006/main">
             <a:r>
-              <a:t>- evaluation/results/latest.json — generated six-document metrics.</a:t>
+              <a:t>- evaluation/results/latest.json — generated seven-document metrics.</a:t>
+            </a:r>
+          </a:p>
+          <a:p xmlns:a="http://schemas.openxmlformats.org/drawingml/2006/main">
+            <a:r>
+              <a:t>- evaluation/results/rag-latest.json — labeled retrieval precision and recall.</a:t>
             </a:r>
           </a:p>
           <a:p xmlns:a="http://schemas.openxmlformats.org/drawingml/2006/main">
@@ -633,7 +638,7 @@
           <a:lstStyle xmlns:a="http://schemas.openxmlformats.org/drawingml/2006/main"/>
           <a:p xmlns:a="http://schemas.openxmlformats.org/drawingml/2006/main">
             <a:r>
-              <a:t>The demo path is intentionally short enough for a technical review while the optional services remain available.</a:t>
+              <a:t>The demo path is intentionally short enough for a technical review. It demonstrates automatic posting eligibility and a retry with the same idempotency key.</a:t>
             </a:r>
           </a:p>
           <a:p xmlns:a="http://schemas.openxmlformats.org/drawingml/2006/main">
@@ -658,7 +663,7 @@
           </a:p>
           <a:p xmlns:a="http://schemas.openxmlformats.org/drawingml/2006/main">
             <a:r>
-              <a:t>- scripts/demo.ps1 — AP happy-path demo.</a:t>
+              <a:t>- scripts/demo.ps1 — AP happy-path and idempotent replay demo.</a:t>
             </a:r>
           </a:p>
         </p:txBody>
@@ -1088,7 +1093,7 @@
           <a:lstStyle xmlns:a="http://schemas.openxmlformats.org/drawingml/2006/main"/>
           <a:p xmlns:a="http://schemas.openxmlformats.org/drawingml/2006/main">
             <a:r>
-              <a:t>The boundary test makes the policy precise: equal to the tolerance passes, exceeding it fails.</a:t>
+              <a:t>The boundary test makes the policy precise: equal to the tolerance passes, exceeding it fails. Partial quantities, line arithmetic, and tax/freight reconciliation are also deterministic.</a:t>
             </a:r>
           </a:p>
           <a:p xmlns:a="http://schemas.openxmlformats.org/drawingml/2006/main">
@@ -1103,12 +1108,12 @@
           </a:p>
           <a:p xmlns:a="http://schemas.openxmlformats.org/drawingml/2006/main">
             <a:r>
-              <a:t>- app/matching.py — tolerance and variance logic.</a:t>
-            </a:r>
-          </a:p>
-          <a:p xmlns:a="http://schemas.openxmlformats.org/drawingml/2006/main">
-            <a:r>
-              <a:t>- tests/test_matching.py — exact boundary and outside-boundary tests.</a:t>
+              <a:t>- app/matching.py — tolerance, arithmetic, partial-invoice, and reconciliation logic.</a:t>
+            </a:r>
+          </a:p>
+          <a:p xmlns:a="http://schemas.openxmlformats.org/drawingml/2006/main">
+            <a:r>
+              <a:t>- tests/test_matching.py — boundary, partial, arithmetic, and tax tests.</a:t>
             </a:r>
           </a:p>
           <a:p xmlns:a="http://schemas.openxmlformats.org/drawingml/2006/main">
@@ -1183,7 +1188,7 @@
           <a:lstStyle xmlns:a="http://schemas.openxmlformats.org/drawingml/2006/main"/>
           <a:p xmlns:a="http://schemas.openxmlformats.org/drawingml/2006/main">
             <a:r>
-              <a:t>Explain that the original mismatch remains visible after approval.</a:t>
+              <a:t>Explain that the original mismatch remains visible after approval. The demo accepts a supplied actor string; production deployment must bind that actor to authenticated RBAC identity.</a:t>
             </a:r>
           </a:p>
           <a:p xmlns:a="http://schemas.openxmlformats.org/drawingml/2006/main">
@@ -1208,7 +1213,7 @@
           </a:p>
           <a:p xmlns:a="http://schemas.openxmlformats.org/drawingml/2006/main">
             <a:r>
-              <a:t>- docs/security-and-controls.md — control posture.</a:t>
+              <a:t>- docs/security-and-controls.md — control posture and identity limitation.</a:t>
             </a:r>
           </a:p>
         </p:txBody>
@@ -1468,7 +1473,7 @@
           <a:lstStyle xmlns:a="http://schemas.openxmlformats.org/drawingml/2006/main"/>
           <a:p xmlns:a="http://schemas.openxmlformats.org/drawingml/2006/main">
             <a:r>
-              <a:t>Point to code or deployment evidence for every row of the assignment's technology table.</a:t>
+              <a:t>Point to code or deployment evidence for every row of the assignment's technology table. LlamaIndex performs real ranking and the labeled policy set is scored with RAGAS.</a:t>
             </a:r>
           </a:p>
           <a:p xmlns:a="http://schemas.openxmlformats.org/drawingml/2006/main">
@@ -1488,12 +1493,12 @@
           </a:p>
           <a:p xmlns:a="http://schemas.openxmlformats.org/drawingml/2006/main">
             <a:r>
-              <a:t>- pyproject.toml — pinned Python dependencies.</a:t>
-            </a:r>
-          </a:p>
-          <a:p xmlns:a="http://schemas.openxmlformats.org/drawingml/2006/main">
-            <a:r>
-              <a:t>- docker-compose.yml — PostgreSQL, Ollama, and Phoenix services.</a:t>
+              <a:t>- pyproject.toml; app/context.py — pinned dependencies and retrieval implementation.</a:t>
+            </a:r>
+          </a:p>
+          <a:p xmlns:a="http://schemas.openxmlformats.org/drawingml/2006/main">
+            <a:r>
+              <a:t>- evaluation/results/rag-latest.json; docker-compose.yml.</a:t>
             </a:r>
           </a:p>
         </p:txBody>
@@ -1561,7 +1566,7 @@
   </p:cSld>
   <p:clrMap bg1="lt1" tx1="dk1" bg2="lt2" tx2="dk2" accent1="accent1" accent2="accent2" accent3="accent3" accent4="accent4" accent5="accent5" accent6="accent6" hlink="hlink" folHlink="folHlink"/>
   <p:sldLayoutIdLst>
-    <p:sldLayoutId xmlns:r="http://schemas.openxmlformats.org/officeDocument/2006/relationships" id="2147483649" r:id="R87f8d3d6ee504aea"/>
+    <p:sldLayoutId xmlns:r="http://schemas.openxmlformats.org/officeDocument/2006/relationships" id="2147483649" r:id="Rc2fba6f38f2046ba"/>
   </p:sldLayoutIdLst>
   <p:txStyles>
     <p:titleStyle>
@@ -2383,7 +2388,7 @@
           <p:nvPr/>
         </p:nvPicPr>
         <p:blipFill>
-          <a:blip xmlns:r="http://schemas.openxmlformats.org/officeDocument/2006/relationships" xmlns:a="http://schemas.openxmlformats.org/drawingml/2006/main" r:embed="R253d26adb28041d3"/>
+          <a:blip xmlns:r="http://schemas.openxmlformats.org/officeDocument/2006/relationships" xmlns:a="http://schemas.openxmlformats.org/drawingml/2006/main" r:embed="Rfc648dc9e80e4de2"/>
           <a:srcRect xmlns:a="http://schemas.openxmlformats.org/drawingml/2006/main" l="0" t="9434" r="0" b="9434"/>
           <a:stretch xmlns:a="http://schemas.openxmlformats.org/drawingml/2006/main">
             <a:fillRect l="0" t="0" r="0" b="0"/>
@@ -2751,7 +2756,7 @@
                 <a:ea typeface="Arial"/>
                 <a:cs typeface="Arial"/>
               </a:rPr>
-              <a:t>Six synthetic cases span JSON, text-native PDF, and scan-like PNG: three clean and three controlled exceptions.</a:t>
+              <a:t>Seven synthetic cases span JSON, PDF, PNG, and forced Docling HTML: four clean and three controlled exceptions.</a:t>
             </a:r>
           </a:p>
         </p:txBody>
@@ -2924,7 +2929,7 @@
                 <a:ea typeface="Arial"/>
                 <a:cs typeface="Arial"/>
               </a:rPr>
-              <a:t>30 / 30 labels</a:t>
+              <a:t>35 / 35 labels</a:t>
             </a:r>
           </a:p>
         </p:txBody>
@@ -3097,7 +3102,7 @@
                 <a:ea typeface="Arial"/>
                 <a:cs typeface="Arial"/>
               </a:rPr>
-              <a:t>6 / 6 documents</a:t>
+              <a:t>7 / 7 documents</a:t>
             </a:r>
           </a:p>
         </p:txBody>
@@ -3187,7 +3192,7 @@
                 <a:ea typeface="Arial"/>
                 <a:cs typeface="Arial"/>
               </a:rPr>
-              <a:t>50%</a:t>
+              <a:t>57%</a:t>
             </a:r>
           </a:p>
         </p:txBody>
@@ -3270,7 +3275,7 @@
                 <a:ea typeface="Arial"/>
                 <a:cs typeface="Arial"/>
               </a:rPr>
-              <a:t>3 / 6 documents</a:t>
+              <a:t>4 / 7 documents</a:t>
             </a:r>
           </a:p>
         </p:txBody>
@@ -3329,7 +3334,7 @@
                 <a:ea typeface="Arial"/>
                 <a:cs typeface="Arial"/>
               </a:rPr>
-              <a:t>Next gate: ≥500 permissioned invoices, stratified by vendor, scan quality, language, and line count—plus false-STP and reconciliation metrics.</a:t>
+              <a:t>RAGAS retrieval: 100% precision + recall on 4 labeled queries. Next gate: ≥500 permissioned invoices across vendors and scan quality.</a:t>
             </a:r>
           </a:p>
         </p:txBody>
@@ -4065,7 +4070,7 @@
                 <a:ea typeface="Arial"/>
                 <a:cs typeface="Arial"/>
               </a:rPr>
-              <a:t>11 tests · multi-format eval</a:t>
+              <a:t>21 tests · 7-doc + RAGAS eval</a:t>
             </a:r>
           </a:p>
         </p:txBody>
@@ -4275,7 +4280,7 @@
                 <a:ea typeface="Arial"/>
                 <a:cs typeface="Arial"/>
               </a:rPr>
-              <a:t>ingest → match → post</a:t>
+              <a:t>ingest → match → auto-post</a:t>
             </a:r>
           </a:p>
           <a:p xmlns:a="http://schemas.openxmlformats.org/drawingml/2006/main">
@@ -4299,7 +4304,7 @@
                 <a:ea typeface="Arial"/>
                 <a:cs typeface="Arial"/>
               </a:rPr>
-              <a:t>then inspect audit chain</a:t>
+              <a:t>replay safely → inspect audit</a:t>
             </a:r>
           </a:p>
         </p:txBody>
@@ -9152,7 +9157,7 @@
                 <a:ea typeface="Arial"/>
                 <a:cs typeface="Arial"/>
               </a:rPr>
-              <a:t>Vendor · currency · line mapping · unit price · ordered quantity · total · duplicate</a:t>
+              <a:t>Vendor · currency · line mapping · unit price · partial quantity · arithmetic · tax / freight · duplicate</a:t>
             </a:r>
           </a:p>
         </p:txBody>
@@ -10370,7 +10375,7 @@
                 <a:ea typeface="Arial"/>
                 <a:cs typeface="Arial"/>
               </a:rPr>
-              <a:t>PRICE / QUANTITY VARIANCE</a:t>
+              <a:t>PRICE / QTY / ARITHMETIC</a:t>
             </a:r>
           </a:p>
         </p:txBody>
@@ -10727,7 +10732,7 @@
                 <a:ea typeface="Arial"/>
                 <a:cs typeface="Arial"/>
               </a:rPr>
-              <a:t>Actor + comment → immutable audit event</a:t>
+              <a:t>Supplied actor + comment → immutable audit event</a:t>
             </a:r>
           </a:p>
         </p:txBody>
@@ -14112,7 +14117,7 @@
         </p:spPr>
         <p:txBody>
           <a:bodyPr xmlns:a="http://schemas.openxmlformats.org/drawingml/2006/main" wrap="square" lIns="0" tIns="0" rIns="0" bIns="0" anchor="ctr">
-            <a:normAutofit fontScale="100000"/>
+            <a:normAutofit fontScale="97746"/>
           </a:bodyPr>
           <a:lstStyle xmlns:a="http://schemas.openxmlformats.org/drawingml/2006/main"/>
           <a:p xmlns:a="http://schemas.openxmlformats.org/drawingml/2006/main">
@@ -14136,7 +14141,7 @@
                 <a:ea typeface="Arial"/>
                 <a:cs typeface="Arial"/>
               </a:rPr>
-              <a:t>RAGAS + custom metrics</a:t>
+              <a:t>RAGAS retrieval metrics</a:t>
             </a:r>
           </a:p>
           <a:p xmlns:a="http://schemas.openxmlformats.org/drawingml/2006/main">

</xml_diff>

<commit_message>
Polish AR exception visibility and controls
</commit_message>
<xml_diff>
--- a/presentation/LedgerPilot_Assignment_Deck.pptx
+++ b/presentation/LedgerPilot_Assignment_Deck.pptx
@@ -2,24 +2,24 @@
 <file path=ppt/presentation.xml><?xml version="1.0" encoding="utf-8"?>
 <p:presentation xmlns:p="http://schemas.openxmlformats.org/presentationml/2006/main">
   <p:sldMasterIdLst>
-    <p:sldMasterId xmlns:r="http://schemas.openxmlformats.org/officeDocument/2006/relationships" id="2147483648" r:id="Rbd2cb8e19eee45df"/>
+    <p:sldMasterId xmlns:r="http://schemas.openxmlformats.org/officeDocument/2006/relationships" id="2147483648" r:id="R8be4a033ff6f48cd"/>
   </p:sldMasterIdLst>
   <p:notesMasterIdLst>
-    <p:notesMasterId xmlns:r="http://schemas.openxmlformats.org/officeDocument/2006/relationships" r:id="Rc260ec79f0374a38"/>
+    <p:notesMasterId xmlns:r="http://schemas.openxmlformats.org/officeDocument/2006/relationships" r:id="Rcd42a70c30ba417a"/>
   </p:notesMasterIdLst>
   <p:sldIdLst>
-    <p:sldId xmlns:r="http://schemas.openxmlformats.org/officeDocument/2006/relationships" id="256" r:id="Rfe8000e77c1f4b11"/>
-    <p:sldId xmlns:r="http://schemas.openxmlformats.org/officeDocument/2006/relationships" id="257" r:id="R56c17a4b731a47b0"/>
-    <p:sldId xmlns:r="http://schemas.openxmlformats.org/officeDocument/2006/relationships" id="258" r:id="Rcc621dd5e0344d45"/>
-    <p:sldId xmlns:r="http://schemas.openxmlformats.org/officeDocument/2006/relationships" id="259" r:id="R82ae7f20b9eb499e"/>
-    <p:sldId xmlns:r="http://schemas.openxmlformats.org/officeDocument/2006/relationships" id="260" r:id="R26b94abe2c914b17"/>
-    <p:sldId xmlns:r="http://schemas.openxmlformats.org/officeDocument/2006/relationships" id="261" r:id="R228cf1d02e474a08"/>
-    <p:sldId xmlns:r="http://schemas.openxmlformats.org/officeDocument/2006/relationships" id="262" r:id="Rfd8c94f3d28e4030"/>
-    <p:sldId xmlns:r="http://schemas.openxmlformats.org/officeDocument/2006/relationships" id="263" r:id="Rca6bca1f4830437d"/>
-    <p:sldId xmlns:r="http://schemas.openxmlformats.org/officeDocument/2006/relationships" id="264" r:id="Ra3e64c3effb6479b"/>
-    <p:sldId xmlns:r="http://schemas.openxmlformats.org/officeDocument/2006/relationships" id="265" r:id="Rce0a70f8e3984cb9"/>
-    <p:sldId xmlns:r="http://schemas.openxmlformats.org/officeDocument/2006/relationships" id="266" r:id="Rfaa8187cf21e4ea0"/>
-    <p:sldId xmlns:r="http://schemas.openxmlformats.org/officeDocument/2006/relationships" id="267" r:id="Rccb81db7f623494d"/>
+    <p:sldId xmlns:r="http://schemas.openxmlformats.org/officeDocument/2006/relationships" id="256" r:id="R31d0b0e6b8954767"/>
+    <p:sldId xmlns:r="http://schemas.openxmlformats.org/officeDocument/2006/relationships" id="257" r:id="R566d228a75c04b40"/>
+    <p:sldId xmlns:r="http://schemas.openxmlformats.org/officeDocument/2006/relationships" id="258" r:id="R2d08aac2ffb7440c"/>
+    <p:sldId xmlns:r="http://schemas.openxmlformats.org/officeDocument/2006/relationships" id="259" r:id="Rf08f2ca0fd0b459e"/>
+    <p:sldId xmlns:r="http://schemas.openxmlformats.org/officeDocument/2006/relationships" id="260" r:id="Re2855aef7c67446f"/>
+    <p:sldId xmlns:r="http://schemas.openxmlformats.org/officeDocument/2006/relationships" id="261" r:id="R9705b5ee98d74f10"/>
+    <p:sldId xmlns:r="http://schemas.openxmlformats.org/officeDocument/2006/relationships" id="262" r:id="R1f94814b2dc44adc"/>
+    <p:sldId xmlns:r="http://schemas.openxmlformats.org/officeDocument/2006/relationships" id="263" r:id="R764990d6f63e4697"/>
+    <p:sldId xmlns:r="http://schemas.openxmlformats.org/officeDocument/2006/relationships" id="264" r:id="R299ca11f78c74b90"/>
+    <p:sldId xmlns:r="http://schemas.openxmlformats.org/officeDocument/2006/relationships" id="265" r:id="R97ae8761dd7f4c3f"/>
+    <p:sldId xmlns:r="http://schemas.openxmlformats.org/officeDocument/2006/relationships" id="266" r:id="Re84a504da26f4c47"/>
+    <p:sldId xmlns:r="http://schemas.openxmlformats.org/officeDocument/2006/relationships" id="267" r:id="Rb4004625c736442f"/>
   </p:sldIdLst>
   <p:sldSz cx="12192000" cy="6858000"/>
   <p:notesSz cx="6858000" cy="9144000"/>
@@ -1566,7 +1566,7 @@
   </p:cSld>
   <p:clrMap bg1="lt1" tx1="dk1" bg2="lt2" tx2="dk2" accent1="accent1" accent2="accent2" accent3="accent3" accent4="accent4" accent5="accent5" accent6="accent6" hlink="hlink" folHlink="folHlink"/>
   <p:sldLayoutIdLst>
-    <p:sldLayoutId xmlns:r="http://schemas.openxmlformats.org/officeDocument/2006/relationships" id="2147483649" r:id="Rc2fba6f38f2046ba"/>
+    <p:sldLayoutId xmlns:r="http://schemas.openxmlformats.org/officeDocument/2006/relationships" id="2147483649" r:id="Ra4ae60825fb0451d"/>
   </p:sldLayoutIdLst>
   <p:txStyles>
     <p:titleStyle>
@@ -2388,7 +2388,7 @@
           <p:nvPr/>
         </p:nvPicPr>
         <p:blipFill>
-          <a:blip xmlns:r="http://schemas.openxmlformats.org/officeDocument/2006/relationships" xmlns:a="http://schemas.openxmlformats.org/drawingml/2006/main" r:embed="Rfc648dc9e80e4de2"/>
+          <a:blip xmlns:r="http://schemas.openxmlformats.org/officeDocument/2006/relationships" xmlns:a="http://schemas.openxmlformats.org/drawingml/2006/main" r:embed="R032193fd666d4e70"/>
           <a:srcRect xmlns:a="http://schemas.openxmlformats.org/drawingml/2006/main" l="0" t="9434" r="0" b="9434"/>
           <a:stretch xmlns:a="http://schemas.openxmlformats.org/drawingml/2006/main">
             <a:fillRect l="0" t="0" r="0" b="0"/>
@@ -4070,7 +4070,18 @@
                 <a:ea typeface="Arial"/>
                 <a:cs typeface="Arial"/>
               </a:rPr>
-              <a:t>21 tests · 7-doc + RAGAS eval</a:t>
+              <a:t>25 tests</a:t>
+            </a:r>
+            <a:r>
+              <a:rPr sz="1425" b="0">
+                <a:solidFill>
+                  <a:srgbClr val="5E6773"/>
+                </a:solidFill>
+                <a:latin typeface="Arial"/>
+                <a:ea typeface="Arial"/>
+                <a:cs typeface="Arial"/>
+              </a:rPr>
+              <a:t> · 7-doc + RAGAS eval</a:t>
             </a:r>
           </a:p>
         </p:txBody>
@@ -10914,7 +10925,7 @@
         </p:spPr>
         <p:txBody>
           <a:bodyPr xmlns:a="http://schemas.openxmlformats.org/drawingml/2006/main" wrap="square" lIns="0" tIns="0" rIns="0" bIns="0" anchor="t">
-            <a:normAutofit fontScale="93680"/>
+            <a:normAutofit fontScale="100000"/>
           </a:bodyPr>
           <a:lstStyle xmlns:a="http://schemas.openxmlformats.org/drawingml/2006/main"/>
           <a:p xmlns:a="http://schemas.openxmlformats.org/drawingml/2006/main">
@@ -10938,7 +10949,7 @@
                 <a:ea typeface="Arial"/>
                 <a:cs typeface="Arial"/>
               </a:rPr>
-              <a:t>The same governed pattern applies incoming cash to open AR items</a:t>
+              <a:t>The AR path mirrors the business outcome for incoming cash</a:t>
             </a:r>
           </a:p>
         </p:txBody>
@@ -11519,7 +11530,7 @@
                 <a:ea typeface="Arial"/>
                 <a:cs typeface="Arial"/>
               </a:rPr>
-              <a:t>Shared controls: source traceability · exact amount/currency · exception routing · idempotent external action</a:t>
+              <a:t>AR controls: source reference · exact customer/amount · exception visibility · audited application result</a:t>
             </a:r>
           </a:p>
         </p:txBody>
@@ -13063,7 +13074,7 @@
                 <a:ea typeface="Arial"/>
                 <a:cs typeface="Arial"/>
               </a:rPr>
-              <a:t>Additional endpoints cover mailbox polling, exception decisions, review queue, and AR remittance ingestion.</a:t>
+              <a:t>Additional endpoints cover mailbox polling, AP exception decisions, review queues, and AR remittance processing.</a:t>
             </a:r>
           </a:p>
         </p:txBody>

</xml_diff>

<commit_message>
Enforce AR currency matching
</commit_message>
<xml_diff>
--- a/presentation/LedgerPilot_Assignment_Deck.pptx
+++ b/presentation/LedgerPilot_Assignment_Deck.pptx
@@ -2,24 +2,24 @@
 <file path=ppt/presentation.xml><?xml version="1.0" encoding="utf-8"?>
 <p:presentation xmlns:p="http://schemas.openxmlformats.org/presentationml/2006/main">
   <p:sldMasterIdLst>
-    <p:sldMasterId xmlns:r="http://schemas.openxmlformats.org/officeDocument/2006/relationships" id="2147483648" r:id="R8be4a033ff6f48cd"/>
+    <p:sldMasterId xmlns:r="http://schemas.openxmlformats.org/officeDocument/2006/relationships" id="2147483648" r:id="R77ce58e2c9a0474b"/>
   </p:sldMasterIdLst>
   <p:notesMasterIdLst>
-    <p:notesMasterId xmlns:r="http://schemas.openxmlformats.org/officeDocument/2006/relationships" r:id="Rcd42a70c30ba417a"/>
+    <p:notesMasterId xmlns:r="http://schemas.openxmlformats.org/officeDocument/2006/relationships" r:id="R98e165cc60984833"/>
   </p:notesMasterIdLst>
   <p:sldIdLst>
-    <p:sldId xmlns:r="http://schemas.openxmlformats.org/officeDocument/2006/relationships" id="256" r:id="R31d0b0e6b8954767"/>
-    <p:sldId xmlns:r="http://schemas.openxmlformats.org/officeDocument/2006/relationships" id="257" r:id="R566d228a75c04b40"/>
-    <p:sldId xmlns:r="http://schemas.openxmlformats.org/officeDocument/2006/relationships" id="258" r:id="R2d08aac2ffb7440c"/>
-    <p:sldId xmlns:r="http://schemas.openxmlformats.org/officeDocument/2006/relationships" id="259" r:id="Rf08f2ca0fd0b459e"/>
-    <p:sldId xmlns:r="http://schemas.openxmlformats.org/officeDocument/2006/relationships" id="260" r:id="Re2855aef7c67446f"/>
-    <p:sldId xmlns:r="http://schemas.openxmlformats.org/officeDocument/2006/relationships" id="261" r:id="R9705b5ee98d74f10"/>
-    <p:sldId xmlns:r="http://schemas.openxmlformats.org/officeDocument/2006/relationships" id="262" r:id="R1f94814b2dc44adc"/>
-    <p:sldId xmlns:r="http://schemas.openxmlformats.org/officeDocument/2006/relationships" id="263" r:id="R764990d6f63e4697"/>
-    <p:sldId xmlns:r="http://schemas.openxmlformats.org/officeDocument/2006/relationships" id="264" r:id="R299ca11f78c74b90"/>
-    <p:sldId xmlns:r="http://schemas.openxmlformats.org/officeDocument/2006/relationships" id="265" r:id="R97ae8761dd7f4c3f"/>
-    <p:sldId xmlns:r="http://schemas.openxmlformats.org/officeDocument/2006/relationships" id="266" r:id="Re84a504da26f4c47"/>
-    <p:sldId xmlns:r="http://schemas.openxmlformats.org/officeDocument/2006/relationships" id="267" r:id="Rb4004625c736442f"/>
+    <p:sldId xmlns:r="http://schemas.openxmlformats.org/officeDocument/2006/relationships" id="256" r:id="Re8f84ab8b0174efa"/>
+    <p:sldId xmlns:r="http://schemas.openxmlformats.org/officeDocument/2006/relationships" id="257" r:id="R89b2e3571f3747b5"/>
+    <p:sldId xmlns:r="http://schemas.openxmlformats.org/officeDocument/2006/relationships" id="258" r:id="Rbe9089fee7234336"/>
+    <p:sldId xmlns:r="http://schemas.openxmlformats.org/officeDocument/2006/relationships" id="259" r:id="R1afaf364c74b4f08"/>
+    <p:sldId xmlns:r="http://schemas.openxmlformats.org/officeDocument/2006/relationships" id="260" r:id="R3d63754f7f514e00"/>
+    <p:sldId xmlns:r="http://schemas.openxmlformats.org/officeDocument/2006/relationships" id="261" r:id="Rf63d4c49402745ff"/>
+    <p:sldId xmlns:r="http://schemas.openxmlformats.org/officeDocument/2006/relationships" id="262" r:id="Rb9160aa717d8410c"/>
+    <p:sldId xmlns:r="http://schemas.openxmlformats.org/officeDocument/2006/relationships" id="263" r:id="R9457ddcc2365407e"/>
+    <p:sldId xmlns:r="http://schemas.openxmlformats.org/officeDocument/2006/relationships" id="264" r:id="Rb7420dd934374f86"/>
+    <p:sldId xmlns:r="http://schemas.openxmlformats.org/officeDocument/2006/relationships" id="265" r:id="R213bcb654e25452d"/>
+    <p:sldId xmlns:r="http://schemas.openxmlformats.org/officeDocument/2006/relationships" id="266" r:id="R4f993447eb684cf0"/>
+    <p:sldId xmlns:r="http://schemas.openxmlformats.org/officeDocument/2006/relationships" id="267" r:id="R17c45b7694f9479b"/>
   </p:sldIdLst>
   <p:sldSz cx="12192000" cy="6858000"/>
   <p:notesSz cx="6858000" cy="9144000"/>
@@ -1566,7 +1566,7 @@
   </p:cSld>
   <p:clrMap bg1="lt1" tx1="dk1" bg2="lt2" tx2="dk2" accent1="accent1" accent2="accent2" accent3="accent3" accent4="accent4" accent5="accent5" accent6="accent6" hlink="hlink" folHlink="folHlink"/>
   <p:sldLayoutIdLst>
-    <p:sldLayoutId xmlns:r="http://schemas.openxmlformats.org/officeDocument/2006/relationships" id="2147483649" r:id="Ra4ae60825fb0451d"/>
+    <p:sldLayoutId xmlns:r="http://schemas.openxmlformats.org/officeDocument/2006/relationships" id="2147483649" r:id="Rc77041be71ca4625"/>
   </p:sldLayoutIdLst>
   <p:txStyles>
     <p:titleStyle>
@@ -2388,7 +2388,7 @@
           <p:nvPr/>
         </p:nvPicPr>
         <p:blipFill>
-          <a:blip xmlns:r="http://schemas.openxmlformats.org/officeDocument/2006/relationships" xmlns:a="http://schemas.openxmlformats.org/drawingml/2006/main" r:embed="R032193fd666d4e70"/>
+          <a:blip xmlns:r="http://schemas.openxmlformats.org/officeDocument/2006/relationships" xmlns:a="http://schemas.openxmlformats.org/drawingml/2006/main" r:embed="R874030bdb0064fd5"/>
           <a:srcRect xmlns:a="http://schemas.openxmlformats.org/drawingml/2006/main" l="0" t="9434" r="0" b="9434"/>
           <a:stretch xmlns:a="http://schemas.openxmlformats.org/drawingml/2006/main">
             <a:fillRect l="0" t="0" r="0" b="0"/>
@@ -4070,7 +4070,7 @@
                 <a:ea typeface="Arial"/>
                 <a:cs typeface="Arial"/>
               </a:rPr>
-              <a:t>25 tests</a:t>
+              <a:t>27 tests</a:t>
             </a:r>
             <a:r>
               <a:rPr sz="1425" b="0">
@@ -11530,7 +11530,7 @@
                 <a:ea typeface="Arial"/>
                 <a:cs typeface="Arial"/>
               </a:rPr>
-              <a:t>AR controls: source reference · exact customer/amount · exception visibility · audited application result</a:t>
+              <a:t>AR controls: source ref · exact customer/currency/amount · exception queue · audited result</a:t>
             </a:r>
           </a:p>
         </p:txBody>

</xml_diff>

<commit_message>
Implement unified AP/AR orchestration and Mock ERP API
</commit_message>
<xml_diff>
--- a/presentation/LedgerPilot_Assignment_Deck.pptx
+++ b/presentation/LedgerPilot_Assignment_Deck.pptx
@@ -2,24 +2,24 @@
 <file path=ppt/presentation.xml><?xml version="1.0" encoding="utf-8"?>
 <p:presentation xmlns:p="http://schemas.openxmlformats.org/presentationml/2006/main">
   <p:sldMasterIdLst>
-    <p:sldMasterId xmlns:r="http://schemas.openxmlformats.org/officeDocument/2006/relationships" id="2147483648" r:id="R77ce58e2c9a0474b"/>
+    <p:sldMasterId xmlns:r="http://schemas.openxmlformats.org/officeDocument/2006/relationships" id="2147483648" r:id="R27070bd1df2a44d5"/>
   </p:sldMasterIdLst>
   <p:notesMasterIdLst>
-    <p:notesMasterId xmlns:r="http://schemas.openxmlformats.org/officeDocument/2006/relationships" r:id="R98e165cc60984833"/>
+    <p:notesMasterId xmlns:r="http://schemas.openxmlformats.org/officeDocument/2006/relationships" r:id="Rf36df9da8ea04cb7"/>
   </p:notesMasterIdLst>
   <p:sldIdLst>
-    <p:sldId xmlns:r="http://schemas.openxmlformats.org/officeDocument/2006/relationships" id="256" r:id="Re8f84ab8b0174efa"/>
-    <p:sldId xmlns:r="http://schemas.openxmlformats.org/officeDocument/2006/relationships" id="257" r:id="R89b2e3571f3747b5"/>
-    <p:sldId xmlns:r="http://schemas.openxmlformats.org/officeDocument/2006/relationships" id="258" r:id="Rbe9089fee7234336"/>
-    <p:sldId xmlns:r="http://schemas.openxmlformats.org/officeDocument/2006/relationships" id="259" r:id="R1afaf364c74b4f08"/>
-    <p:sldId xmlns:r="http://schemas.openxmlformats.org/officeDocument/2006/relationships" id="260" r:id="R3d63754f7f514e00"/>
-    <p:sldId xmlns:r="http://schemas.openxmlformats.org/officeDocument/2006/relationships" id="261" r:id="Rf63d4c49402745ff"/>
-    <p:sldId xmlns:r="http://schemas.openxmlformats.org/officeDocument/2006/relationships" id="262" r:id="Rb9160aa717d8410c"/>
-    <p:sldId xmlns:r="http://schemas.openxmlformats.org/officeDocument/2006/relationships" id="263" r:id="R9457ddcc2365407e"/>
-    <p:sldId xmlns:r="http://schemas.openxmlformats.org/officeDocument/2006/relationships" id="264" r:id="Rb7420dd934374f86"/>
-    <p:sldId xmlns:r="http://schemas.openxmlformats.org/officeDocument/2006/relationships" id="265" r:id="R213bcb654e25452d"/>
-    <p:sldId xmlns:r="http://schemas.openxmlformats.org/officeDocument/2006/relationships" id="266" r:id="R4f993447eb684cf0"/>
-    <p:sldId xmlns:r="http://schemas.openxmlformats.org/officeDocument/2006/relationships" id="267" r:id="R17c45b7694f9479b"/>
+    <p:sldId xmlns:r="http://schemas.openxmlformats.org/officeDocument/2006/relationships" id="256" r:id="R7b74120b6b164179"/>
+    <p:sldId xmlns:r="http://schemas.openxmlformats.org/officeDocument/2006/relationships" id="257" r:id="R9ea1798b9c664aa7"/>
+    <p:sldId xmlns:r="http://schemas.openxmlformats.org/officeDocument/2006/relationships" id="258" r:id="R435774bc707441cc"/>
+    <p:sldId xmlns:r="http://schemas.openxmlformats.org/officeDocument/2006/relationships" id="259" r:id="R1d629c5f6df543d8"/>
+    <p:sldId xmlns:r="http://schemas.openxmlformats.org/officeDocument/2006/relationships" id="260" r:id="R63167b1c6be94de2"/>
+    <p:sldId xmlns:r="http://schemas.openxmlformats.org/officeDocument/2006/relationships" id="261" r:id="R936e42614ce041cb"/>
+    <p:sldId xmlns:r="http://schemas.openxmlformats.org/officeDocument/2006/relationships" id="262" r:id="R274b9b89b1a04410"/>
+    <p:sldId xmlns:r="http://schemas.openxmlformats.org/officeDocument/2006/relationships" id="263" r:id="R1b628ef16759412c"/>
+    <p:sldId xmlns:r="http://schemas.openxmlformats.org/officeDocument/2006/relationships" id="264" r:id="R7db6fe33ff2b4c05"/>
+    <p:sldId xmlns:r="http://schemas.openxmlformats.org/officeDocument/2006/relationships" id="265" r:id="Rae9ebb6b62ba494c"/>
+    <p:sldId xmlns:r="http://schemas.openxmlformats.org/officeDocument/2006/relationships" id="266" r:id="Rf8ccb575532948e6"/>
+    <p:sldId xmlns:r="http://schemas.openxmlformats.org/officeDocument/2006/relationships" id="267" r:id="R6f4c8f90fba14cd8"/>
   </p:sldIdLst>
   <p:sldSz cx="12192000" cy="6858000"/>
   <p:notesSz cx="6858000" cy="9144000"/>
@@ -453,7 +453,7 @@
           <a:lstStyle xmlns:a="http://schemas.openxmlformats.org/drawingml/2006/main"/>
           <a:p xmlns:a="http://schemas.openxmlformats.org/drawingml/2006/main">
             <a:r>
-              <a:t>Open with the control philosophy: AI reads and reasons; deterministic policy decides whether money moves.</a:t>
+              <a:t>Open with the completed control philosophy: one document layer dispatches to mirrored AP and AR workflows; deterministic policy decides whether money moves.</a:t>
             </a:r>
           </a:p>
           <a:p xmlns:a="http://schemas.openxmlformats.org/drawingml/2006/main">
@@ -468,7 +468,7 @@
           </a:p>
           <a:p xmlns:a="http://schemas.openxmlformats.org/drawingml/2006/main">
             <a:r>
-              <a:t>- AI-Engineer - Assignment.docx — objective, scenario, and required stack.</a:t>
+              <a:t>- AI-Engineer - Assignment.docx — objective, mirrored AP/AR scenario, and required stack.</a:t>
             </a:r>
           </a:p>
           <a:p xmlns:a="http://schemas.openxmlformats.org/drawingml/2006/main">
@@ -543,7 +543,7 @@
           <a:lstStyle xmlns:a="http://schemas.openxmlformats.org/drawingml/2006/main"/>
           <a:p xmlns:a="http://schemas.openxmlformats.org/drawingml/2006/main">
             <a:r>
-              <a:t>The 100% figures are controlled-fixture results, not production estimates. Call out the zero false-auto-post rate, forced Docling path, and the need for a permissioned pilot.</a:t>
+              <a:t>The controlled fixtures prove regression behavior, not production accuracy. Call out the honest OCR miss, perfect finance decisions, and zero false financial actions.</a:t>
             </a:r>
           </a:p>
           <a:p xmlns:a="http://schemas.openxmlformats.org/drawingml/2006/main">
@@ -558,17 +558,22 @@
           </a:p>
           <a:p xmlns:a="http://schemas.openxmlformats.org/drawingml/2006/main">
             <a:r>
-              <a:t>- evaluation/results/latest.json — generated seven-document metrics.</a:t>
-            </a:r>
-          </a:p>
-          <a:p xmlns:a="http://schemas.openxmlformats.org/drawingml/2006/main">
-            <a:r>
-              <a:t>- evaluation/results/rag-latest.json — labeled retrieval precision and recall.</a:t>
-            </a:r>
-          </a:p>
-          <a:p xmlns:a="http://schemas.openxmlformats.org/drawingml/2006/main">
-            <a:r>
-              <a:t>- docs/evaluation-report.md — definitions, limitations, and pilot plan.</a:t>
+              <a:t>- evaluation/results/latest.json — seven-document AP metrics.</a:t>
+            </a:r>
+          </a:p>
+          <a:p xmlns:a="http://schemas.openxmlformats.org/drawingml/2006/main">
+            <a:r>
+              <a:t>- evaluation/results/ar-latest.json — nine-document AR metrics.</a:t>
+            </a:r>
+          </a:p>
+          <a:p xmlns:a="http://schemas.openxmlformats.org/drawingml/2006/main">
+            <a:r>
+              <a:t>- evaluation/results/rag-latest.json — policy retrieval metrics.</a:t>
+            </a:r>
+          </a:p>
+          <a:p xmlns:a="http://schemas.openxmlformats.org/drawingml/2006/main">
+            <a:r>
+              <a:t>- docs/evaluation-report.md — definitions and limitations.</a:t>
             </a:r>
           </a:p>
         </p:txBody>
@@ -638,7 +643,7 @@
           <a:lstStyle xmlns:a="http://schemas.openxmlformats.org/drawingml/2006/main"/>
           <a:p xmlns:a="http://schemas.openxmlformats.org/drawingml/2006/main">
             <a:r>
-              <a:t>The demo path is intentionally short enough for a technical review. It demonstrates automatic posting eligibility and a retry with the same idempotency key.</a:t>
+              <a:t>The demo proves both domains plus the service boundary: bring up PostgreSQL, Mock ERP, and API; verify contracts and tests; then dispatch AP and AR fixtures.</a:t>
             </a:r>
           </a:p>
           <a:p xmlns:a="http://schemas.openxmlformats.org/drawingml/2006/main">
@@ -653,17 +658,17 @@
           </a:p>
           <a:p xmlns:a="http://schemas.openxmlformats.org/drawingml/2006/main">
             <a:r>
-              <a:t>- README.md — quick start and demo commands.</a:t>
-            </a:r>
-          </a:p>
-          <a:p xmlns:a="http://schemas.openxmlformats.org/drawingml/2006/main">
-            <a:r>
-              <a:t>- Dockerfile and docker-compose.yml — deployment configuration.</a:t>
-            </a:r>
-          </a:p>
-          <a:p xmlns:a="http://schemas.openxmlformats.org/drawingml/2006/main">
-            <a:r>
-              <a:t>- scripts/demo.ps1 — AP happy-path and idempotent replay demo.</a:t>
+              <a:t>- README.md — quick start and unified API walkthrough.</a:t>
+            </a:r>
+          </a:p>
+          <a:p xmlns:a="http://schemas.openxmlformats.org/drawingml/2006/main">
+            <a:r>
+              <a:t>- Dockerfile; docker-compose.yml — deployment topology.</a:t>
+            </a:r>
+          </a:p>
+          <a:p xmlns:a="http://schemas.openxmlformats.org/drawingml/2006/main">
+            <a:r>
+              <a:t>- scripts/demo.ps1 — AP journal replay and AR cash application demo.</a:t>
             </a:r>
           </a:p>
         </p:txBody>
@@ -733,7 +738,7 @@
           <a:lstStyle xmlns:a="http://schemas.openxmlformats.org/drawingml/2006/main"/>
           <a:p xmlns:a="http://schemas.openxmlformats.org/drawingml/2006/main">
             <a:r>
-              <a:t>Close on the next evidence-building step, not on a generic thank-you.</a:t>
+              <a:t>Close on the production evidence-building step: vendor-specific ERP integration and permissioned AP/AR documents.</a:t>
             </a:r>
           </a:p>
           <a:p xmlns:a="http://schemas.openxmlformats.org/drawingml/2006/main">
@@ -749,6 +754,11 @@
           <a:p xmlns:a="http://schemas.openxmlformats.org/drawingml/2006/main">
             <a:r>
               <a:t>- docs/traceability-matrix.md — assignment-to-artifact mapping.</a:t>
+            </a:r>
+          </a:p>
+          <a:p xmlns:a="http://schemas.openxmlformats.org/drawingml/2006/main">
+            <a:r>
+              <a:t>- docs/evaluation-report.md — production pilot plan and limitations.</a:t>
             </a:r>
           </a:p>
           <a:p xmlns:a="http://schemas.openxmlformats.org/drawingml/2006/main">
@@ -908,7 +918,7 @@
           <a:lstStyle xmlns:a="http://schemas.openxmlformats.org/drawingml/2006/main"/>
           <a:p xmlns:a="http://schemas.openxmlformats.org/drawingml/2006/main">
             <a:r>
-              <a:t>Walk left to right. The bottom rail receives evidence from every stage.</a:t>
+              <a:t>Walk left to right: conversion and classification happen once, then the parent graph dispatches into a domain subgraph. The bottom rail receives evidence from every stage.</a:t>
             </a:r>
           </a:p>
           <a:p xmlns:a="http://schemas.openxmlformats.org/drawingml/2006/main">
@@ -923,17 +933,17 @@
           </a:p>
           <a:p xmlns:a="http://schemas.openxmlformats.org/drawingml/2006/main">
             <a:r>
-              <a:t>- README.md — architecture and component map.</a:t>
-            </a:r>
-          </a:p>
-          <a:p xmlns:a="http://schemas.openxmlformats.org/drawingml/2006/main">
-            <a:r>
-              <a:t>- docs/architecture.md — component view and failure behavior.</a:t>
-            </a:r>
-          </a:p>
-          <a:p xmlns:a="http://schemas.openxmlformats.org/drawingml/2006/main">
-            <a:r>
-              <a:t>- app/workflow.py; app/audit.py; docker-compose.yml.</a:t>
+              <a:t>- app/document_processing.py; app/orchestrator.py — canonical processing and conditional dispatch.</a:t>
+            </a:r>
+          </a:p>
+          <a:p xmlns:a="http://schemas.openxmlformats.org/drawingml/2006/main">
+            <a:r>
+              <a:t>- app/workflow.py; app/ar_workflow.py — AP and AR subgraphs.</a:t>
+            </a:r>
+          </a:p>
+          <a:p xmlns:a="http://schemas.openxmlformats.org/drawingml/2006/main">
+            <a:r>
+              <a:t>- app/mock_erp_api.py; docker-compose.yml — separate HTTP Mock ERP service.</a:t>
             </a:r>
           </a:p>
         </p:txBody>
@@ -1003,7 +1013,7 @@
           <a:lstStyle xmlns:a="http://schemas.openxmlformats.org/drawingml/2006/main"/>
           <a:p xmlns:a="http://schemas.openxmlformats.org/drawingml/2006/main">
             <a:r>
-              <a:t>Emphasize that LangGraph coordinates the state, while matching and eligibility remain deterministic.</a:t>
+              <a:t>The parent graph owns classification and dispatch. Both subgraphs retrieve context, run deterministic controls, and choose post or review; their domain rules remain separate.</a:t>
             </a:r>
           </a:p>
           <a:p xmlns:a="http://schemas.openxmlformats.org/drawingml/2006/main">
@@ -1018,12 +1028,17 @@
           </a:p>
           <a:p xmlns:a="http://schemas.openxmlformats.org/drawingml/2006/main">
             <a:r>
-              <a:t>- app/workflow.py — workflow state and routing.</a:t>
-            </a:r>
-          </a:p>
-          <a:p xmlns:a="http://schemas.openxmlformats.org/drawingml/2006/main">
-            <a:r>
-              <a:t>- app/extraction.py; app/matching.py; app/erp.py.</a:t>
+              <a:t>- app/orchestrator.py — parent graph nodes and conditional routes.</a:t>
+            </a:r>
+          </a:p>
+          <a:p xmlns:a="http://schemas.openxmlformats.org/drawingml/2006/main">
+            <a:r>
+              <a:t>- app/workflow.py; app/ar_workflow.py — mirrored subgraph state transitions.</a:t>
+            </a:r>
+          </a:p>
+          <a:p xmlns:a="http://schemas.openxmlformats.org/drawingml/2006/main">
+            <a:r>
+              <a:t>- app/repository.py — durable generic finance workflow state.</a:t>
             </a:r>
           </a:p>
         </p:txBody>
@@ -1188,7 +1203,7 @@
           <a:lstStyle xmlns:a="http://schemas.openxmlformats.org/drawingml/2006/main"/>
           <a:p xmlns:a="http://schemas.openxmlformats.org/drawingml/2006/main">
             <a:r>
-              <a:t>Explain that the original mismatch remains visible after approval. The demo accepts a supplied actor string; production deployment must bind that actor to authenticated RBAC identity.</a:t>
+              <a:t>Contrast AP and AR review semantics. AR corrections always return through matching against current ERP state; an invalid allocation cannot be force-approved.</a:t>
             </a:r>
           </a:p>
           <a:p xmlns:a="http://schemas.openxmlformats.org/drawingml/2006/main">
@@ -1203,17 +1218,17 @@
           </a:p>
           <a:p xmlns:a="http://schemas.openxmlformats.org/drawingml/2006/main">
             <a:r>
-              <a:t>- app/api.py — exception queue and decision endpoint.</a:t>
-            </a:r>
-          </a:p>
-          <a:p xmlns:a="http://schemas.openxmlformats.org/drawingml/2006/main">
-            <a:r>
-              <a:t>- app/audit.py — append-only hash chain.</a:t>
-            </a:r>
-          </a:p>
-          <a:p xmlns:a="http://schemas.openxmlformats.org/drawingml/2006/main">
-            <a:r>
-              <a:t>- docs/security-and-controls.md — control posture and identity limitation.</a:t>
+              <a:t>- app/api.py — unified queue and AP/AR decision endpoints.</a:t>
+            </a:r>
+          </a:p>
+          <a:p xmlns:a="http://schemas.openxmlformats.org/drawingml/2006/main">
+            <a:r>
+              <a:t>- app/ar_workflow.py — correction, re-match, reject, manual-resolution, and valid-match approval guards.</a:t>
+            </a:r>
+          </a:p>
+          <a:p xmlns:a="http://schemas.openxmlformats.org/drawingml/2006/main">
+            <a:r>
+              <a:t>- docs/security-and-controls.md — identity limitation and production controls.</a:t>
             </a:r>
           </a:p>
         </p:txBody>
@@ -1283,7 +1298,7 @@
           <a:lstStyle xmlns:a="http://schemas.openxmlformats.org/drawingml/2006/main"/>
           <a:p xmlns:a="http://schemas.openxmlformats.org/drawingml/2006/main">
             <a:r>
-              <a:t>AR is not a second architecture; it is a second domain path through the same governance pattern.</a:t>
+              <a:t>This is the literal mirror: AP and AR share the orchestration pattern and evidence model, while each subgraph enforces its own financial controls.</a:t>
             </a:r>
           </a:p>
           <a:p xmlns:a="http://schemas.openxmlformats.org/drawingml/2006/main">
@@ -1298,17 +1313,22 @@
           </a:p>
           <a:p xmlns:a="http://schemas.openxmlformats.org/drawingml/2006/main">
             <a:r>
-              <a:t>- app/api.py — /api/v1/ingest-remittance.</a:t>
-            </a:r>
-          </a:p>
-          <a:p xmlns:a="http://schemas.openxmlformats.org/drawingml/2006/main">
-            <a:r>
-              <a:t>- app/erp.py — apply_cash implementation.</a:t>
-            </a:r>
-          </a:p>
-          <a:p xmlns:a="http://schemas.openxmlformats.org/drawingml/2006/main">
-            <a:r>
-              <a:t>- tests/test_ar.py — exact and partial payment cases.</a:t>
+              <a:t>- app/document_processing.py; app/orchestrator.py — shared layer and parent dispatch.</a:t>
+            </a:r>
+          </a:p>
+          <a:p xmlns:a="http://schemas.openxmlformats.org/drawingml/2006/main">
+            <a:r>
+              <a:t>- app/workflow.py — AP subgraph.</a:t>
+            </a:r>
+          </a:p>
+          <a:p xmlns:a="http://schemas.openxmlformats.org/drawingml/2006/main">
+            <a:r>
+              <a:t>- app/ar_workflow.py; app/ar_matching.py — AR subgraph and deterministic allocation.</a:t>
+            </a:r>
+          </a:p>
+          <a:p xmlns:a="http://schemas.openxmlformats.org/drawingml/2006/main">
+            <a:r>
+              <a:t>- tests/test_orchestrator.py; tests/test_ar_workflow.py — executable evidence.</a:t>
             </a:r>
           </a:p>
         </p:txBody>
@@ -1378,7 +1398,7 @@
           <a:lstStyle xmlns:a="http://schemas.openxmlformats.org/drawingml/2006/main"/>
           <a:p xmlns:a="http://schemas.openxmlformats.org/drawingml/2006/main">
             <a:r>
-              <a:t>The contract is both auto-served by FastAPI and checked into source control.</a:t>
+              <a:t>The five required contracts remain unchanged. Additive endpoints demonstrate cross-domain dispatch and mirrored AR review without breaking the assignment walkthrough.</a:t>
             </a:r>
           </a:p>
           <a:p xmlns:a="http://schemas.openxmlformats.org/drawingml/2006/main">
@@ -1393,17 +1413,17 @@
           </a:p>
           <a:p xmlns:a="http://schemas.openxmlformats.org/drawingml/2006/main">
             <a:r>
-              <a:t>- openapi/openapi.yaml — versioned API contract.</a:t>
+              <a:t>- openapi/openapi.yaml — generated, versioned finance API contract.</a:t>
+            </a:r>
+          </a:p>
+          <a:p xmlns:a="http://schemas.openxmlformats.org/drawingml/2006/main">
+            <a:r>
+              <a:t>- openapi/mock-erp-openapi.yaml — generated ERP sandbox contract.</a:t>
             </a:r>
           </a:p>
           <a:p xmlns:a="http://schemas.openxmlformats.org/drawingml/2006/main">
             <a:r>
               <a:t>- app/api.py — FastAPI implementation.</a:t>
-            </a:r>
-          </a:p>
-          <a:p xmlns:a="http://schemas.openxmlformats.org/drawingml/2006/main">
-            <a:r>
-              <a:t>- app/audit.py — event schema and verification.</a:t>
             </a:r>
           </a:p>
         </p:txBody>
@@ -1473,7 +1493,7 @@
           <a:lstStyle xmlns:a="http://schemas.openxmlformats.org/drawingml/2006/main"/>
           <a:p xmlns:a="http://schemas.openxmlformats.org/drawingml/2006/main">
             <a:r>
-              <a:t>Point to code or deployment evidence for every row of the assignment's technology table. LlamaIndex performs real ranking and the labeled policy set is scored with RAGAS.</a:t>
+              <a:t>Point to concrete implementation evidence for every mandatory technology. The ERP requirement is now met through a separate HTTP Mock API rather than only an in-process adapter.</a:t>
             </a:r>
           </a:p>
           <a:p xmlns:a="http://schemas.openxmlformats.org/drawingml/2006/main">
@@ -1493,12 +1513,17 @@
           </a:p>
           <a:p xmlns:a="http://schemas.openxmlformats.org/drawingml/2006/main">
             <a:r>
-              <a:t>- pyproject.toml; app/context.py — pinned dependencies and retrieval implementation.</a:t>
-            </a:r>
-          </a:p>
-          <a:p xmlns:a="http://schemas.openxmlformats.org/drawingml/2006/main">
-            <a:r>
-              <a:t>- evaluation/results/rag-latest.json; docker-compose.yml.</a:t>
+              <a:t>- pyproject.toml; app/context.py — pinned stack and retrieval implementation.</a:t>
+            </a:r>
+          </a:p>
+          <a:p xmlns:a="http://schemas.openxmlformats.org/drawingml/2006/main">
+            <a:r>
+              <a:t>- app/mock_erp_api.py; docker-compose.yml — Mock ERP API service.</a:t>
+            </a:r>
+          </a:p>
+          <a:p xmlns:a="http://schemas.openxmlformats.org/drawingml/2006/main">
+            <a:r>
+              <a:t>- evaluation/results/rag-latest.json.</a:t>
             </a:r>
           </a:p>
         </p:txBody>
@@ -1566,7 +1591,7 @@
   </p:cSld>
   <p:clrMap bg1="lt1" tx1="dk1" bg2="lt2" tx2="dk2" accent1="accent1" accent2="accent2" accent3="accent3" accent4="accent4" accent5="accent5" accent6="accent6" hlink="hlink" folHlink="folHlink"/>
   <p:sldLayoutIdLst>
-    <p:sldLayoutId xmlns:r="http://schemas.openxmlformats.org/officeDocument/2006/relationships" id="2147483649" r:id="Rc77041be71ca4625"/>
+    <p:sldLayoutId xmlns:r="http://schemas.openxmlformats.org/officeDocument/2006/relationships" id="2147483649" r:id="R1674c5530236401f"/>
   </p:sldLayoutIdLst>
   <p:txStyles>
     <p:titleStyle>
@@ -2284,7 +2309,7 @@
                 <a:ea typeface="Arial"/>
                 <a:cs typeface="Arial"/>
               </a:rPr>
-              <a:t>A runnable AP + AR prototype with deterministic financial controls, human exception ownership, and verifiable auditability.</a:t>
+              <a:t>A runnable AP + AR prototype with shared document intelligence, mirrored agentic workflows, deterministic controls, and an HTTP Mock ERP.</a:t>
             </a:r>
           </a:p>
         </p:txBody>
@@ -2374,7 +2399,7 @@
                 <a:ea typeface="Arial"/>
                 <a:cs typeface="Arial"/>
               </a:rPr>
-              <a:t>LedgerPilot · Python · FastAPI · LangGraph · Docling</a:t>
+              <a:t>LedgerPilot · FastAPI · LangGraph · Docling · Mock ERP API</a:t>
             </a:r>
           </a:p>
         </p:txBody>
@@ -2388,7 +2413,7 @@
           <p:nvPr/>
         </p:nvPicPr>
         <p:blipFill>
-          <a:blip xmlns:r="http://schemas.openxmlformats.org/officeDocument/2006/relationships" xmlns:a="http://schemas.openxmlformats.org/drawingml/2006/main" r:embed="R874030bdb0064fd5"/>
+          <a:blip xmlns:r="http://schemas.openxmlformats.org/officeDocument/2006/relationships" xmlns:a="http://schemas.openxmlformats.org/drawingml/2006/main" r:embed="R63b0cb24ba214104"/>
           <a:srcRect xmlns:a="http://schemas.openxmlformats.org/drawingml/2006/main" l="0" t="9434" r="0" b="9434"/>
           <a:stretch xmlns:a="http://schemas.openxmlformats.org/drawingml/2006/main">
             <a:fillRect l="0" t="0" r="0" b="0"/>
@@ -2583,7 +2608,7 @@
         </p:spPr>
         <p:txBody>
           <a:bodyPr xmlns:a="http://schemas.openxmlformats.org/drawingml/2006/main" wrap="square" lIns="0" tIns="0" rIns="0" bIns="0" anchor="t">
-            <a:normAutofit fontScale="85796"/>
+            <a:normAutofit fontScale="85564"/>
           </a:bodyPr>
           <a:lstStyle xmlns:a="http://schemas.openxmlformats.org/drawingml/2006/main"/>
           <a:p xmlns:a="http://schemas.openxmlformats.org/drawingml/2006/main">
@@ -2607,7 +2632,7 @@
                 <a:ea typeface="Arial"/>
                 <a:cs typeface="Arial"/>
               </a:rPr>
-              <a:t>The controlled benchmark proves behavior—not production generalization</a:t>
+              <a:t>Two benchmarks prove controlled behavior—not production generalization</a:t>
             </a:r>
           </a:p>
         </p:txBody>
@@ -2756,7 +2781,7 @@
                 <a:ea typeface="Arial"/>
                 <a:cs typeface="Arial"/>
               </a:rPr>
-              <a:t>Seven synthetic cases span JSON, PDF, PNG, and forced Docling HTML: four clean and three controlled exceptions.</a:t>
+              <a:t>16 synthetic documents: AP 7 + AR 9 across JSON, text, PDF, scan, HTML, and controlled exceptions.</a:t>
             </a:r>
           </a:p>
         </p:txBody>
@@ -2905,7 +2930,7 @@
                 <a:ea typeface="Arial"/>
                 <a:cs typeface="Arial"/>
               </a:rPr>
-              <a:t>field extraction</a:t>
+              <a:t>AP + AR match decisions</a:t>
             </a:r>
           </a:p>
           <a:p xmlns:a="http://schemas.openxmlformats.org/drawingml/2006/main">
@@ -2929,7 +2954,7 @@
                 <a:ea typeface="Arial"/>
                 <a:cs typeface="Arial"/>
               </a:rPr>
-              <a:t>35 / 35 labels</a:t>
+              <a:t>16 / 16 documents</a:t>
             </a:r>
           </a:p>
         </p:txBody>
@@ -3019,7 +3044,7 @@
                 <a:ea typeface="Arial"/>
                 <a:cs typeface="Arial"/>
               </a:rPr>
-              <a:t>100%</a:t>
+              <a:t>97.2%</a:t>
             </a:r>
           </a:p>
         </p:txBody>
@@ -3078,7 +3103,7 @@
                 <a:ea typeface="Arial"/>
                 <a:cs typeface="Arial"/>
               </a:rPr>
-              <a:t>match + exception</a:t>
+              <a:t>AR field extraction</a:t>
             </a:r>
           </a:p>
           <a:p xmlns:a="http://schemas.openxmlformats.org/drawingml/2006/main">
@@ -3102,7 +3127,7 @@
                 <a:ea typeface="Arial"/>
                 <a:cs typeface="Arial"/>
               </a:rPr>
-              <a:t>7 / 7 documents</a:t>
+              <a:t>35 / 36 labels</a:t>
             </a:r>
           </a:p>
         </p:txBody>
@@ -3192,7 +3217,7 @@
                 <a:ea typeface="Arial"/>
                 <a:cs typeface="Arial"/>
               </a:rPr>
-              <a:t>57%</a:t>
+              <a:t>0%</a:t>
             </a:r>
           </a:p>
         </p:txBody>
@@ -3251,7 +3276,7 @@
                 <a:ea typeface="Arial"/>
                 <a:cs typeface="Arial"/>
               </a:rPr>
-              <a:t>straight-through</a:t>
+              <a:t>false journal / cash action</a:t>
             </a:r>
           </a:p>
           <a:p xmlns:a="http://schemas.openxmlformats.org/drawingml/2006/main">
@@ -3275,7 +3300,7 @@
                 <a:ea typeface="Arial"/>
                 <a:cs typeface="Arial"/>
               </a:rPr>
-              <a:t>4 / 7 documents</a:t>
+              <a:t>0 / 16 documents</a:t>
             </a:r>
           </a:p>
         </p:txBody>
@@ -3334,7 +3359,7 @@
                 <a:ea typeface="Arial"/>
                 <a:cs typeface="Arial"/>
               </a:rPr>
-              <a:t>RAGAS retrieval: 100% precision + recall on 4 labeled queries. Next gate: ≥500 permissioned invoices across vendors and scan quality.</a:t>
+              <a:t>RAGAS retrieval: 100% precision + recall on 4 labeled queries. Next gate: permissioned invoice and remittance pilot.</a:t>
             </a:r>
           </a:p>
         </p:txBody>
@@ -3812,7 +3837,7 @@
                 <a:ea typeface="Arial"/>
                 <a:cs typeface="Arial"/>
               </a:rPr>
-              <a:t>docker compose up</a:t>
+              <a:t>docker compose up --build</a:t>
             </a:r>
           </a:p>
           <a:p xmlns:a="http://schemas.openxmlformats.org/drawingml/2006/main">
@@ -3836,7 +3861,7 @@
                 <a:ea typeface="Arial"/>
                 <a:cs typeface="Arial"/>
               </a:rPr>
-              <a:t>--build -d postgres api</a:t>
+              <a:t>-d postgres mock-erp api</a:t>
             </a:r>
           </a:p>
         </p:txBody>
@@ -4046,7 +4071,7 @@
                 <a:ea typeface="Arial"/>
                 <a:cs typeface="Arial"/>
               </a:rPr>
-              <a:t>/health · Swagger</a:t>
+              <a:t>/health · docs · ERP health</a:t>
             </a:r>
           </a:p>
           <a:p xmlns:a="http://schemas.openxmlformats.org/drawingml/2006/main">
@@ -4070,18 +4095,7 @@
                 <a:ea typeface="Arial"/>
                 <a:cs typeface="Arial"/>
               </a:rPr>
-              <a:t>27 tests</a:t>
-            </a:r>
-            <a:r>
-              <a:rPr sz="1425" b="0">
-                <a:solidFill>
-                  <a:srgbClr val="5E6773"/>
-                </a:solidFill>
-                <a:latin typeface="Arial"/>
-                <a:ea typeface="Arial"/>
-                <a:cs typeface="Arial"/>
-              </a:rPr>
-              <a:t> · 7-doc + RAGAS eval</a:t>
+              <a:t>42 tests · AP/AR + RAGAS eval</a:t>
             </a:r>
           </a:p>
         </p:txBody>
@@ -4291,7 +4305,7 @@
                 <a:ea typeface="Arial"/>
                 <a:cs typeface="Arial"/>
               </a:rPr>
-              <a:t>ingest → match → auto-post</a:t>
+              <a:t>unified ingest → AP / AR dispatch</a:t>
             </a:r>
           </a:p>
           <a:p xmlns:a="http://schemas.openxmlformats.org/drawingml/2006/main">
@@ -4315,7 +4329,7 @@
                 <a:ea typeface="Arial"/>
                 <a:cs typeface="Arial"/>
               </a:rPr>
-              <a:t>replay safely → inspect audit</a:t>
+              <a:t>journal + cash → inspect audit</a:t>
             </a:r>
           </a:p>
         </p:txBody>
@@ -4552,7 +4566,7 @@
                 <a:ea typeface="Arial"/>
                 <a:cs typeface="Arial"/>
               </a:rPr>
-              <a:t>Ready to demonstrate a controlled path from evidence to payment</a:t>
+              <a:t>Ready to demonstrate mirrored AP and AR agentic workflows</a:t>
             </a:r>
           </a:p>
         </p:txBody>
@@ -4642,7 +4656,7 @@
                 <a:ea typeface="Arial"/>
                 <a:cs typeface="Arial"/>
               </a:rPr>
-              <a:t>Working AP + AR flows</a:t>
+              <a:t>Shared document intelligence + parent orchestrator</a:t>
             </a:r>
           </a:p>
           <a:p xmlns:a="http://schemas.openxmlformats.org/drawingml/2006/main">
@@ -4666,7 +4680,7 @@
                 <a:ea typeface="Arial"/>
                 <a:cs typeface="Arial"/>
               </a:rPr>
-              <a:t>Versioned OpenAPI + Docker Compose</a:t>
+              <a:t>Mirrored AP and AR LangGraph subflows</a:t>
             </a:r>
           </a:p>
           <a:p xmlns:a="http://schemas.openxmlformats.org/drawingml/2006/main">
@@ -4690,7 +4704,7 @@
                 <a:ea typeface="Arial"/>
                 <a:cs typeface="Arial"/>
               </a:rPr>
-              <a:t>Tests + evaluation + audit chain</a:t>
+              <a:t>Separate HTTP Mock ERP + versioned contracts</a:t>
             </a:r>
           </a:p>
           <a:p xmlns:a="http://schemas.openxmlformats.org/drawingml/2006/main">
@@ -4714,7 +4728,7 @@
                 <a:ea typeface="Arial"/>
                 <a:cs typeface="Arial"/>
               </a:rPr>
-              <a:t>Architecture, controls, and deployment docs</a:t>
+              <a:t>42 tests + AP/AR/RAGAS evaluation + audit chain</a:t>
             </a:r>
           </a:p>
         </p:txBody>
@@ -4780,7 +4794,7 @@
         </p:spPr>
         <p:txBody>
           <a:bodyPr xmlns:a="http://schemas.openxmlformats.org/drawingml/2006/main" wrap="square" lIns="0" tIns="0" rIns="0" bIns="0" anchor="t">
-            <a:normAutofit fontScale="82466"/>
+            <a:normAutofit fontScale="89216"/>
           </a:bodyPr>
           <a:lstStyle xmlns:a="http://schemas.openxmlformats.org/drawingml/2006/main"/>
           <a:p xmlns:a="http://schemas.openxmlformats.org/drawingml/2006/main">
@@ -4833,7 +4847,51 @@
                 <a:ea typeface="Arial"/>
                 <a:cs typeface="Arial"/>
               </a:rPr>
-              <a:t>Connect a real ERP sandbox and evaluate on permissioned vendor invoices.</a:t>
+              <a:t>Pilot permissioned invoices</a:t>
+            </a:r>
+            <a:r>
+              <a:rPr sz="1650" b="1">
+                <a:solidFill>
+                  <a:srgbClr val="FFFFFF"/>
+                </a:solidFill>
+                <a:latin typeface="Arial"/>
+                <a:ea typeface="Arial"/>
+                <a:cs typeface="Arial"/>
+              </a:rPr>
+              <a:t> </a:t>
+            </a:r>
+            <a:r>
+              <a:rPr sz="1650" b="1">
+                <a:solidFill>
+                  <a:srgbClr val="FFFFFF"/>
+                </a:solidFill>
+                <a:latin typeface="Arial"/>
+                <a:ea typeface="Arial"/>
+                <a:cs typeface="Arial"/>
+              </a:rPr>
+              <a:t>and remittances against</a:t>
+            </a:r>
+            <a:r>
+              <a:rPr sz="1650" b="1">
+                <a:solidFill>
+                  <a:srgbClr val="FFFFFF"/>
+                </a:solidFill>
+                <a:latin typeface="Arial"/>
+                <a:ea typeface="Arial"/>
+                <a:cs typeface="Arial"/>
+              </a:rPr>
+              <a:t> </a:t>
+            </a:r>
+            <a:r>
+              <a:rPr sz="1650" b="1">
+                <a:solidFill>
+                  <a:srgbClr val="FFFFFF"/>
+                </a:solidFill>
+                <a:latin typeface="Arial"/>
+                <a:ea typeface="Arial"/>
+                <a:cs typeface="Arial"/>
+              </a:rPr>
+              <a:t>a real ERP sandbox.</a:t>
             </a:r>
           </a:p>
         </p:txBody>
@@ -5841,7 +5899,7 @@
                 <a:ea typeface="Arial"/>
                 <a:cs typeface="Arial"/>
               </a:rPr>
-              <a:t>One governed path connects source evidence to ERP action</a:t>
+              <a:t>One parent graph dispatches shared documents to AP and AR</a:t>
             </a:r>
           </a:p>
         </p:txBody>
@@ -6359,7 +6417,7 @@
                 <a:ea typeface="Arial"/>
                 <a:cs typeface="Arial"/>
               </a:rPr>
-              <a:t>Graph mailbox</a:t>
+              <a:t>Finance mailbox</a:t>
             </a:r>
           </a:p>
           <a:p xmlns:a="http://schemas.openxmlformats.org/drawingml/2006/main">
@@ -6383,7 +6441,7 @@
                 <a:ea typeface="Arial"/>
                 <a:cs typeface="Arial"/>
               </a:rPr>
-              <a:t>API upload</a:t>
+              <a:t>Unified API</a:t>
             </a:r>
           </a:p>
         </p:txBody>
@@ -6473,7 +6531,7 @@
                 <a:ea typeface="Arial"/>
                 <a:cs typeface="Arial"/>
               </a:rPr>
-              <a:t>Interpret</a:t>
+              <a:t>Normalize</a:t>
             </a:r>
           </a:p>
         </p:txBody>
@@ -6532,7 +6590,7 @@
                 <a:ea typeface="Arial"/>
                 <a:cs typeface="Arial"/>
               </a:rPr>
-              <a:t>PDF text + OCR</a:t>
+              <a:t>Canonical document</a:t>
             </a:r>
           </a:p>
           <a:p xmlns:a="http://schemas.openxmlformats.org/drawingml/2006/main">
@@ -6556,7 +6614,7 @@
                 <a:ea typeface="Arial"/>
                 <a:cs typeface="Arial"/>
               </a:rPr>
-              <a:t>Docling + Ollama</a:t>
+              <a:t>AP / AR / unknown</a:t>
             </a:r>
           </a:p>
         </p:txBody>
@@ -6646,7 +6704,7 @@
                 <a:ea typeface="Arial"/>
                 <a:cs typeface="Arial"/>
               </a:rPr>
-              <a:t>Orchestrate</a:t>
+              <a:t>Dispatch</a:t>
             </a:r>
           </a:p>
         </p:txBody>
@@ -6705,7 +6763,7 @@
                 <a:ea typeface="Arial"/>
                 <a:cs typeface="Arial"/>
               </a:rPr>
-              <a:t>LangGraph</a:t>
+              <a:t>Parent LangGraph</a:t>
             </a:r>
           </a:p>
           <a:p xmlns:a="http://schemas.openxmlformats.org/drawingml/2006/main">
@@ -6729,7 +6787,7 @@
                 <a:ea typeface="Arial"/>
                 <a:cs typeface="Arial"/>
               </a:rPr>
-              <a:t>LlamaIndex</a:t>
+              <a:t>AP + AR subgraphs</a:t>
             </a:r>
           </a:p>
         </p:txBody>
@@ -6878,7 +6936,7 @@
                 <a:ea typeface="Arial"/>
                 <a:cs typeface="Arial"/>
               </a:rPr>
-              <a:t>2/3-way match</a:t>
+              <a:t>PO + GR</a:t>
             </a:r>
           </a:p>
           <a:p xmlns:a="http://schemas.openxmlformats.org/drawingml/2006/main">
@@ -6902,7 +6960,7 @@
                 <a:ea typeface="Arial"/>
                 <a:cs typeface="Arial"/>
               </a:rPr>
-              <a:t>policy gate</a:t>
+              <a:t>Open AR items</a:t>
             </a:r>
           </a:p>
         </p:txBody>
@@ -6992,7 +7050,7 @@
                 <a:ea typeface="Arial"/>
                 <a:cs typeface="Arial"/>
               </a:rPr>
-              <a:t>Act</a:t>
+              <a:t>ERP</a:t>
             </a:r>
           </a:p>
         </p:txBody>
@@ -7051,7 +7109,7 @@
                 <a:ea typeface="Arial"/>
                 <a:cs typeface="Arial"/>
               </a:rPr>
-              <a:t>ERP journal</a:t>
+              <a:t>HTTP</a:t>
             </a:r>
           </a:p>
           <a:p xmlns:a="http://schemas.openxmlformats.org/drawingml/2006/main">
@@ -7075,7 +7133,7 @@
                 <a:ea typeface="Arial"/>
                 <a:cs typeface="Arial"/>
               </a:rPr>
-              <a:t>AR cash apply</a:t>
+              <a:t>Mock API</a:t>
             </a:r>
           </a:p>
         </p:txBody>
@@ -7167,7 +7225,7 @@
                 <a:ea typeface="Arial"/>
                 <a:cs typeface="Arial"/>
               </a:rPr>
-              <a:t>POSTGRESQL + PGVECTOR · HASH-CHAINED AUDIT · PHOENIX TRACES</a:t>
+              <a:t>POSTGRESQL + PGVECTOR · GENERIC WORKFLOW STATE · HASH-CHAINED AUDIT</a:t>
             </a:r>
           </a:p>
         </p:txBody>
@@ -7290,7 +7348,7 @@
         </p:spPr>
         <p:txBody>
           <a:bodyPr xmlns:a="http://schemas.openxmlformats.org/drawingml/2006/main" wrap="square" lIns="0" tIns="0" rIns="0" bIns="0" anchor="t">
-            <a:normAutofit fontScale="99462"/>
+            <a:normAutofit fontScale="100000"/>
           </a:bodyPr>
           <a:lstStyle xmlns:a="http://schemas.openxmlformats.org/drawingml/2006/main"/>
           <a:p xmlns:a="http://schemas.openxmlformats.org/drawingml/2006/main">
@@ -7314,7 +7372,7 @@
                 <a:ea typeface="Arial"/>
                 <a:cs typeface="Arial"/>
               </a:rPr>
-              <a:t>The AP agent advances only when each control state is satisfied</a:t>
+              <a:t>Both subgraphs follow the same governed state pattern</a:t>
             </a:r>
           </a:p>
         </p:txBody>
@@ -7586,7 +7644,7 @@
                 <a:ea typeface="Arial"/>
                 <a:cs typeface="Arial"/>
               </a:rPr>
-              <a:t>Ingest</a:t>
+              <a:t>Register</a:t>
             </a:r>
           </a:p>
         </p:txBody>
@@ -7645,7 +7703,7 @@
                 <a:ea typeface="Arial"/>
                 <a:cs typeface="Arial"/>
               </a:rPr>
-              <a:t>Hash source and classify attachment.</a:t>
+              <a:t>Hash and retain the source envelope.</a:t>
             </a:r>
           </a:p>
         </p:txBody>
@@ -7796,7 +7854,7 @@
                 <a:ea typeface="Arial"/>
                 <a:cs typeface="Arial"/>
               </a:rPr>
-              <a:t>Extract</a:t>
+              <a:t>Normalize</a:t>
             </a:r>
           </a:p>
         </p:txBody>
@@ -7855,7 +7913,7 @@
                 <a:ea typeface="Arial"/>
                 <a:cs typeface="Arial"/>
               </a:rPr>
-              <a:t>Normalize fields, lines, confidence, evidence.</a:t>
+              <a:t>Convert once; classify AP, AR, or unknown.</a:t>
             </a:r>
           </a:p>
         </p:txBody>
@@ -8065,7 +8123,7 @@
                 <a:ea typeface="Arial"/>
                 <a:cs typeface="Arial"/>
               </a:rPr>
-              <a:t>Load relevant finance policies.</a:t>
+              <a:t>Retrieve domain finance policies.</a:t>
             </a:r>
           </a:p>
         </p:txBody>
@@ -8275,7 +8333,7 @@
                 <a:ea typeface="Arial"/>
                 <a:cs typeface="Arial"/>
               </a:rPr>
-              <a:t>Apply PO, GR, tolerance, duplicate rules.</a:t>
+              <a:t>Apply AP or AR deterministic controls.</a:t>
             </a:r>
           </a:p>
         </p:txBody>
@@ -8485,7 +8543,7 @@
                 <a:ea typeface="Arial"/>
                 <a:cs typeface="Arial"/>
               </a:rPr>
-              <a:t>Route named exceptions to a human.</a:t>
+              <a:t>Route domain-safe actions to a human.</a:t>
             </a:r>
           </a:p>
         </p:txBody>
@@ -8695,7 +8753,7 @@
                 <a:ea typeface="Arial"/>
                 <a:cs typeface="Arial"/>
               </a:rPr>
-              <a:t>Send one idempotent ERP journal.</a:t>
+              <a:t>Call one idempotent ERP API.</a:t>
             </a:r>
           </a:p>
         </p:txBody>
@@ -8754,7 +8812,7 @@
                 <a:ea typeface="Arial"/>
                 <a:cs typeface="Arial"/>
               </a:rPr>
-              <a:t>A failed transition creates an exception event; it never silently falls through to posting.</a:t>
+              <a:t>A failed transition creates an exception; corrected AR data must pass the full match again.</a:t>
             </a:r>
           </a:p>
         </p:txBody>
@@ -9943,7 +10001,7 @@
         </p:spPr>
         <p:txBody>
           <a:bodyPr xmlns:a="http://schemas.openxmlformats.org/drawingml/2006/main" wrap="square" lIns="0" tIns="0" rIns="0" bIns="0" anchor="t">
-            <a:normAutofit fontScale="97988"/>
+            <a:normAutofit fontScale="100000"/>
           </a:bodyPr>
           <a:lstStyle xmlns:a="http://schemas.openxmlformats.org/drawingml/2006/main"/>
           <a:p xmlns:a="http://schemas.openxmlformats.org/drawingml/2006/main">
@@ -9967,7 +10025,7 @@
                 <a:ea typeface="Arial"/>
                 <a:cs typeface="Arial"/>
               </a:rPr>
-              <a:t>Exceptions stop money movement and preserve decision context</a:t>
+              <a:t>One exception desk preserves AP and AR decision context</a:t>
             </a:r>
           </a:p>
         </p:txBody>
@@ -10116,7 +10174,7 @@
                 <a:ea typeface="Arial"/>
                 <a:cs typeface="Arial"/>
               </a:rPr>
-              <a:t>Agent-created exception</a:t>
+              <a:t>Domain-created exception</a:t>
             </a:r>
           </a:p>
         </p:txBody>
@@ -10386,7 +10444,7 @@
                 <a:ea typeface="Arial"/>
                 <a:cs typeface="Arial"/>
               </a:rPr>
-              <a:t>PRICE / QTY / ARITHMETIC</a:t>
+              <a:t>AP_PRICE / QTY / ARITHMETIC</a:t>
             </a:r>
           </a:p>
         </p:txBody>
@@ -10476,7 +10534,7 @@
                 <a:ea typeface="Arial"/>
                 <a:cs typeface="Arial"/>
               </a:rPr>
-              <a:t>RECEIPT_SHORTFALL</a:t>
+              <a:t>AR_CURRENCY / AMOUNT / OPEN_ITEM</a:t>
             </a:r>
           </a:p>
         </p:txBody>
@@ -10625,7 +10683,7 @@
                 <a:ea typeface="Arial"/>
                 <a:cs typeface="Arial"/>
               </a:rPr>
-              <a:t>Approve or reject</a:t>
+              <a:t>Domain-safe actions</a:t>
             </a:r>
           </a:p>
         </p:txBody>
@@ -10684,7 +10742,7 @@
                 <a:ea typeface="Arial"/>
                 <a:cs typeface="Arial"/>
               </a:rPr>
-              <a:t>The reviewer sees extracted evidence, match variances, retrieved policy context, and the complete source-linked trail.</a:t>
+              <a:t>AP follows approve/reject policy. AR allows correction and re-match, rejection, or recorded manual resolution.</a:t>
             </a:r>
           </a:p>
         </p:txBody>
@@ -10743,7 +10801,7 @@
                 <a:ea typeface="Arial"/>
                 <a:cs typeface="Arial"/>
               </a:rPr>
-              <a:t>Supplied actor + comment → immutable audit event</a:t>
+              <a:t>Invalid AR matches cannot be approved into cash</a:t>
             </a:r>
           </a:p>
         </p:txBody>
@@ -10802,7 +10860,7 @@
                 <a:ea typeface="Arial"/>
                 <a:cs typeface="Arial"/>
               </a:rPr>
-              <a:t>Approval is a workflow transition—not an override that erases the exception.</a:t>
+              <a:t>Every action retains the original variance, named actor, comment, and resulting state.</a:t>
             </a:r>
           </a:p>
         </p:txBody>
@@ -10949,7 +11007,7 @@
                 <a:ea typeface="Arial"/>
                 <a:cs typeface="Arial"/>
               </a:rPr>
-              <a:t>The AR path mirrors the business outcome for incoming cash</a:t>
+              <a:t>AR now mirrors AP through a separate controlled subgraph</a:t>
             </a:r>
           </a:p>
         </p:txBody>
@@ -11159,7 +11217,7 @@
                 <a:ea typeface="Arial"/>
                 <a:cs typeface="Arial"/>
               </a:rPr>
-              <a:t>Invoice</a:t>
+              <a:t>Canonical invoice</a:t>
             </a:r>
           </a:p>
           <a:p xmlns:a="http://schemas.openxmlformats.org/drawingml/2006/main">
@@ -11207,7 +11265,7 @@
                 <a:ea typeface="Arial"/>
                 <a:cs typeface="Arial"/>
               </a:rPr>
-              <a:t>PO + receipt</a:t>
+              <a:t>AP policy + PO / GR match</a:t>
             </a:r>
           </a:p>
           <a:p xmlns:a="http://schemas.openxmlformats.org/drawingml/2006/main">
@@ -11255,7 +11313,7 @@
                 <a:ea typeface="Arial"/>
                 <a:cs typeface="Arial"/>
               </a:rPr>
-              <a:t>Payment journal</a:t>
+              <a:t>Payment Journal</a:t>
             </a:r>
           </a:p>
         </p:txBody>
@@ -11375,7 +11433,7 @@
                 <a:ea typeface="Arial"/>
                 <a:cs typeface="Arial"/>
               </a:rPr>
-              <a:t>Remittance</a:t>
+              <a:t>Canonical remittance</a:t>
             </a:r>
           </a:p>
           <a:p xmlns:a="http://schemas.openxmlformats.org/drawingml/2006/main">
@@ -11423,7 +11481,7 @@
                 <a:ea typeface="Arial"/>
                 <a:cs typeface="Arial"/>
               </a:rPr>
-              <a:t>Customer + open items</a:t>
+              <a:t>AR policy + open-item match</a:t>
             </a:r>
           </a:p>
           <a:p xmlns:a="http://schemas.openxmlformats.org/drawingml/2006/main">
@@ -11530,7 +11588,7 @@
                 <a:ea typeface="Arial"/>
                 <a:cs typeface="Arial"/>
               </a:rPr>
-              <a:t>AR controls: source ref · exact customer/currency/amount · exception queue · audited result</a:t>
+              <a:t>Shared: convert → classify → retrieve → match → review/post · Separate: domain rules and safe actions</a:t>
             </a:r>
           </a:p>
         </p:txBody>
@@ -11653,7 +11711,7 @@
         </p:spPr>
         <p:txBody>
           <a:bodyPr xmlns:a="http://schemas.openxmlformats.org/drawingml/2006/main" wrap="square" lIns="0" tIns="0" rIns="0" bIns="0" anchor="t">
-            <a:normAutofit fontScale="91993"/>
+            <a:normAutofit fontScale="95522"/>
           </a:bodyPr>
           <a:lstStyle xmlns:a="http://schemas.openxmlformats.org/drawingml/2006/main"/>
           <a:p xmlns:a="http://schemas.openxmlformats.org/drawingml/2006/main">
@@ -11677,7 +11735,7 @@
                 <a:ea typeface="Arial"/>
                 <a:cs typeface="Arial"/>
               </a:rPr>
-              <a:t>Five mandatory APIs expose the controlled workflow and its evidence</a:t>
+              <a:t>Mandatory APIs stay intact while unified APIs expose orchestration</a:t>
             </a:r>
           </a:p>
         </p:txBody>
@@ -13074,7 +13132,7 @@
                 <a:ea typeface="Arial"/>
                 <a:cs typeface="Arial"/>
               </a:rPr>
-              <a:t>Additional endpoints cover mailbox polling, AP exception decisions, review queues, and AR remittance processing.</a:t>
+              <a:t>Added: unified document ingest · generic workflow state · unified exceptions · audited AR correction decisions.</a:t>
             </a:r>
           </a:p>
         </p:txBody>
@@ -13979,7 +14037,7 @@
                 <a:ea typeface="Arial"/>
                 <a:cs typeface="Arial"/>
               </a:rPr>
-              <a:t>Mock ERP adapter</a:t>
+              <a:t>Mock ERP HTTP API</a:t>
             </a:r>
           </a:p>
           <a:p xmlns:a="http://schemas.openxmlformats.org/drawingml/2006/main">

</xml_diff>

<commit_message>
Harden workflow transitions and ERP failure handling
</commit_message>
<xml_diff>
--- a/presentation/LedgerPilot_Assignment_Deck.pptx
+++ b/presentation/LedgerPilot_Assignment_Deck.pptx
@@ -2,24 +2,24 @@
 <file path=ppt/presentation.xml><?xml version="1.0" encoding="utf-8"?>
 <p:presentation xmlns:p="http://schemas.openxmlformats.org/presentationml/2006/main">
   <p:sldMasterIdLst>
-    <p:sldMasterId xmlns:r="http://schemas.openxmlformats.org/officeDocument/2006/relationships" id="2147483648" r:id="R27070bd1df2a44d5"/>
+    <p:sldMasterId xmlns:r="http://schemas.openxmlformats.org/officeDocument/2006/relationships" id="2147483648" r:id="R4927bded7cd645d7"/>
   </p:sldMasterIdLst>
   <p:notesMasterIdLst>
-    <p:notesMasterId xmlns:r="http://schemas.openxmlformats.org/officeDocument/2006/relationships" r:id="Rf36df9da8ea04cb7"/>
+    <p:notesMasterId xmlns:r="http://schemas.openxmlformats.org/officeDocument/2006/relationships" r:id="R6c7ee4bef9524258"/>
   </p:notesMasterIdLst>
   <p:sldIdLst>
-    <p:sldId xmlns:r="http://schemas.openxmlformats.org/officeDocument/2006/relationships" id="256" r:id="R7b74120b6b164179"/>
-    <p:sldId xmlns:r="http://schemas.openxmlformats.org/officeDocument/2006/relationships" id="257" r:id="R9ea1798b9c664aa7"/>
-    <p:sldId xmlns:r="http://schemas.openxmlformats.org/officeDocument/2006/relationships" id="258" r:id="R435774bc707441cc"/>
-    <p:sldId xmlns:r="http://schemas.openxmlformats.org/officeDocument/2006/relationships" id="259" r:id="R1d629c5f6df543d8"/>
-    <p:sldId xmlns:r="http://schemas.openxmlformats.org/officeDocument/2006/relationships" id="260" r:id="R63167b1c6be94de2"/>
-    <p:sldId xmlns:r="http://schemas.openxmlformats.org/officeDocument/2006/relationships" id="261" r:id="R936e42614ce041cb"/>
-    <p:sldId xmlns:r="http://schemas.openxmlformats.org/officeDocument/2006/relationships" id="262" r:id="R274b9b89b1a04410"/>
-    <p:sldId xmlns:r="http://schemas.openxmlformats.org/officeDocument/2006/relationships" id="263" r:id="R1b628ef16759412c"/>
-    <p:sldId xmlns:r="http://schemas.openxmlformats.org/officeDocument/2006/relationships" id="264" r:id="R7db6fe33ff2b4c05"/>
-    <p:sldId xmlns:r="http://schemas.openxmlformats.org/officeDocument/2006/relationships" id="265" r:id="Rae9ebb6b62ba494c"/>
-    <p:sldId xmlns:r="http://schemas.openxmlformats.org/officeDocument/2006/relationships" id="266" r:id="Rf8ccb575532948e6"/>
-    <p:sldId xmlns:r="http://schemas.openxmlformats.org/officeDocument/2006/relationships" id="267" r:id="R6f4c8f90fba14cd8"/>
+    <p:sldId xmlns:r="http://schemas.openxmlformats.org/officeDocument/2006/relationships" id="256" r:id="R7736526166384a7a"/>
+    <p:sldId xmlns:r="http://schemas.openxmlformats.org/officeDocument/2006/relationships" id="257" r:id="Reddf1fd2deed4b31"/>
+    <p:sldId xmlns:r="http://schemas.openxmlformats.org/officeDocument/2006/relationships" id="258" r:id="R228b3c7472ef4139"/>
+    <p:sldId xmlns:r="http://schemas.openxmlformats.org/officeDocument/2006/relationships" id="259" r:id="R127d6e8482624c8c"/>
+    <p:sldId xmlns:r="http://schemas.openxmlformats.org/officeDocument/2006/relationships" id="260" r:id="R4616fc033f1545fd"/>
+    <p:sldId xmlns:r="http://schemas.openxmlformats.org/officeDocument/2006/relationships" id="261" r:id="R07a78f643b3d4680"/>
+    <p:sldId xmlns:r="http://schemas.openxmlformats.org/officeDocument/2006/relationships" id="262" r:id="Rbeff9c2818c941de"/>
+    <p:sldId xmlns:r="http://schemas.openxmlformats.org/officeDocument/2006/relationships" id="263" r:id="Raeab7ad0b85e48c5"/>
+    <p:sldId xmlns:r="http://schemas.openxmlformats.org/officeDocument/2006/relationships" id="264" r:id="R76fb546637024841"/>
+    <p:sldId xmlns:r="http://schemas.openxmlformats.org/officeDocument/2006/relationships" id="265" r:id="R776ce25c18b24e38"/>
+    <p:sldId xmlns:r="http://schemas.openxmlformats.org/officeDocument/2006/relationships" id="266" r:id="R7e646598111b44b7"/>
+    <p:sldId xmlns:r="http://schemas.openxmlformats.org/officeDocument/2006/relationships" id="267" r:id="R96db59bdc1764940"/>
   </p:sldIdLst>
   <p:sldSz cx="12192000" cy="6858000"/>
   <p:notesSz cx="6858000" cy="9144000"/>
@@ -1591,7 +1591,7 @@
   </p:cSld>
   <p:clrMap bg1="lt1" tx1="dk1" bg2="lt2" tx2="dk2" accent1="accent1" accent2="accent2" accent3="accent3" accent4="accent4" accent5="accent5" accent6="accent6" hlink="hlink" folHlink="folHlink"/>
   <p:sldLayoutIdLst>
-    <p:sldLayoutId xmlns:r="http://schemas.openxmlformats.org/officeDocument/2006/relationships" id="2147483649" r:id="R1674c5530236401f"/>
+    <p:sldLayoutId xmlns:r="http://schemas.openxmlformats.org/officeDocument/2006/relationships" id="2147483649" r:id="Re174e5b7f99e4397"/>
   </p:sldLayoutIdLst>
   <p:txStyles>
     <p:titleStyle>
@@ -2413,7 +2413,7 @@
           <p:nvPr/>
         </p:nvPicPr>
         <p:blipFill>
-          <a:blip xmlns:r="http://schemas.openxmlformats.org/officeDocument/2006/relationships" xmlns:a="http://schemas.openxmlformats.org/drawingml/2006/main" r:embed="R63b0cb24ba214104"/>
+          <a:blip xmlns:r="http://schemas.openxmlformats.org/officeDocument/2006/relationships" xmlns:a="http://schemas.openxmlformats.org/drawingml/2006/main" r:embed="R926f1b9ee69748f7"/>
           <a:srcRect xmlns:a="http://schemas.openxmlformats.org/drawingml/2006/main" l="0" t="9434" r="0" b="9434"/>
           <a:stretch xmlns:a="http://schemas.openxmlformats.org/drawingml/2006/main">
             <a:fillRect l="0" t="0" r="0" b="0"/>
@@ -3359,7 +3359,7 @@
                 <a:ea typeface="Arial"/>
                 <a:cs typeface="Arial"/>
               </a:rPr>
-              <a:t>RAGAS retrieval: 100% precision + recall on 4 labeled queries. Next gate: permissioned invoice and remittance pilot.</a:t>
+              <a:t>RAGAS: 88.9% precision + recall on 9 paraphrase, multi-policy, and abstention cases. Next: permissioned pilot.</a:t>
             </a:r>
           </a:p>
         </p:txBody>
@@ -4095,7 +4095,18 @@
                 <a:ea typeface="Arial"/>
                 <a:cs typeface="Arial"/>
               </a:rPr>
-              <a:t>42 tests · AP/AR + RAGAS eval</a:t>
+              <a:t>49 tests</a:t>
+            </a:r>
+            <a:r>
+              <a:rPr sz="1425" b="0">
+                <a:solidFill>
+                  <a:srgbClr val="5E6773"/>
+                </a:solidFill>
+                <a:latin typeface="Arial"/>
+                <a:ea typeface="Arial"/>
+                <a:cs typeface="Arial"/>
+              </a:rPr>
+              <a:t> · AP/AR + RAGAS eval</a:t>
             </a:r>
           </a:p>
         </p:txBody>
@@ -4728,7 +4739,18 @@
                 <a:ea typeface="Arial"/>
                 <a:cs typeface="Arial"/>
               </a:rPr>
-              <a:t>42 tests + AP/AR/RAGAS evaluation + audit chain</a:t>
+              <a:t>49 tests</a:t>
+            </a:r>
+            <a:r>
+              <a:rPr sz="1800" b="0">
+                <a:solidFill>
+                  <a:srgbClr val="5E6773"/>
+                </a:solidFill>
+                <a:latin typeface="Arial"/>
+                <a:ea typeface="Arial"/>
+                <a:cs typeface="Arial"/>
+              </a:rPr>
+              <a:t> + AP/AR/RAGAS evaluation + audit chain</a:t>
             </a:r>
           </a:p>
         </p:txBody>

</xml_diff>

<commit_message>
Make AP and AR workflows mandatory AI agents
</commit_message>
<xml_diff>
--- a/presentation/LedgerPilot_Assignment_Deck.pptx
+++ b/presentation/LedgerPilot_Assignment_Deck.pptx
@@ -2,24 +2,24 @@
 <file path=ppt/presentation.xml><?xml version="1.0" encoding="utf-8"?>
 <p:presentation xmlns:p="http://schemas.openxmlformats.org/presentationml/2006/main">
   <p:sldMasterIdLst>
-    <p:sldMasterId xmlns:r="http://schemas.openxmlformats.org/officeDocument/2006/relationships" id="2147483648" r:id="R4927bded7cd645d7"/>
+    <p:sldMasterId xmlns:r="http://schemas.openxmlformats.org/officeDocument/2006/relationships" id="2147483648" r:id="Rc4f9fc1fb5da47d8"/>
   </p:sldMasterIdLst>
   <p:notesMasterIdLst>
-    <p:notesMasterId xmlns:r="http://schemas.openxmlformats.org/officeDocument/2006/relationships" r:id="R6c7ee4bef9524258"/>
+    <p:notesMasterId xmlns:r="http://schemas.openxmlformats.org/officeDocument/2006/relationships" r:id="R3bbd0d36553f469b"/>
   </p:notesMasterIdLst>
   <p:sldIdLst>
-    <p:sldId xmlns:r="http://schemas.openxmlformats.org/officeDocument/2006/relationships" id="256" r:id="R7736526166384a7a"/>
-    <p:sldId xmlns:r="http://schemas.openxmlformats.org/officeDocument/2006/relationships" id="257" r:id="Reddf1fd2deed4b31"/>
-    <p:sldId xmlns:r="http://schemas.openxmlformats.org/officeDocument/2006/relationships" id="258" r:id="R228b3c7472ef4139"/>
-    <p:sldId xmlns:r="http://schemas.openxmlformats.org/officeDocument/2006/relationships" id="259" r:id="R127d6e8482624c8c"/>
-    <p:sldId xmlns:r="http://schemas.openxmlformats.org/officeDocument/2006/relationships" id="260" r:id="R4616fc033f1545fd"/>
-    <p:sldId xmlns:r="http://schemas.openxmlformats.org/officeDocument/2006/relationships" id="261" r:id="R07a78f643b3d4680"/>
-    <p:sldId xmlns:r="http://schemas.openxmlformats.org/officeDocument/2006/relationships" id="262" r:id="Rbeff9c2818c941de"/>
-    <p:sldId xmlns:r="http://schemas.openxmlformats.org/officeDocument/2006/relationships" id="263" r:id="Raeab7ad0b85e48c5"/>
-    <p:sldId xmlns:r="http://schemas.openxmlformats.org/officeDocument/2006/relationships" id="264" r:id="R76fb546637024841"/>
-    <p:sldId xmlns:r="http://schemas.openxmlformats.org/officeDocument/2006/relationships" id="265" r:id="R776ce25c18b24e38"/>
-    <p:sldId xmlns:r="http://schemas.openxmlformats.org/officeDocument/2006/relationships" id="266" r:id="R7e646598111b44b7"/>
-    <p:sldId xmlns:r="http://schemas.openxmlformats.org/officeDocument/2006/relationships" id="267" r:id="R96db59bdc1764940"/>
+    <p:sldId xmlns:r="http://schemas.openxmlformats.org/officeDocument/2006/relationships" id="256" r:id="Rfff063f0441f48ea"/>
+    <p:sldId xmlns:r="http://schemas.openxmlformats.org/officeDocument/2006/relationships" id="257" r:id="R091960dd67f44fd0"/>
+    <p:sldId xmlns:r="http://schemas.openxmlformats.org/officeDocument/2006/relationships" id="258" r:id="Rd1f86669c4d74d25"/>
+    <p:sldId xmlns:r="http://schemas.openxmlformats.org/officeDocument/2006/relationships" id="259" r:id="R008fa9af3d0d43ec"/>
+    <p:sldId xmlns:r="http://schemas.openxmlformats.org/officeDocument/2006/relationships" id="260" r:id="Rbada69f662b5424a"/>
+    <p:sldId xmlns:r="http://schemas.openxmlformats.org/officeDocument/2006/relationships" id="261" r:id="R82ed033758614354"/>
+    <p:sldId xmlns:r="http://schemas.openxmlformats.org/officeDocument/2006/relationships" id="262" r:id="R2605ae634fce4e6d"/>
+    <p:sldId xmlns:r="http://schemas.openxmlformats.org/officeDocument/2006/relationships" id="263" r:id="Re47d2847d7b24377"/>
+    <p:sldId xmlns:r="http://schemas.openxmlformats.org/officeDocument/2006/relationships" id="264" r:id="R512a4db91b724f46"/>
+    <p:sldId xmlns:r="http://schemas.openxmlformats.org/officeDocument/2006/relationships" id="265" r:id="R1ca2fcd65d214681"/>
+    <p:sldId xmlns:r="http://schemas.openxmlformats.org/officeDocument/2006/relationships" id="266" r:id="Rde6f2672f7464383"/>
+    <p:sldId xmlns:r="http://schemas.openxmlformats.org/officeDocument/2006/relationships" id="267" r:id="R5b162419cb1a4a17"/>
   </p:sldIdLst>
   <p:sldSz cx="12192000" cy="6858000"/>
   <p:notesSz cx="6858000" cy="9144000"/>
@@ -453,7 +453,7 @@
           <a:lstStyle xmlns:a="http://schemas.openxmlformats.org/drawingml/2006/main"/>
           <a:p xmlns:a="http://schemas.openxmlformats.org/drawingml/2006/main">
             <a:r>
-              <a:t>Open with the completed control philosophy: one document layer dispatches to mirrored AP and AR workflows; deterministic policy decides whether money moves.</a:t>
+              <a:t>Open with the completed architecture: a deterministic document processor supplies evidence to a mandatory local supervisor and mirrored AP/AR agents; deterministic controls decide whether money moves.</a:t>
             </a:r>
           </a:p>
           <a:p xmlns:a="http://schemas.openxmlformats.org/drawingml/2006/main">
@@ -468,12 +468,17 @@
           </a:p>
           <a:p xmlns:a="http://schemas.openxmlformats.org/drawingml/2006/main">
             <a:r>
-              <a:t>- AI-Engineer - Assignment.docx — objective, mirrored AP/AR scenario, and required stack.</a:t>
+              <a:t>- AI-Engineer - Assignment.docx — objective and mirrored AP/AR scenario.</a:t>
             </a:r>
           </a:p>
           <a:p xmlns:a="http://schemas.openxmlformats.org/drawingml/2006/main">
             <a:r>
               <a:t>- Project-generated image: presentation/assets/invoice-automation-hero.png.</a:t>
+            </a:r>
+          </a:p>
+          <a:p xmlns:a="http://schemas.openxmlformats.org/drawingml/2006/main">
+            <a:r>
+              <a:t>- https://ollama.com/library/qwen3.5/tags — selected local Qwen model.</a:t>
             </a:r>
           </a:p>
         </p:txBody>
@@ -543,7 +548,7 @@
           <a:lstStyle xmlns:a="http://schemas.openxmlformats.org/drawingml/2006/main"/>
           <a:p xmlns:a="http://schemas.openxmlformats.org/drawingml/2006/main">
             <a:r>
-              <a:t>The controlled fixtures prove regression behavior, not production accuracy. Call out the honest OCR miss, perfect finance decisions, and zero false financial actions.</a:t>
+              <a:t>The live-agent evaluation exercises model extraction/action selection while deterministic controls still determine financial eligibility. Results are regression evidence, not a production accuracy estimate.</a:t>
             </a:r>
           </a:p>
           <a:p xmlns:a="http://schemas.openxmlformats.org/drawingml/2006/main">
@@ -558,22 +563,12 @@
           </a:p>
           <a:p xmlns:a="http://schemas.openxmlformats.org/drawingml/2006/main">
             <a:r>
-              <a:t>- evaluation/results/latest.json — seven-document AP metrics.</a:t>
-            </a:r>
-          </a:p>
-          <a:p xmlns:a="http://schemas.openxmlformats.org/drawingml/2006/main">
-            <a:r>
-              <a:t>- evaluation/results/ar-latest.json — nine-document AR metrics.</a:t>
-            </a:r>
-          </a:p>
-          <a:p xmlns:a="http://schemas.openxmlformats.org/drawingml/2006/main">
-            <a:r>
-              <a:t>- evaluation/results/rag-latest.json — policy retrieval metrics.</a:t>
-            </a:r>
-          </a:p>
-          <a:p xmlns:a="http://schemas.openxmlformats.org/drawingml/2006/main">
-            <a:r>
-              <a:t>- docs/evaluation-report.md — definitions and limitations.</a:t>
+              <a:t>- evaluation/results/latest.json; evaluation/results/ar-latest.json; evaluation/results/rag-latest.json.</a:t>
+            </a:r>
+          </a:p>
+          <a:p xmlns:a="http://schemas.openxmlformats.org/drawingml/2006/main">
+            <a:r>
+              <a:t>- docs/evaluation-report.md; tests/test_agent_runtime.py.</a:t>
             </a:r>
           </a:p>
         </p:txBody>
@@ -643,7 +638,7 @@
           <a:lstStyle xmlns:a="http://schemas.openxmlformats.org/drawingml/2006/main"/>
           <a:p xmlns:a="http://schemas.openxmlformats.org/drawingml/2006/main">
             <a:r>
-              <a:t>The demo proves both domains plus the service boundary: bring up PostgreSQL, Mock ERP, and API; verify contracts and tests; then dispatch AP and AR fixtures.</a:t>
+              <a:t>One Compose command starts the complete required topology, pulls models once, and exposes Swagger, Phoenix, and the Mock ERP for a reviewer-led AP/AR demonstration.</a:t>
             </a:r>
           </a:p>
           <a:p xmlns:a="http://schemas.openxmlformats.org/drawingml/2006/main">
@@ -658,17 +653,7 @@
           </a:p>
           <a:p xmlns:a="http://schemas.openxmlformats.org/drawingml/2006/main">
             <a:r>
-              <a:t>- README.md — quick start and unified API walkthrough.</a:t>
-            </a:r>
-          </a:p>
-          <a:p xmlns:a="http://schemas.openxmlformats.org/drawingml/2006/main">
-            <a:r>
-              <a:t>- Dockerfile; docker-compose.yml — deployment topology.</a:t>
-            </a:r>
-          </a:p>
-          <a:p xmlns:a="http://schemas.openxmlformats.org/drawingml/2006/main">
-            <a:r>
-              <a:t>- scripts/demo.ps1 — AP journal replay and AR cash application demo.</a:t>
+              <a:t>- README.md; Dockerfile; docker-compose.yml; scripts/demo.ps1.</a:t>
             </a:r>
           </a:p>
         </p:txBody>
@@ -738,7 +723,7 @@
           <a:lstStyle xmlns:a="http://schemas.openxmlformats.org/drawingml/2006/main"/>
           <a:p xmlns:a="http://schemas.openxmlformats.org/drawingml/2006/main">
             <a:r>
-              <a:t>Close on the production evidence-building step: vendor-specific ERP integration and permissioned AP/AR documents.</a:t>
+              <a:t>Close on the evidence-building step: run permissioned vendor and remittance documents against a real ERP sandbox after the controlled local demonstration.</a:t>
             </a:r>
           </a:p>
           <a:p xmlns:a="http://schemas.openxmlformats.org/drawingml/2006/main">
@@ -753,17 +738,7 @@
           </a:p>
           <a:p xmlns:a="http://schemas.openxmlformats.org/drawingml/2006/main">
             <a:r>
-              <a:t>- docs/traceability-matrix.md — assignment-to-artifact mapping.</a:t>
-            </a:r>
-          </a:p>
-          <a:p xmlns:a="http://schemas.openxmlformats.org/drawingml/2006/main">
-            <a:r>
-              <a:t>- docs/evaluation-report.md — production pilot plan and limitations.</a:t>
-            </a:r>
-          </a:p>
-          <a:p xmlns:a="http://schemas.openxmlformats.org/drawingml/2006/main">
-            <a:r>
-              <a:t>- Repository root — complete submission package.</a:t>
+              <a:t>- docs/traceability-matrix.md; docs/evaluation-report.md; repository root.</a:t>
             </a:r>
           </a:p>
         </p:txBody>
@@ -918,7 +893,7 @@
           <a:lstStyle xmlns:a="http://schemas.openxmlformats.org/drawingml/2006/main"/>
           <a:p xmlns:a="http://schemas.openxmlformats.org/drawingml/2006/main">
             <a:r>
-              <a:t>Walk left to right: conversion and classification happen once, then the parent graph dispatches into a domain subgraph. The bottom rail receives evidence from every stage.</a:t>
+              <a:t>Walk left to right: the document processor is a tool, Qwen supervises routing, and bounded AP/AR agents invoke policy and ERP tools. The bottom rail retains every decision and evidence item.</a:t>
             </a:r>
           </a:p>
           <a:p xmlns:a="http://schemas.openxmlformats.org/drawingml/2006/main">
@@ -933,17 +908,22 @@
           </a:p>
           <a:p xmlns:a="http://schemas.openxmlformats.org/drawingml/2006/main">
             <a:r>
-              <a:t>- app/document_processing.py; app/orchestrator.py — canonical processing and conditional dispatch.</a:t>
-            </a:r>
-          </a:p>
-          <a:p xmlns:a="http://schemas.openxmlformats.org/drawingml/2006/main">
-            <a:r>
-              <a:t>- app/workflow.py; app/ar_workflow.py — AP and AR subgraphs.</a:t>
-            </a:r>
-          </a:p>
-          <a:p xmlns:a="http://schemas.openxmlformats.org/drawingml/2006/main">
-            <a:r>
-              <a:t>- app/mock_erp_api.py; docker-compose.yml — separate HTTP Mock ERP service.</a:t>
+              <a:t>- app/document_processing.py; app/agent_runtime.py; app/orchestrator.py.</a:t>
+            </a:r>
+          </a:p>
+          <a:p xmlns:a="http://schemas.openxmlformats.org/drawingml/2006/main">
+            <a:r>
+              <a:t>- app/workflow.py; app/ar_workflow.py; app/context.py.</a:t>
+            </a:r>
+          </a:p>
+          <a:p xmlns:a="http://schemas.openxmlformats.org/drawingml/2006/main">
+            <a:r>
+              <a:t>- https://ollama.com/library/qwen3.5/tags.</a:t>
+            </a:r>
+          </a:p>
+          <a:p xmlns:a="http://schemas.openxmlformats.org/drawingml/2006/main">
+            <a:r>
+              <a:t>- https://ollama.com/library/embeddinggemma.</a:t>
             </a:r>
           </a:p>
         </p:txBody>
@@ -1013,7 +993,7 @@
           <a:lstStyle xmlns:a="http://schemas.openxmlformats.org/drawingml/2006/main"/>
           <a:p xmlns:a="http://schemas.openxmlformats.org/drawingml/2006/main">
             <a:r>
-              <a:t>The parent graph owns classification and dispatch. Both subgraphs retrieve context, run deterministic controls, and choose post or review; their domain rules remain separate.</a:t>
+              <a:t>The fixed graphs bound the lifecycle. The model selects only schema-valid, stage-allow-listed actions; deterministic matching and posting guards remain authoritative.</a:t>
             </a:r>
           </a:p>
           <a:p xmlns:a="http://schemas.openxmlformats.org/drawingml/2006/main">
@@ -1028,17 +1008,12 @@
           </a:p>
           <a:p xmlns:a="http://schemas.openxmlformats.org/drawingml/2006/main">
             <a:r>
-              <a:t>- app/orchestrator.py — parent graph nodes and conditional routes.</a:t>
-            </a:r>
-          </a:p>
-          <a:p xmlns:a="http://schemas.openxmlformats.org/drawingml/2006/main">
-            <a:r>
-              <a:t>- app/workflow.py; app/ar_workflow.py — mirrored subgraph state transitions.</a:t>
-            </a:r>
-          </a:p>
-          <a:p xmlns:a="http://schemas.openxmlformats.org/drawingml/2006/main">
-            <a:r>
-              <a:t>- app/repository.py — durable generic finance workflow state.</a:t>
+              <a:t>- app/agent_runtime.py — structured decision contracts and allow-lists.</a:t>
+            </a:r>
+          </a:p>
+          <a:p xmlns:a="http://schemas.openxmlformats.org/drawingml/2006/main">
+            <a:r>
+              <a:t>- app/orchestrator.py; app/workflow.py; app/ar_workflow.py — fixed mirrored graph transitions.</a:t>
             </a:r>
           </a:p>
         </p:txBody>
@@ -1298,7 +1273,7 @@
           <a:lstStyle xmlns:a="http://schemas.openxmlformats.org/drawingml/2006/main"/>
           <a:p xmlns:a="http://schemas.openxmlformats.org/drawingml/2006/main">
             <a:r>
-              <a:t>This is the literal mirror: AP and AR share the orchestration pattern and evidence model, while each subgraph enforces its own financial controls.</a:t>
+              <a:t>This is the literal mirror: both domains receive processor evidence, supervisor dispatch, semantic policy context, current ERP facts, a model decision, deterministic guard validation, and an audited action.</a:t>
             </a:r>
           </a:p>
           <a:p xmlns:a="http://schemas.openxmlformats.org/drawingml/2006/main">
@@ -1313,22 +1288,12 @@
           </a:p>
           <a:p xmlns:a="http://schemas.openxmlformats.org/drawingml/2006/main">
             <a:r>
-              <a:t>- app/document_processing.py; app/orchestrator.py — shared layer and parent dispatch.</a:t>
-            </a:r>
-          </a:p>
-          <a:p xmlns:a="http://schemas.openxmlformats.org/drawingml/2006/main">
-            <a:r>
-              <a:t>- app/workflow.py — AP subgraph.</a:t>
-            </a:r>
-          </a:p>
-          <a:p xmlns:a="http://schemas.openxmlformats.org/drawingml/2006/main">
-            <a:r>
-              <a:t>- app/ar_workflow.py; app/ar_matching.py — AR subgraph and deterministic allocation.</a:t>
-            </a:r>
-          </a:p>
-          <a:p xmlns:a="http://schemas.openxmlformats.org/drawingml/2006/main">
-            <a:r>
-              <a:t>- tests/test_orchestrator.py; tests/test_ar_workflow.py — executable evidence.</a:t>
+              <a:t>- app/orchestrator.py; app/workflow.py; app/ar_workflow.py.</a:t>
+            </a:r>
+          </a:p>
+          <a:p xmlns:a="http://schemas.openxmlformats.org/drawingml/2006/main">
+            <a:r>
+              <a:t>- tests/test_orchestrator.py; tests/test_agent_runtime.py.</a:t>
             </a:r>
           </a:p>
         </p:txBody>
@@ -1398,7 +1363,7 @@
           <a:lstStyle xmlns:a="http://schemas.openxmlformats.org/drawingml/2006/main"/>
           <a:p xmlns:a="http://schemas.openxmlformats.org/drawingml/2006/main">
             <a:r>
-              <a:t>The five required contracts remain unchanged. Additive endpoints demonstrate cross-domain dispatch and mirrored AR review without breaking the assignment walkthrough.</a:t>
+              <a:t>The five required contracts remain intact. Their evidence now includes supervisor/domain decisions and required-model health without breaking the assignment walkthrough.</a:t>
             </a:r>
           </a:p>
           <a:p xmlns:a="http://schemas.openxmlformats.org/drawingml/2006/main">
@@ -1413,17 +1378,12 @@
           </a:p>
           <a:p xmlns:a="http://schemas.openxmlformats.org/drawingml/2006/main">
             <a:r>
-              <a:t>- openapi/openapi.yaml — generated, versioned finance API contract.</a:t>
-            </a:r>
-          </a:p>
-          <a:p xmlns:a="http://schemas.openxmlformats.org/drawingml/2006/main">
-            <a:r>
-              <a:t>- openapi/mock-erp-openapi.yaml — generated ERP sandbox contract.</a:t>
-            </a:r>
-          </a:p>
-          <a:p xmlns:a="http://schemas.openxmlformats.org/drawingml/2006/main">
-            <a:r>
-              <a:t>- app/api.py — FastAPI implementation.</a:t>
+              <a:t>- openapi/openapi.yaml; app/api.py.</a:t>
+            </a:r>
+          </a:p>
+          <a:p xmlns:a="http://schemas.openxmlformats.org/drawingml/2006/main">
+            <a:r>
+              <a:t>- app/agent_runtime.py; app/observability.py.</a:t>
             </a:r>
           </a:p>
         </p:txBody>
@@ -1493,7 +1453,7 @@
           <a:lstStyle xmlns:a="http://schemas.openxmlformats.org/drawingml/2006/main"/>
           <a:p xmlns:a="http://schemas.openxmlformats.org/drawingml/2006/main">
             <a:r>
-              <a:t>Point to concrete implementation evidence for every mandatory technology. The ERP requirement is now met through a separate HTTP Mock API rather than only an in-process adapter.</a:t>
+              <a:t>Every required technology is active in the default stack. Ollama, both models, and Phoenix are startup dependencies rather than optional profiles.</a:t>
             </a:r>
           </a:p>
           <a:p xmlns:a="http://schemas.openxmlformats.org/drawingml/2006/main">
@@ -1508,22 +1468,22 @@
           </a:p>
           <a:p xmlns:a="http://schemas.openxmlformats.org/drawingml/2006/main">
             <a:r>
-              <a:t>- AI-Engineer - Assignment.docx — mandatory technology stack.</a:t>
-            </a:r>
-          </a:p>
-          <a:p xmlns:a="http://schemas.openxmlformats.org/drawingml/2006/main">
-            <a:r>
-              <a:t>- pyproject.toml; app/context.py — pinned stack and retrieval implementation.</a:t>
-            </a:r>
-          </a:p>
-          <a:p xmlns:a="http://schemas.openxmlformats.org/drawingml/2006/main">
-            <a:r>
-              <a:t>- app/mock_erp_api.py; docker-compose.yml — Mock ERP API service.</a:t>
-            </a:r>
-          </a:p>
-          <a:p xmlns:a="http://schemas.openxmlformats.org/drawingml/2006/main">
-            <a:r>
-              <a:t>- evaluation/results/rag-latest.json.</a:t>
+              <a:t>- docker-compose.yml; pyproject.toml; app/context.py; app/observability.py.</a:t>
+            </a:r>
+          </a:p>
+          <a:p xmlns:a="http://schemas.openxmlformats.org/drawingml/2006/main">
+            <a:r>
+              <a:t>- https://ollama.com/library/qwen3.5/tags.</a:t>
+            </a:r>
+          </a:p>
+          <a:p xmlns:a="http://schemas.openxmlformats.org/drawingml/2006/main">
+            <a:r>
+              <a:t>- https://ollama.com/library/embeddinggemma.</a:t>
+            </a:r>
+          </a:p>
+          <a:p xmlns:a="http://schemas.openxmlformats.org/drawingml/2006/main">
+            <a:r>
+              <a:t>- https://github.com/ollama/ollama/releases.</a:t>
             </a:r>
           </a:p>
         </p:txBody>
@@ -1591,7 +1551,7 @@
   </p:cSld>
   <p:clrMap bg1="lt1" tx1="dk1" bg2="lt2" tx2="dk2" accent1="accent1" accent2="accent2" accent3="accent3" accent4="accent4" accent5="accent5" accent6="accent6" hlink="hlink" folHlink="folHlink"/>
   <p:sldLayoutIdLst>
-    <p:sldLayoutId xmlns:r="http://schemas.openxmlformats.org/officeDocument/2006/relationships" id="2147483649" r:id="Re174e5b7f99e4397"/>
+    <p:sldLayoutId xmlns:r="http://schemas.openxmlformats.org/officeDocument/2006/relationships" id="2147483649" r:id="Ra35a0caf48b24b11"/>
   </p:sldLayoutIdLst>
   <p:txStyles>
     <p:titleStyle>
@@ -2309,7 +2269,7 @@
                 <a:ea typeface="Arial"/>
                 <a:cs typeface="Arial"/>
               </a:rPr>
-              <a:t>A runnable AP + AR prototype with shared document intelligence, mirrored agentic workflows, deterministic controls, and an HTTP Mock ERP.</a:t>
+              <a:t>A runnable AP + AR prototype with a mandatory local supervisor, mirrored finance agents, deterministic controls, and an HTTP Mock ERP.</a:t>
             </a:r>
           </a:p>
         </p:txBody>
@@ -2399,7 +2359,7 @@
                 <a:ea typeface="Arial"/>
                 <a:cs typeface="Arial"/>
               </a:rPr>
-              <a:t>LedgerPilot · FastAPI · LangGraph · Docling · Mock ERP API</a:t>
+              <a:t>LedgerPilot · Qwen 3.5 · LangGraph · Semantic RAG · Mock ERP</a:t>
             </a:r>
           </a:p>
         </p:txBody>
@@ -2413,7 +2373,7 @@
           <p:nvPr/>
         </p:nvPicPr>
         <p:blipFill>
-          <a:blip xmlns:r="http://schemas.openxmlformats.org/officeDocument/2006/relationships" xmlns:a="http://schemas.openxmlformats.org/drawingml/2006/main" r:embed="R926f1b9ee69748f7"/>
+          <a:blip xmlns:r="http://schemas.openxmlformats.org/officeDocument/2006/relationships" xmlns:a="http://schemas.openxmlformats.org/drawingml/2006/main" r:embed="R47c46ef212a942cd"/>
           <a:srcRect xmlns:a="http://schemas.openxmlformats.org/drawingml/2006/main" l="0" t="9434" r="0" b="9434"/>
           <a:stretch xmlns:a="http://schemas.openxmlformats.org/drawingml/2006/main">
             <a:fillRect l="0" t="0" r="0" b="0"/>
@@ -2608,7 +2568,7 @@
         </p:spPr>
         <p:txBody>
           <a:bodyPr xmlns:a="http://schemas.openxmlformats.org/drawingml/2006/main" wrap="square" lIns="0" tIns="0" rIns="0" bIns="0" anchor="t">
-            <a:normAutofit fontScale="85564"/>
+            <a:normAutofit fontScale="91851"/>
           </a:bodyPr>
           <a:lstStyle xmlns:a="http://schemas.openxmlformats.org/drawingml/2006/main"/>
           <a:p xmlns:a="http://schemas.openxmlformats.org/drawingml/2006/main">
@@ -2632,7 +2592,7 @@
                 <a:ea typeface="Arial"/>
                 <a:cs typeface="Arial"/>
               </a:rPr>
-              <a:t>Two benchmarks prove controlled behavior—not production generalization</a:t>
+              <a:t>Live-agent benchmarks prove controlled behavior—not generalization</a:t>
             </a:r>
           </a:p>
         </p:txBody>
@@ -2781,7 +2741,7 @@
                 <a:ea typeface="Arial"/>
                 <a:cs typeface="Arial"/>
               </a:rPr>
-              <a:t>16 synthetic documents: AP 7 + AR 9 across JSON, text, PDF, scan, HTML, and controlled exceptions.</a:t>
+              <a:t>16 live-agent documents · AP extraction 88.6% · AR extraction 94.4% · decisions 100%.</a:t>
             </a:r>
           </a:p>
         </p:txBody>
@@ -3044,7 +3004,7 @@
                 <a:ea typeface="Arial"/>
                 <a:cs typeface="Arial"/>
               </a:rPr>
-              <a:t>97.2%</a:t>
+              <a:t>94.4%</a:t>
             </a:r>
           </a:p>
         </p:txBody>
@@ -3127,7 +3087,7 @@
                 <a:ea typeface="Arial"/>
                 <a:cs typeface="Arial"/>
               </a:rPr>
-              <a:t>35 / 36 labels</a:t>
+              <a:t>34 / 36 labels</a:t>
             </a:r>
           </a:p>
         </p:txBody>
@@ -3359,7 +3319,7 @@
                 <a:ea typeface="Arial"/>
                 <a:cs typeface="Arial"/>
               </a:rPr>
-              <a:t>RAGAS: 88.9% precision + recall on 9 paraphrase, multi-policy, and abstention cases. Next: permissioned pilot.</a:t>
+              <a:t>RAGAS: 88.9% precision + recall across 9 queries. 53 tests pass. Next: a permissioned pilot.</a:t>
             </a:r>
           </a:p>
         </p:txBody>
@@ -3837,7 +3797,7 @@
                 <a:ea typeface="Arial"/>
                 <a:cs typeface="Arial"/>
               </a:rPr>
-              <a:t>docker compose up --build</a:t>
+              <a:t>docker compose up --build -d</a:t>
             </a:r>
           </a:p>
           <a:p xmlns:a="http://schemas.openxmlformats.org/drawingml/2006/main">
@@ -3861,7 +3821,7 @@
                 <a:ea typeface="Arial"/>
                 <a:cs typeface="Arial"/>
               </a:rPr>
-              <a:t>-d postgres mock-erp api</a:t>
+              <a:t>pulls Qwen + embedding model</a:t>
             </a:r>
           </a:p>
         </p:txBody>
@@ -4071,7 +4031,7 @@
                 <a:ea typeface="Arial"/>
                 <a:cs typeface="Arial"/>
               </a:rPr>
-              <a:t>/health · docs · ERP health</a:t>
+              <a:t>/health · docs · ERP · Phoenix</a:t>
             </a:r>
           </a:p>
           <a:p xmlns:a="http://schemas.openxmlformats.org/drawingml/2006/main">
@@ -4095,18 +4055,7 @@
                 <a:ea typeface="Arial"/>
                 <a:cs typeface="Arial"/>
               </a:rPr>
-              <a:t>49 tests</a:t>
-            </a:r>
-            <a:r>
-              <a:rPr sz="1425" b="0">
-                <a:solidFill>
-                  <a:srgbClr val="5E6773"/>
-                </a:solidFill>
-                <a:latin typeface="Arial"/>
-                <a:ea typeface="Arial"/>
-                <a:cs typeface="Arial"/>
-              </a:rPr>
-              <a:t> · AP/AR + RAGAS eval</a:t>
+              <a:t>53 tests · live AP/AR + RAGAS eval</a:t>
             </a:r>
           </a:p>
         </p:txBody>
@@ -4316,7 +4265,7 @@
                 <a:ea typeface="Arial"/>
                 <a:cs typeface="Arial"/>
               </a:rPr>
-              <a:t>unified ingest → AP / AR dispatch</a:t>
+              <a:t>unified ingest → supervisor → AP / AR</a:t>
             </a:r>
           </a:p>
           <a:p xmlns:a="http://schemas.openxmlformats.org/drawingml/2006/main">
@@ -4340,7 +4289,7 @@
                 <a:ea typeface="Arial"/>
                 <a:cs typeface="Arial"/>
               </a:rPr>
-              <a:t>journal + cash → inspect audit</a:t>
+              <a:t>journal + cash → traces + audit</a:t>
             </a:r>
           </a:p>
         </p:txBody>
@@ -4430,7 +4379,7 @@
                 <a:ea typeface="Arial"/>
                 <a:cs typeface="Arial"/>
               </a:rPr>
-              <a:t>Optional profiles add Ollama and Phoenix; the deterministic core remains demoable without them.</a:t>
+              <a:t>Mandatory Qwen, EmbeddingGemma, and Phoenix fail closed when unavailable.</a:t>
             </a:r>
           </a:p>
         </p:txBody>
@@ -4577,7 +4526,7 @@
                 <a:ea typeface="Arial"/>
                 <a:cs typeface="Arial"/>
               </a:rPr>
-              <a:t>Ready to demonstrate mirrored AP and AR agentic workflows</a:t>
+              <a:t>Ready to demonstrate real agent-driven AP and AR workflows</a:t>
             </a:r>
           </a:p>
         </p:txBody>
@@ -4667,7 +4616,7 @@
                 <a:ea typeface="Arial"/>
                 <a:cs typeface="Arial"/>
               </a:rPr>
-              <a:t>Shared document intelligence + parent orchestrator</a:t>
+              <a:t>Deterministic processor tool + Qwen supervisor</a:t>
             </a:r>
           </a:p>
           <a:p xmlns:a="http://schemas.openxmlformats.org/drawingml/2006/main">
@@ -4691,7 +4640,7 @@
                 <a:ea typeface="Arial"/>
                 <a:cs typeface="Arial"/>
               </a:rPr>
-              <a:t>Mirrored AP and AR LangGraph subflows</a:t>
+              <a:t>Mirrored AP and AR observe-reason-act agents</a:t>
             </a:r>
           </a:p>
           <a:p xmlns:a="http://schemas.openxmlformats.org/drawingml/2006/main">
@@ -4715,7 +4664,7 @@
                 <a:ea typeface="Arial"/>
                 <a:cs typeface="Arial"/>
               </a:rPr>
-              <a:t>Separate HTTP Mock ERP + versioned contracts</a:t>
+              <a:t>Semantic RAG + Mock ERP + Phoenix traces</a:t>
             </a:r>
           </a:p>
           <a:p xmlns:a="http://schemas.openxmlformats.org/drawingml/2006/main">
@@ -4739,18 +4688,7 @@
                 <a:ea typeface="Arial"/>
                 <a:cs typeface="Arial"/>
               </a:rPr>
-              <a:t>49 tests</a:t>
-            </a:r>
-            <a:r>
-              <a:rPr sz="1800" b="0">
-                <a:solidFill>
-                  <a:srgbClr val="5E6773"/>
-                </a:solidFill>
-                <a:latin typeface="Arial"/>
-                <a:ea typeface="Arial"/>
-                <a:cs typeface="Arial"/>
-              </a:rPr>
-              <a:t> + AP/AR/RAGAS evaluation + audit chain</a:t>
+              <a:t>53 tests + live AP/AR/RAGAS gates + audit chain</a:t>
             </a:r>
           </a:p>
         </p:txBody>
@@ -5897,7 +5835,7 @@
         </p:spPr>
         <p:txBody>
           <a:bodyPr xmlns:a="http://schemas.openxmlformats.org/drawingml/2006/main" wrap="square" lIns="0" tIns="0" rIns="0" bIns="0" anchor="t">
-            <a:normAutofit fontScale="100000"/>
+            <a:normAutofit fontScale="95151"/>
           </a:bodyPr>
           <a:lstStyle xmlns:a="http://schemas.openxmlformats.org/drawingml/2006/main"/>
           <a:p xmlns:a="http://schemas.openxmlformats.org/drawingml/2006/main">
@@ -5921,7 +5859,7 @@
                 <a:ea typeface="Arial"/>
                 <a:cs typeface="Arial"/>
               </a:rPr>
-              <a:t>One parent graph dispatches shared documents to AP and AR</a:t>
+              <a:t>One supervisor dispatches evidence to bounded AP and AR agents</a:t>
             </a:r>
           </a:p>
         </p:txBody>
@@ -6553,7 +6491,7 @@
                 <a:ea typeface="Arial"/>
                 <a:cs typeface="Arial"/>
               </a:rPr>
-              <a:t>Normalize</a:t>
+              <a:t>Process</a:t>
             </a:r>
           </a:p>
         </p:txBody>
@@ -6612,7 +6550,7 @@
                 <a:ea typeface="Arial"/>
                 <a:cs typeface="Arial"/>
               </a:rPr>
-              <a:t>Canonical document</a:t>
+              <a:t>Canonical text</a:t>
             </a:r>
           </a:p>
           <a:p xmlns:a="http://schemas.openxmlformats.org/drawingml/2006/main">
@@ -6636,7 +6574,7 @@
                 <a:ea typeface="Arial"/>
                 <a:cs typeface="Arial"/>
               </a:rPr>
-              <a:t>AP / AR / unknown</a:t>
+              <a:t>Evidence + confidence</a:t>
             </a:r>
           </a:p>
         </p:txBody>
@@ -6726,7 +6664,7 @@
                 <a:ea typeface="Arial"/>
                 <a:cs typeface="Arial"/>
               </a:rPr>
-              <a:t>Dispatch</a:t>
+              <a:t>Supervise</a:t>
             </a:r>
           </a:p>
         </p:txBody>
@@ -6785,7 +6723,7 @@
                 <a:ea typeface="Arial"/>
                 <a:cs typeface="Arial"/>
               </a:rPr>
-              <a:t>Parent LangGraph</a:t>
+              <a:t>Qwen 3.5 agent</a:t>
             </a:r>
           </a:p>
           <a:p xmlns:a="http://schemas.openxmlformats.org/drawingml/2006/main">
@@ -6809,7 +6747,7 @@
                 <a:ea typeface="Arial"/>
                 <a:cs typeface="Arial"/>
               </a:rPr>
-              <a:t>AP + AR subgraphs</a:t>
+              <a:t>AP / AR / escalate</a:t>
             </a:r>
           </a:p>
         </p:txBody>
@@ -6899,7 +6837,7 @@
                 <a:ea typeface="Arial"/>
                 <a:cs typeface="Arial"/>
               </a:rPr>
-              <a:t>Control</a:t>
+              <a:t>Act</a:t>
             </a:r>
           </a:p>
         </p:txBody>
@@ -6958,7 +6896,7 @@
                 <a:ea typeface="Arial"/>
                 <a:cs typeface="Arial"/>
               </a:rPr>
-              <a:t>PO + GR</a:t>
+              <a:t>Bounded tools</a:t>
             </a:r>
           </a:p>
           <a:p xmlns:a="http://schemas.openxmlformats.org/drawingml/2006/main">
@@ -6982,7 +6920,7 @@
                 <a:ea typeface="Arial"/>
                 <a:cs typeface="Arial"/>
               </a:rPr>
-              <a:t>Open AR items</a:t>
+              <a:t>Deterministic guards</a:t>
             </a:r>
           </a:p>
         </p:txBody>
@@ -7247,7 +7185,7 @@
                 <a:ea typeface="Arial"/>
                 <a:cs typeface="Arial"/>
               </a:rPr>
-              <a:t>POSTGRESQL + PGVECTOR · GENERIC WORKFLOW STATE · HASH-CHAINED AUDIT</a:t>
+              <a:t>POSTGRESQL + PGVECTOR · AGENT DECISIONS · TOOL EVIDENCE · HASH-CHAINED AUDIT</a:t>
             </a:r>
           </a:p>
         </p:txBody>
@@ -7370,7 +7308,7 @@
         </p:spPr>
         <p:txBody>
           <a:bodyPr xmlns:a="http://schemas.openxmlformats.org/drawingml/2006/main" wrap="square" lIns="0" tIns="0" rIns="0" bIns="0" anchor="t">
-            <a:normAutofit fontScale="100000"/>
+            <a:normAutofit fontScale="96767"/>
           </a:bodyPr>
           <a:lstStyle xmlns:a="http://schemas.openxmlformats.org/drawingml/2006/main"/>
           <a:p xmlns:a="http://schemas.openxmlformats.org/drawingml/2006/main">
@@ -7394,7 +7332,7 @@
                 <a:ea typeface="Arial"/>
                 <a:cs typeface="Arial"/>
               </a:rPr>
-              <a:t>Both subgraphs follow the same governed state pattern</a:t>
+              <a:t>Both agents follow the same governed observe-reason-act pattern</a:t>
             </a:r>
           </a:p>
         </p:txBody>
@@ -7876,7 +7814,7 @@
                 <a:ea typeface="Arial"/>
                 <a:cs typeface="Arial"/>
               </a:rPr>
-              <a:t>Normalize</a:t>
+              <a:t>Process</a:t>
             </a:r>
           </a:p>
         </p:txBody>
@@ -7935,7 +7873,7 @@
                 <a:ea typeface="Arial"/>
                 <a:cs typeface="Arial"/>
               </a:rPr>
-              <a:t>Convert once; classify AP, AR, or unknown.</a:t>
+              <a:t>Convert once; retain evidence and candidates.</a:t>
             </a:r>
           </a:p>
         </p:txBody>
@@ -8086,7 +8024,7 @@
                 <a:ea typeface="Arial"/>
                 <a:cs typeface="Arial"/>
               </a:rPr>
-              <a:t>Retrieve</a:t>
+              <a:t>Supervise</a:t>
             </a:r>
           </a:p>
         </p:txBody>
@@ -8145,7 +8083,7 @@
                 <a:ea typeface="Arial"/>
                 <a:cs typeface="Arial"/>
               </a:rPr>
-              <a:t>Retrieve domain finance policies.</a:t>
+              <a:t>Qwen routes AP, AR, or review.</a:t>
             </a:r>
           </a:p>
         </p:txBody>
@@ -8296,7 +8234,7 @@
                 <a:ea typeface="Arial"/>
                 <a:cs typeface="Arial"/>
               </a:rPr>
-              <a:t>Match</a:t>
+              <a:t>Retrieve</a:t>
             </a:r>
           </a:p>
         </p:txBody>
@@ -8355,7 +8293,7 @@
                 <a:ea typeface="Arial"/>
                 <a:cs typeface="Arial"/>
               </a:rPr>
-              <a:t>Apply AP or AR deterministic controls.</a:t>
+              <a:t>Agent invokes semantic policy RAG.</a:t>
             </a:r>
           </a:p>
         </p:txBody>
@@ -8506,7 +8444,7 @@
                 <a:ea typeface="Arial"/>
                 <a:cs typeface="Arial"/>
               </a:rPr>
-              <a:t>Review</a:t>
+              <a:t>Observe</a:t>
             </a:r>
           </a:p>
         </p:txBody>
@@ -8565,7 +8503,7 @@
                 <a:ea typeface="Arial"/>
                 <a:cs typeface="Arial"/>
               </a:rPr>
-              <a:t>Route domain-safe actions to a human.</a:t>
+              <a:t>Run ERP facts through domain controls.</a:t>
             </a:r>
           </a:p>
         </p:txBody>
@@ -8716,7 +8654,7 @@
                 <a:ea typeface="Arial"/>
                 <a:cs typeface="Arial"/>
               </a:rPr>
-              <a:t>Post</a:t>
+              <a:t>Act</a:t>
             </a:r>
           </a:p>
         </p:txBody>
@@ -8775,7 +8713,7 @@
                 <a:ea typeface="Arial"/>
                 <a:cs typeface="Arial"/>
               </a:rPr>
-              <a:t>Call one idempotent ERP API.</a:t>
+              <a:t>Post, apply, or escalate safely.</a:t>
             </a:r>
           </a:p>
         </p:txBody>
@@ -8834,7 +8772,7 @@
                 <a:ea typeface="Arial"/>
                 <a:cs typeface="Arial"/>
               </a:rPr>
-              <a:t>A failed transition creates an exception; corrected AR data must pass the full match again.</a:t>
+              <a:t>Every model action is schema-valid, allow-listed, audited, and blocked by deterministic guards.</a:t>
             </a:r>
           </a:p>
         </p:txBody>
@@ -11029,7 +10967,7 @@
                 <a:ea typeface="Arial"/>
                 <a:cs typeface="Arial"/>
               </a:rPr>
-              <a:t>AR now mirrors AP through a separate controlled subgraph</a:t>
+              <a:t>AR mirrors AP through a controlled agent subgraph</a:t>
             </a:r>
           </a:p>
         </p:txBody>
@@ -11239,7 +11177,7 @@
                 <a:ea typeface="Arial"/>
                 <a:cs typeface="Arial"/>
               </a:rPr>
-              <a:t>Canonical invoice</a:t>
+              <a:t>Invoice evidence</a:t>
             </a:r>
           </a:p>
           <a:p xmlns:a="http://schemas.openxmlformats.org/drawingml/2006/main">
@@ -11287,7 +11225,7 @@
                 <a:ea typeface="Arial"/>
                 <a:cs typeface="Arial"/>
               </a:rPr>
-              <a:t>AP policy + PO / GR match</a:t>
+              <a:t>AP agent + policy + PO / GR</a:t>
             </a:r>
           </a:p>
           <a:p xmlns:a="http://schemas.openxmlformats.org/drawingml/2006/main">
@@ -11455,7 +11393,7 @@
                 <a:ea typeface="Arial"/>
                 <a:cs typeface="Arial"/>
               </a:rPr>
-              <a:t>Canonical remittance</a:t>
+              <a:t>Remittance evidence</a:t>
             </a:r>
           </a:p>
           <a:p xmlns:a="http://schemas.openxmlformats.org/drawingml/2006/main">
@@ -11503,7 +11441,7 @@
                 <a:ea typeface="Arial"/>
                 <a:cs typeface="Arial"/>
               </a:rPr>
-              <a:t>AR policy + open-item match</a:t>
+              <a:t>AR agent + policy + open items</a:t>
             </a:r>
           </a:p>
           <a:p xmlns:a="http://schemas.openxmlformats.org/drawingml/2006/main">
@@ -11610,7 +11548,7 @@
                 <a:ea typeface="Arial"/>
                 <a:cs typeface="Arial"/>
               </a:rPr>
-              <a:t>Shared: convert → classify → retrieve → match → review/post · Separate: domain rules and safe actions</a:t>
+              <a:t>Shared: process → supervise → retrieve → observe → decide → act · Separate: domain rules and safe tools</a:t>
             </a:r>
           </a:p>
         </p:txBody>
@@ -12232,7 +12170,7 @@
                 <a:ea typeface="Arial"/>
                 <a:cs typeface="Arial"/>
               </a:rPr>
-              <a:t>source hash + extracted invoice</a:t>
+              <a:t>source hash + supervisor decision</a:t>
             </a:r>
           </a:p>
         </p:txBody>
@@ -12440,7 +12378,7 @@
                 <a:ea typeface="Arial"/>
                 <a:cs typeface="Arial"/>
               </a:rPr>
-              <a:t>variances + next action</a:t>
+              <a:t>agent choices + control variances</a:t>
             </a:r>
           </a:p>
         </p:txBody>
@@ -13064,7 +13002,7 @@
                 <a:ea typeface="Arial"/>
                 <a:cs typeface="Arial"/>
               </a:rPr>
-              <a:t>service + backend + ledger health</a:t>
+              <a:t>required models + Phoenix + ledger</a:t>
             </a:r>
           </a:p>
         </p:txBody>
@@ -13154,7 +13092,7 @@
                 <a:ea typeface="Arial"/>
                 <a:cs typeface="Arial"/>
               </a:rPr>
-              <a:t>Added: unified document ingest · generic workflow state · unified exceptions · audited AR correction decisions.</a:t>
+              <a:t>Added: supervisor dispatch · persisted agent decisions · unified exceptions · audited AP/AR tool actions.</a:t>
             </a:r>
           </a:p>
         </p:txBody>
@@ -13740,6 +13678,30 @@
               <a:t>LlamaIndex</a:t>
             </a:r>
           </a:p>
+          <a:p xmlns:a="http://schemas.openxmlformats.org/drawingml/2006/main">
+            <a:pPr algn="ctr">
+              <a:buNone/>
+              <a:defRPr sz="1725" b="1">
+                <a:solidFill>
+                  <a:srgbClr val="000000"/>
+                </a:solidFill>
+                <a:latin typeface="Arial"/>
+                <a:ea typeface="Arial"/>
+                <a:cs typeface="Arial"/>
+              </a:defRPr>
+            </a:pPr>
+            <a:r>
+              <a:rPr sz="1725" b="1">
+                <a:solidFill>
+                  <a:srgbClr val="000000"/>
+                </a:solidFill>
+                <a:latin typeface="Arial"/>
+                <a:ea typeface="Arial"/>
+                <a:cs typeface="Arial"/>
+              </a:rPr>
+              <a:t>Semantic RAG</a:t>
+            </a:r>
+          </a:p>
         </p:txBody>
       </p:sp>
       <p:sp>
@@ -13886,7 +13848,7 @@
                 <a:ea typeface="Arial"/>
                 <a:cs typeface="Arial"/>
               </a:rPr>
-              <a:t>Ollama</a:t>
+              <a:t>Qwen 3.5 via Ollama</a:t>
             </a:r>
           </a:p>
           <a:p xmlns:a="http://schemas.openxmlformats.org/drawingml/2006/main">
@@ -14083,7 +14045,7 @@
                 <a:ea typeface="Arial"/>
                 <a:cs typeface="Arial"/>
               </a:rPr>
-              <a:t>Arize Phoenix</a:t>
+              <a:t>Arize Phoenix traces</a:t>
             </a:r>
           </a:p>
         </p:txBody>
@@ -14315,7 +14277,7 @@
                 <a:ea typeface="Arial"/>
                 <a:cs typeface="Arial"/>
               </a:rPr>
-              <a:t>Optional services are profile-gated so the core demo remains reproducible without a GPU.</a:t>
+              <a:t>Ollama, both models, and Phoenix are mandatory; missing AI returns 503 and blocks execution.</a:t>
             </a:r>
           </a:p>
         </p:txBody>

</xml_diff>

<commit_message>
Close agent control gaps and refresh deliverables
</commit_message>
<xml_diff>
--- a/presentation/LedgerPilot_Assignment_Deck.pptx
+++ b/presentation/LedgerPilot_Assignment_Deck.pptx
@@ -2,24 +2,24 @@
 <file path=ppt/presentation.xml><?xml version="1.0" encoding="utf-8"?>
 <p:presentation xmlns:p="http://schemas.openxmlformats.org/presentationml/2006/main">
   <p:sldMasterIdLst>
-    <p:sldMasterId xmlns:r="http://schemas.openxmlformats.org/officeDocument/2006/relationships" id="2147483648" r:id="Rc4f9fc1fb5da47d8"/>
+    <p:sldMasterId xmlns:r="http://schemas.openxmlformats.org/officeDocument/2006/relationships" id="2147483648" r:id="Rccf95f48dc6043ce"/>
   </p:sldMasterIdLst>
   <p:notesMasterIdLst>
-    <p:notesMasterId xmlns:r="http://schemas.openxmlformats.org/officeDocument/2006/relationships" r:id="R3bbd0d36553f469b"/>
+    <p:notesMasterId xmlns:r="http://schemas.openxmlformats.org/officeDocument/2006/relationships" r:id="R9173eef0df724e0b"/>
   </p:notesMasterIdLst>
   <p:sldIdLst>
-    <p:sldId xmlns:r="http://schemas.openxmlformats.org/officeDocument/2006/relationships" id="256" r:id="Rfff063f0441f48ea"/>
-    <p:sldId xmlns:r="http://schemas.openxmlformats.org/officeDocument/2006/relationships" id="257" r:id="R091960dd67f44fd0"/>
-    <p:sldId xmlns:r="http://schemas.openxmlformats.org/officeDocument/2006/relationships" id="258" r:id="Rd1f86669c4d74d25"/>
-    <p:sldId xmlns:r="http://schemas.openxmlformats.org/officeDocument/2006/relationships" id="259" r:id="R008fa9af3d0d43ec"/>
-    <p:sldId xmlns:r="http://schemas.openxmlformats.org/officeDocument/2006/relationships" id="260" r:id="Rbada69f662b5424a"/>
-    <p:sldId xmlns:r="http://schemas.openxmlformats.org/officeDocument/2006/relationships" id="261" r:id="R82ed033758614354"/>
-    <p:sldId xmlns:r="http://schemas.openxmlformats.org/officeDocument/2006/relationships" id="262" r:id="R2605ae634fce4e6d"/>
-    <p:sldId xmlns:r="http://schemas.openxmlformats.org/officeDocument/2006/relationships" id="263" r:id="Re47d2847d7b24377"/>
-    <p:sldId xmlns:r="http://schemas.openxmlformats.org/officeDocument/2006/relationships" id="264" r:id="R512a4db91b724f46"/>
-    <p:sldId xmlns:r="http://schemas.openxmlformats.org/officeDocument/2006/relationships" id="265" r:id="R1ca2fcd65d214681"/>
-    <p:sldId xmlns:r="http://schemas.openxmlformats.org/officeDocument/2006/relationships" id="266" r:id="Rde6f2672f7464383"/>
-    <p:sldId xmlns:r="http://schemas.openxmlformats.org/officeDocument/2006/relationships" id="267" r:id="R5b162419cb1a4a17"/>
+    <p:sldId xmlns:r="http://schemas.openxmlformats.org/officeDocument/2006/relationships" id="256" r:id="R2e1f02bd47024095"/>
+    <p:sldId xmlns:r="http://schemas.openxmlformats.org/officeDocument/2006/relationships" id="257" r:id="R128f554359c44032"/>
+    <p:sldId xmlns:r="http://schemas.openxmlformats.org/officeDocument/2006/relationships" id="258" r:id="R2f6dd9812bef4726"/>
+    <p:sldId xmlns:r="http://schemas.openxmlformats.org/officeDocument/2006/relationships" id="259" r:id="R80841a4cba7e48bd"/>
+    <p:sldId xmlns:r="http://schemas.openxmlformats.org/officeDocument/2006/relationships" id="260" r:id="R60fa7e0a23244e5c"/>
+    <p:sldId xmlns:r="http://schemas.openxmlformats.org/officeDocument/2006/relationships" id="261" r:id="R6268934610ed455f"/>
+    <p:sldId xmlns:r="http://schemas.openxmlformats.org/officeDocument/2006/relationships" id="262" r:id="Rb9443d8d75f34f7f"/>
+    <p:sldId xmlns:r="http://schemas.openxmlformats.org/officeDocument/2006/relationships" id="263" r:id="Rb3b61cbcd5dc4b02"/>
+    <p:sldId xmlns:r="http://schemas.openxmlformats.org/officeDocument/2006/relationships" id="264" r:id="R80ea82d8699b4f82"/>
+    <p:sldId xmlns:r="http://schemas.openxmlformats.org/officeDocument/2006/relationships" id="265" r:id="Rc258635c76854a0c"/>
+    <p:sldId xmlns:r="http://schemas.openxmlformats.org/officeDocument/2006/relationships" id="266" r:id="R7dad8c7fdefe44b1"/>
+    <p:sldId xmlns:r="http://schemas.openxmlformats.org/officeDocument/2006/relationships" id="267" r:id="Rfc856eccb38c489c"/>
   </p:sldIdLst>
   <p:sldSz cx="12192000" cy="6858000"/>
   <p:notesSz cx="6858000" cy="9144000"/>
@@ -548,7 +548,7 @@
           <a:lstStyle xmlns:a="http://schemas.openxmlformats.org/drawingml/2006/main"/>
           <a:p xmlns:a="http://schemas.openxmlformats.org/drawingml/2006/main">
             <a:r>
-              <a:t>The live-agent evaluation exercises model extraction/action selection while deterministic controls still determine financial eligibility. Results are regression evidence, not a production accuracy estimate.</a:t>
+              <a:t>The live-agent evaluation exercises model extraction and bounded action selection while deterministic controls decide financial eligibility. Conservative escalation counts eligible matches the agent voluntarily sends to review. Results are regression evidence, not a production accuracy estimate.</a:t>
             </a:r>
           </a:p>
           <a:p xmlns:a="http://schemas.openxmlformats.org/drawingml/2006/main">
@@ -563,12 +563,22 @@
           </a:p>
           <a:p xmlns:a="http://schemas.openxmlformats.org/drawingml/2006/main">
             <a:r>
-              <a:t>- evaluation/results/latest.json; evaluation/results/ar-latest.json; evaluation/results/rag-latest.json.</a:t>
-            </a:r>
-          </a:p>
-          <a:p xmlns:a="http://schemas.openxmlformats.org/drawingml/2006/main">
-            <a:r>
-              <a:t>- docs/evaluation-report.md; tests/test_agent_runtime.py.</a:t>
+              <a:t>- https://github.com/saifs1315/Agentic-Invoice-to-Payment/blob/main/evaluation/results/latest.json</a:t>
+            </a:r>
+          </a:p>
+          <a:p xmlns:a="http://schemas.openxmlformats.org/drawingml/2006/main">
+            <a:r>
+              <a:t>- https://github.com/saifs1315/Agentic-Invoice-to-Payment/blob/main/evaluation/results/ar-latest.json</a:t>
+            </a:r>
+          </a:p>
+          <a:p xmlns:a="http://schemas.openxmlformats.org/drawingml/2006/main">
+            <a:r>
+              <a:t>- https://github.com/saifs1315/Agentic-Invoice-to-Payment/blob/main/evaluation/results/rag-latest.json</a:t>
+            </a:r>
+          </a:p>
+          <a:p xmlns:a="http://schemas.openxmlformats.org/drawingml/2006/main">
+            <a:r>
+              <a:t>- https://github.com/saifs1315/Agentic-Invoice-to-Payment/blob/main/docs/evaluation-report.md</a:t>
             </a:r>
           </a:p>
         </p:txBody>
@@ -638,7 +648,7 @@
           <a:lstStyle xmlns:a="http://schemas.openxmlformats.org/drawingml/2006/main"/>
           <a:p xmlns:a="http://schemas.openxmlformats.org/drawingml/2006/main">
             <a:r>
-              <a:t>One Compose command starts the complete required topology, pulls models once, and exposes Swagger, Phoenix, and the Mock ERP for a reviewer-led AP/AR demonstration.</a:t>
+              <a:t>One Compose command starts the complete required topology, pulls models once, and exposes Swagger, Phoenix, and the Mock ERP for a reviewer-led AP/AR demonstration. The verification line reflects the current automated suite and live evaluation commands.</a:t>
             </a:r>
           </a:p>
           <a:p xmlns:a="http://schemas.openxmlformats.org/drawingml/2006/main">
@@ -653,7 +663,22 @@
           </a:p>
           <a:p xmlns:a="http://schemas.openxmlformats.org/drawingml/2006/main">
             <a:r>
-              <a:t>- README.md; Dockerfile; docker-compose.yml; scripts/demo.ps1.</a:t>
+              <a:t>- https://github.com/saifs1315/Agentic-Invoice-to-Payment/blob/main/README.md</a:t>
+            </a:r>
+          </a:p>
+          <a:p xmlns:a="http://schemas.openxmlformats.org/drawingml/2006/main">
+            <a:r>
+              <a:t>- https://github.com/saifs1315/Agentic-Invoice-to-Payment/blob/main/docker-compose.yml</a:t>
+            </a:r>
+          </a:p>
+          <a:p xmlns:a="http://schemas.openxmlformats.org/drawingml/2006/main">
+            <a:r>
+              <a:t>- https://github.com/saifs1315/Agentic-Invoice-to-Payment/blob/main/scripts/demo.ps1</a:t>
+            </a:r>
+          </a:p>
+          <a:p xmlns:a="http://schemas.openxmlformats.org/drawingml/2006/main">
+            <a:r>
+              <a:t>- https://github.com/saifs1315/Agentic-Invoice-to-Payment/blob/main/docs/evaluation-report.md</a:t>
             </a:r>
           </a:p>
         </p:txBody>
@@ -738,7 +763,17 @@
           </a:p>
           <a:p xmlns:a="http://schemas.openxmlformats.org/drawingml/2006/main">
             <a:r>
-              <a:t>- docs/traceability-matrix.md; docs/evaluation-report.md; repository root.</a:t>
+              <a:t>- https://github.com/saifs1315/Agentic-Invoice-to-Payment/blob/main/docs/traceability-matrix.md</a:t>
+            </a:r>
+          </a:p>
+          <a:p xmlns:a="http://schemas.openxmlformats.org/drawingml/2006/main">
+            <a:r>
+              <a:t>- https://github.com/saifs1315/Agentic-Invoice-to-Payment/blob/main/docs/evaluation-report.md</a:t>
+            </a:r>
+          </a:p>
+          <a:p xmlns:a="http://schemas.openxmlformats.org/drawingml/2006/main">
+            <a:r>
+              <a:t>- https://github.com/saifs1315/Agentic-Invoice-to-Payment/blob/main/README.md</a:t>
             </a:r>
           </a:p>
         </p:txBody>
@@ -993,7 +1028,7 @@
           <a:lstStyle xmlns:a="http://schemas.openxmlformats.org/drawingml/2006/main"/>
           <a:p xmlns:a="http://schemas.openxmlformats.org/drawingml/2006/main">
             <a:r>
-              <a:t>The fixed graphs bound the lifecycle. The model selects only schema-valid, stage-allow-listed actions; deterministic matching and posting guards remain authoritative.</a:t>
+              <a:t>The fixed graphs bound the lifecycle. The supervisor dispatches the shared evidence to AP, AR, or review; the domain agent then chooses only a schema-valid, stage-allow-listed post/apply/escalate action. Deterministic matching, status, approval, and posting guards remain authoritative.</a:t>
             </a:r>
           </a:p>
           <a:p xmlns:a="http://schemas.openxmlformats.org/drawingml/2006/main">
@@ -1008,12 +1043,22 @@
           </a:p>
           <a:p xmlns:a="http://schemas.openxmlformats.org/drawingml/2006/main">
             <a:r>
-              <a:t>- app/agent_runtime.py — structured decision contracts and allow-lists.</a:t>
-            </a:r>
-          </a:p>
-          <a:p xmlns:a="http://schemas.openxmlformats.org/drawingml/2006/main">
-            <a:r>
-              <a:t>- app/orchestrator.py; app/workflow.py; app/ar_workflow.py — fixed mirrored graph transitions.</a:t>
+              <a:t>- https://github.com/saifs1315/Agentic-Invoice-to-Payment/blob/main/app/agent_runtime.py</a:t>
+            </a:r>
+          </a:p>
+          <a:p xmlns:a="http://schemas.openxmlformats.org/drawingml/2006/main">
+            <a:r>
+              <a:t>- https://github.com/saifs1315/Agentic-Invoice-to-Payment/blob/main/app/orchestrator.py</a:t>
+            </a:r>
+          </a:p>
+          <a:p xmlns:a="http://schemas.openxmlformats.org/drawingml/2006/main">
+            <a:r>
+              <a:t>- https://github.com/saifs1315/Agentic-Invoice-to-Payment/blob/main/app/workflow.py</a:t>
+            </a:r>
+          </a:p>
+          <a:p xmlns:a="http://schemas.openxmlformats.org/drawingml/2006/main">
+            <a:r>
+              <a:t>- https://github.com/saifs1315/Agentic-Invoice-to-Payment/blob/main/app/ar_workflow.py</a:t>
             </a:r>
           </a:p>
         </p:txBody>
@@ -1551,7 +1596,7 @@
   </p:cSld>
   <p:clrMap bg1="lt1" tx1="dk1" bg2="lt2" tx2="dk2" accent1="accent1" accent2="accent2" accent3="accent3" accent4="accent4" accent5="accent5" accent6="accent6" hlink="hlink" folHlink="folHlink"/>
   <p:sldLayoutIdLst>
-    <p:sldLayoutId xmlns:r="http://schemas.openxmlformats.org/officeDocument/2006/relationships" id="2147483649" r:id="Ra35a0caf48b24b11"/>
+    <p:sldLayoutId xmlns:r="http://schemas.openxmlformats.org/officeDocument/2006/relationships" id="2147483649" r:id="Rb07b8317176d49d8"/>
   </p:sldLayoutIdLst>
   <p:txStyles>
     <p:titleStyle>
@@ -2373,7 +2418,7 @@
           <p:nvPr/>
         </p:nvPicPr>
         <p:blipFill>
-          <a:blip xmlns:r="http://schemas.openxmlformats.org/officeDocument/2006/relationships" xmlns:a="http://schemas.openxmlformats.org/drawingml/2006/main" r:embed="R47c46ef212a942cd"/>
+          <a:blip xmlns:r="http://schemas.openxmlformats.org/officeDocument/2006/relationships" xmlns:a="http://schemas.openxmlformats.org/drawingml/2006/main" r:embed="R44ec0341e29e4445"/>
           <a:srcRect xmlns:a="http://schemas.openxmlformats.org/drawingml/2006/main" l="0" t="9434" r="0" b="9434"/>
           <a:stretch xmlns:a="http://schemas.openxmlformats.org/drawingml/2006/main">
             <a:fillRect l="0" t="0" r="0" b="0"/>
@@ -2741,7 +2786,7 @@
                 <a:ea typeface="Arial"/>
                 <a:cs typeface="Arial"/>
               </a:rPr>
-              <a:t>16 live-agent documents · AP extraction 88.6% · AR extraction 94.4% · decisions 100%.</a:t>
+              <a:t>16 live-agent documents · AP extraction 88.6% · AR extraction 97.2% · decisions 100%.</a:t>
             </a:r>
           </a:p>
         </p:txBody>
@@ -3004,7 +3049,7 @@
                 <a:ea typeface="Arial"/>
                 <a:cs typeface="Arial"/>
               </a:rPr>
-              <a:t>94.4%</a:t>
+              <a:t>97.2%</a:t>
             </a:r>
           </a:p>
         </p:txBody>
@@ -3087,7 +3132,7 @@
                 <a:ea typeface="Arial"/>
                 <a:cs typeface="Arial"/>
               </a:rPr>
-              <a:t>34 / 36 labels</a:t>
+              <a:t>35 / 36 labels</a:t>
             </a:r>
           </a:p>
         </p:txBody>
@@ -3319,7 +3364,7 @@
                 <a:ea typeface="Arial"/>
                 <a:cs typeface="Arial"/>
               </a:rPr>
-              <a:t>RAGAS: 88.9% precision + recall across 9 queries. 53 tests pass. Next: a permissioned pilot.</a:t>
+              <a:t>RAGAS: 88.9% precision + recall · conservative escalation: 0 / 9 eligible · 66 tests pass.</a:t>
             </a:r>
           </a:p>
         </p:txBody>
@@ -4055,7 +4100,7 @@
                 <a:ea typeface="Arial"/>
                 <a:cs typeface="Arial"/>
               </a:rPr>
-              <a:t>53 tests · live AP/AR + RAGAS eval</a:t>
+              <a:t>66 tests · live AP/AR + RAGAS eval</a:t>
             </a:r>
           </a:p>
         </p:txBody>
@@ -4688,7 +4733,7 @@
                 <a:ea typeface="Arial"/>
                 <a:cs typeface="Arial"/>
               </a:rPr>
-              <a:t>53 tests + live AP/AR/RAGAS gates + audit chain</a:t>
+              <a:t>66 tests + live AP/AR/RAGAS gates + audit chain</a:t>
             </a:r>
           </a:p>
         </p:txBody>
@@ -8083,7 +8128,7 @@
                 <a:ea typeface="Arial"/>
                 <a:cs typeface="Arial"/>
               </a:rPr>
-              <a:t>Qwen routes AP, AR, or review.</a:t>
+              <a:t>Qwen dispatches AP, AR, or review.</a:t>
             </a:r>
           </a:p>
         </p:txBody>
@@ -8713,7 +8758,7 @@
                 <a:ea typeface="Arial"/>
                 <a:cs typeface="Arial"/>
               </a:rPr>
-              <a:t>Post, apply, or escalate safely.</a:t>
+              <a:t>Agent chooses post, apply, or escalate.</a:t>
             </a:r>
           </a:p>
         </p:txBody>

</xml_diff>

<commit_message>
Remove presentation hero image
</commit_message>
<xml_diff>
--- a/presentation/LedgerPilot_Assignment_Deck.pptx
+++ b/presentation/LedgerPilot_Assignment_Deck.pptx
@@ -2,24 +2,24 @@
 <file path=ppt/presentation.xml><?xml version="1.0" encoding="utf-8"?>
 <p:presentation xmlns:p="http://schemas.openxmlformats.org/presentationml/2006/main">
   <p:sldMasterIdLst>
-    <p:sldMasterId xmlns:r="http://schemas.openxmlformats.org/officeDocument/2006/relationships" id="2147483648" r:id="Rccf95f48dc6043ce"/>
+    <p:sldMasterId xmlns:r="http://schemas.openxmlformats.org/officeDocument/2006/relationships" id="2147483648" r:id="Rf96680c20b834445"/>
   </p:sldMasterIdLst>
   <p:notesMasterIdLst>
-    <p:notesMasterId xmlns:r="http://schemas.openxmlformats.org/officeDocument/2006/relationships" r:id="R9173eef0df724e0b"/>
+    <p:notesMasterId xmlns:r="http://schemas.openxmlformats.org/officeDocument/2006/relationships" r:id="R1643cac8bdee4f11"/>
   </p:notesMasterIdLst>
   <p:sldIdLst>
-    <p:sldId xmlns:r="http://schemas.openxmlformats.org/officeDocument/2006/relationships" id="256" r:id="R2e1f02bd47024095"/>
-    <p:sldId xmlns:r="http://schemas.openxmlformats.org/officeDocument/2006/relationships" id="257" r:id="R128f554359c44032"/>
-    <p:sldId xmlns:r="http://schemas.openxmlformats.org/officeDocument/2006/relationships" id="258" r:id="R2f6dd9812bef4726"/>
-    <p:sldId xmlns:r="http://schemas.openxmlformats.org/officeDocument/2006/relationships" id="259" r:id="R80841a4cba7e48bd"/>
-    <p:sldId xmlns:r="http://schemas.openxmlformats.org/officeDocument/2006/relationships" id="260" r:id="R60fa7e0a23244e5c"/>
-    <p:sldId xmlns:r="http://schemas.openxmlformats.org/officeDocument/2006/relationships" id="261" r:id="R6268934610ed455f"/>
-    <p:sldId xmlns:r="http://schemas.openxmlformats.org/officeDocument/2006/relationships" id="262" r:id="Rb9443d8d75f34f7f"/>
-    <p:sldId xmlns:r="http://schemas.openxmlformats.org/officeDocument/2006/relationships" id="263" r:id="Rb3b61cbcd5dc4b02"/>
-    <p:sldId xmlns:r="http://schemas.openxmlformats.org/officeDocument/2006/relationships" id="264" r:id="R80ea82d8699b4f82"/>
-    <p:sldId xmlns:r="http://schemas.openxmlformats.org/officeDocument/2006/relationships" id="265" r:id="Rc258635c76854a0c"/>
-    <p:sldId xmlns:r="http://schemas.openxmlformats.org/officeDocument/2006/relationships" id="266" r:id="R7dad8c7fdefe44b1"/>
-    <p:sldId xmlns:r="http://schemas.openxmlformats.org/officeDocument/2006/relationships" id="267" r:id="Rfc856eccb38c489c"/>
+    <p:sldId xmlns:r="http://schemas.openxmlformats.org/officeDocument/2006/relationships" id="256" r:id="R701e30aa405f44bd"/>
+    <p:sldId xmlns:r="http://schemas.openxmlformats.org/officeDocument/2006/relationships" id="257" r:id="R9c648a29641445bf"/>
+    <p:sldId xmlns:r="http://schemas.openxmlformats.org/officeDocument/2006/relationships" id="258" r:id="Rd6ccb49a8e994a23"/>
+    <p:sldId xmlns:r="http://schemas.openxmlformats.org/officeDocument/2006/relationships" id="259" r:id="R9f6a3319c81747e1"/>
+    <p:sldId xmlns:r="http://schemas.openxmlformats.org/officeDocument/2006/relationships" id="260" r:id="R45c69639d133409d"/>
+    <p:sldId xmlns:r="http://schemas.openxmlformats.org/officeDocument/2006/relationships" id="261" r:id="R0619f2989c294e1f"/>
+    <p:sldId xmlns:r="http://schemas.openxmlformats.org/officeDocument/2006/relationships" id="262" r:id="Ra92dbbb7189c43aa"/>
+    <p:sldId xmlns:r="http://schemas.openxmlformats.org/officeDocument/2006/relationships" id="263" r:id="Rc3f6e9558b764bae"/>
+    <p:sldId xmlns:r="http://schemas.openxmlformats.org/officeDocument/2006/relationships" id="264" r:id="Rb8b707afb1d443e7"/>
+    <p:sldId xmlns:r="http://schemas.openxmlformats.org/officeDocument/2006/relationships" id="265" r:id="R1487346c2fe4404c"/>
+    <p:sldId xmlns:r="http://schemas.openxmlformats.org/officeDocument/2006/relationships" id="266" r:id="Rc8f87578ec68434c"/>
+    <p:sldId xmlns:r="http://schemas.openxmlformats.org/officeDocument/2006/relationships" id="267" r:id="Rd63ae228303c492c"/>
   </p:sldIdLst>
   <p:sldSz cx="12192000" cy="6858000"/>
   <p:notesSz cx="6858000" cy="9144000"/>
@@ -473,11 +473,6 @@
           </a:p>
           <a:p xmlns:a="http://schemas.openxmlformats.org/drawingml/2006/main">
             <a:r>
-              <a:t>- Project-generated image: presentation/assets/invoice-automation-hero.png.</a:t>
-            </a:r>
-          </a:p>
-          <a:p xmlns:a="http://schemas.openxmlformats.org/drawingml/2006/main">
-            <a:r>
               <a:t>- https://ollama.com/library/qwen3.5/tags — selected local Qwen model.</a:t>
             </a:r>
           </a:p>
@@ -1596,7 +1591,7 @@
   </p:cSld>
   <p:clrMap bg1="lt1" tx1="dk1" bg2="lt2" tx2="dk2" accent1="accent1" accent2="accent2" accent3="accent3" accent4="accent4" accent5="accent5" accent6="accent6" hlink="hlink" folHlink="folHlink"/>
   <p:sldLayoutIdLst>
-    <p:sldLayoutId xmlns:r="http://schemas.openxmlformats.org/officeDocument/2006/relationships" id="2147483649" r:id="Rb07b8317176d49d8"/>
+    <p:sldLayoutId xmlns:r="http://schemas.openxmlformats.org/officeDocument/2006/relationships" id="2147483649" r:id="Ra82cde45b1914790"/>
   </p:sldLayoutIdLst>
   <p:txStyles>
     <p:titleStyle>
@@ -2409,33 +2404,6 @@
           </a:p>
         </p:txBody>
       </p:sp>
-      <p:pic>
-        <p:nvPicPr>
-          <p:cNvPr id="15" name=""/>
-          <p:cNvPicPr>
-            <a:picLocks xmlns:a="http://schemas.openxmlformats.org/drawingml/2006/main" noChangeAspect="1"/>
-          </p:cNvPicPr>
-          <p:nvPr/>
-        </p:nvPicPr>
-        <p:blipFill>
-          <a:blip xmlns:r="http://schemas.openxmlformats.org/officeDocument/2006/relationships" xmlns:a="http://schemas.openxmlformats.org/drawingml/2006/main" r:embed="R44ec0341e29e4445"/>
-          <a:srcRect xmlns:a="http://schemas.openxmlformats.org/drawingml/2006/main" l="0" t="9434" r="0" b="9434"/>
-          <a:stretch xmlns:a="http://schemas.openxmlformats.org/drawingml/2006/main">
-            <a:fillRect l="0" t="0" r="0" b="0"/>
-          </a:stretch>
-        </p:blipFill>
-        <p:spPr>
-          <a:xfrm xmlns:a="http://schemas.openxmlformats.org/drawingml/2006/main">
-            <a:off x="6267450" y="400050"/>
-            <a:ext cx="5524500" cy="5600700"/>
-          </a:xfrm>
-          <a:prstGeom xmlns:a="http://schemas.openxmlformats.org/drawingml/2006/main" prst="roundRect">
-            <a:avLst>
-              <a:gd name="adj" fmla="val 2069"/>
-            </a:avLst>
-          </a:prstGeom>
-        </p:spPr>
-      </p:pic>
       <p:sp>
         <p:nvSpPr>
           <p:cNvPr id="7" name="cover-page">

</xml_diff>